<commit_message>
feat(modeling): complete nested rul improvement study
</commit_message>
<xml_diff>
--- a/slides/cmapss_fd001_presentation.pptx
+++ b/slides/cmapss_fd001_presentation.pptx
@@ -2,27 +2,30 @@
 <file path=ppt/presentation.xml><?xml version="1.0" encoding="utf-8"?>
 <p:presentation xmlns:p="http://schemas.openxmlformats.org/presentationml/2006/main">
   <p:sldMasterIdLst>
-    <p:sldMasterId xmlns:r="http://schemas.openxmlformats.org/officeDocument/2006/relationships" id="2147483648" r:id="R43069f59d5504176"/>
+    <p:sldMasterId xmlns:r="http://schemas.openxmlformats.org/officeDocument/2006/relationships" id="2147483648" r:id="Re58b5c0bddde4125"/>
   </p:sldMasterIdLst>
   <p:notesMasterIdLst>
-    <p:notesMasterId xmlns:r="http://schemas.openxmlformats.org/officeDocument/2006/relationships" r:id="R2ce9423164db42fd"/>
+    <p:notesMasterId xmlns:r="http://schemas.openxmlformats.org/officeDocument/2006/relationships" r:id="Rcd79f44ee7704b31"/>
   </p:notesMasterIdLst>
   <p:sldIdLst>
-    <p:sldId xmlns:r="http://schemas.openxmlformats.org/officeDocument/2006/relationships" id="256" r:id="Rab90cef39654472e"/>
-    <p:sldId xmlns:r="http://schemas.openxmlformats.org/officeDocument/2006/relationships" id="257" r:id="R64425e2d2614412b"/>
-    <p:sldId xmlns:r="http://schemas.openxmlformats.org/officeDocument/2006/relationships" id="258" r:id="R3b84993b311d47f4"/>
-    <p:sldId xmlns:r="http://schemas.openxmlformats.org/officeDocument/2006/relationships" id="259" r:id="R419e7a56efd8496d"/>
-    <p:sldId xmlns:r="http://schemas.openxmlformats.org/officeDocument/2006/relationships" id="260" r:id="Rf9b69426ad6748f2"/>
-    <p:sldId xmlns:r="http://schemas.openxmlformats.org/officeDocument/2006/relationships" id="261" r:id="R4dc9375b883740e5"/>
-    <p:sldId xmlns:r="http://schemas.openxmlformats.org/officeDocument/2006/relationships" id="262" r:id="R107f874a600e40e9"/>
-    <p:sldId xmlns:r="http://schemas.openxmlformats.org/officeDocument/2006/relationships" id="263" r:id="R720a8d47a9c64480"/>
-    <p:sldId xmlns:r="http://schemas.openxmlformats.org/officeDocument/2006/relationships" id="264" r:id="Rdf59772fd4dc4b67"/>
-    <p:sldId xmlns:r="http://schemas.openxmlformats.org/officeDocument/2006/relationships" id="265" r:id="Rdeb0c28602e2461d"/>
-    <p:sldId xmlns:r="http://schemas.openxmlformats.org/officeDocument/2006/relationships" id="266" r:id="R31ae476e0ff4435c"/>
-    <p:sldId xmlns:r="http://schemas.openxmlformats.org/officeDocument/2006/relationships" id="267" r:id="Rab57abaae21f484b"/>
-    <p:sldId xmlns:r="http://schemas.openxmlformats.org/officeDocument/2006/relationships" id="268" r:id="Rbf10ba3e37694dab"/>
-    <p:sldId xmlns:r="http://schemas.openxmlformats.org/officeDocument/2006/relationships" id="269" r:id="Re6e9cff3d423405a"/>
-    <p:sldId xmlns:r="http://schemas.openxmlformats.org/officeDocument/2006/relationships" id="270" r:id="Rd974207a689a441a"/>
+    <p:sldId xmlns:r="http://schemas.openxmlformats.org/officeDocument/2006/relationships" id="256" r:id="R943f942bb23f4e94"/>
+    <p:sldId xmlns:r="http://schemas.openxmlformats.org/officeDocument/2006/relationships" id="257" r:id="Rf42a1872f4154377"/>
+    <p:sldId xmlns:r="http://schemas.openxmlformats.org/officeDocument/2006/relationships" id="258" r:id="R35381d84789240f2"/>
+    <p:sldId xmlns:r="http://schemas.openxmlformats.org/officeDocument/2006/relationships" id="259" r:id="R5a6575d339c64d7a"/>
+    <p:sldId xmlns:r="http://schemas.openxmlformats.org/officeDocument/2006/relationships" id="260" r:id="Rd45e7be1017442a3"/>
+    <p:sldId xmlns:r="http://schemas.openxmlformats.org/officeDocument/2006/relationships" id="261" r:id="R2fb9a20b1a5c4455"/>
+    <p:sldId xmlns:r="http://schemas.openxmlformats.org/officeDocument/2006/relationships" id="262" r:id="R9b39a2a8e8924994"/>
+    <p:sldId xmlns:r="http://schemas.openxmlformats.org/officeDocument/2006/relationships" id="263" r:id="R9ae74660e8724962"/>
+    <p:sldId xmlns:r="http://schemas.openxmlformats.org/officeDocument/2006/relationships" id="264" r:id="R78cafa76bc6d4b51"/>
+    <p:sldId xmlns:r="http://schemas.openxmlformats.org/officeDocument/2006/relationships" id="265" r:id="R244f7aa264284356"/>
+    <p:sldId xmlns:r="http://schemas.openxmlformats.org/officeDocument/2006/relationships" id="266" r:id="R4ed2ce06188a4eb1"/>
+    <p:sldId xmlns:r="http://schemas.openxmlformats.org/officeDocument/2006/relationships" id="267" r:id="R717877d64f884085"/>
+    <p:sldId xmlns:r="http://schemas.openxmlformats.org/officeDocument/2006/relationships" id="268" r:id="R41eb0ad303b64bf2"/>
+    <p:sldId xmlns:r="http://schemas.openxmlformats.org/officeDocument/2006/relationships" id="269" r:id="R70524e69980341a7"/>
+    <p:sldId xmlns:r="http://schemas.openxmlformats.org/officeDocument/2006/relationships" id="270" r:id="R756a1a46ee4c498c"/>
+    <p:sldId xmlns:r="http://schemas.openxmlformats.org/officeDocument/2006/relationships" id="271" r:id="R1f5f99211f604516"/>
+    <p:sldId xmlns:r="http://schemas.openxmlformats.org/officeDocument/2006/relationships" id="272" r:id="Rd399195afe8147d0"/>
+    <p:sldId xmlns:r="http://schemas.openxmlformats.org/officeDocument/2006/relationships" id="273" r:id="Rc6704c059d6d4683"/>
   </p:sldIdLst>
   <p:sldSz cx="12192000" cy="6858000"/>
   <p:notesSz cx="6858000" cy="9144000"/>
@@ -212,16 +215,16 @@
         <a:srgbClr val="96607D"/>
       </a:folHlink>
     </a:clrScheme>
-    <a:fontScheme name="">
+    <a:fontScheme name="Office">
       <a:majorFont>
-        <a:latin typeface="Aptos"/>
-        <a:ea typeface=""/>
-        <a:cs typeface=""/>
+        <a:latin typeface="Calibri Light"/>
+        <a:ea typeface="Calibri Light"/>
+        <a:cs typeface="Calibri Light"/>
       </a:majorFont>
       <a:minorFont>
-        <a:latin typeface="Aptos"/>
-        <a:ea typeface=""/>
-        <a:cs typeface=""/>
+        <a:latin typeface="Calibri"/>
+        <a:ea typeface="Calibri"/>
+        <a:cs typeface="Calibri"/>
       </a:minorFont>
     </a:fontScheme>
     <a:fmtScheme name="ChatGPT">
@@ -736,7 +739,7 @@
           <a:lstStyle xmlns:a="http://schemas.openxmlformats.org/drawingml/2006/main"/>
           <a:p xmlns:a="http://schemas.openxmlformats.org/drawingml/2006/main">
             <a:r>
-              <a:t>Pandas/PySpark cho cùng kết quả tại ba boundary Silver/Gold, max absolute difference 0.0. Benchmark chỉ đo build_engine_summary in-memory bằng Pandas. Scale 100x có 3.372.700 rows, hai lần 1,6752 và 1,6732 giây; không bao gồm I/O và không có PySpark timing. Fresh E2E đối chiếu 18 bảng, 5 hình và raw hash; 151 tests pass.</a:t>
+              <a:t>Pandas/PySpark cho cùng kết quả tại ba boundary Silver/Gold, max absolute difference 0.0. Benchmark chỉ đo build_engine_summary in-memory bằng Pandas. Scale 100x có 3.372.700 rows, hai lần 1,6752 và 1,6732 giây; không bao gồm I/O và không có PySpark timing. Fresh E2E đối chiếu 18 bảng, 5 hình và raw hash; 175 tests pass.</a:t>
             </a:r>
           </a:p>
         </p:txBody>
@@ -806,7 +809,7 @@
           <a:lstStyle xmlns:a="http://schemas.openxmlformats.org/drawingml/2006/main"/>
           <a:p xmlns:a="http://schemas.openxmlformats.org/drawingml/2006/main">
             <a:r>
-              <a:t>Kết luận: HistGradientBoosting được chọn theo GroupKFold, final MAE 15,3490 cycles với window 30 trên FD001. Ma trận bổ sung dùng window 10 cho bốn subset. Transfer từ FD001 sang FD002–FD004 có MAE 60,3215; 47,3949; 58,5731 cycles. Cảnh báo OOF vẫn là mô tả nội bộ. Health Index forecast là phân tích phụ.</a:t>
+              <a:t>Outer 5-fold được giữ từ baseline. Trong mỗi outer train, inner 3-fold chọn window, tham số và trọng số. Chỉ chấm outer validation sau khi chọn xong. Test đã được xem trước đợt này, không dùng để chọn lại cấu hình.</a:t>
             </a:r>
           </a:p>
         </p:txBody>
@@ -837,6 +840,216 @@
 </file>
 
 <file path=ppt/notesSlides/notesSlide15.xml><?xml version="1.0" encoding="utf-8"?>
+<p:notes xmlns:p="http://schemas.openxmlformats.org/presentationml/2006/main">
+  <p:cSld>
+    <p:spTree>
+      <p:nvGrpSpPr>
+        <p:cNvPr id="1" name=""/>
+        <p:cNvGrpSpPr/>
+        <p:nvPr/>
+      </p:nvGrpSpPr>
+      <p:grpSpPr>
+        <a:xfrm xmlns:a="http://schemas.openxmlformats.org/drawingml/2006/main"/>
+      </p:grpSpPr>
+      <p:sp>
+        <p:nvSpPr>
+          <p:cNvPr id="2" name="Slide Image Placeholder 1"/>
+          <p:cNvSpPr>
+            <a:spLocks xmlns:a="http://schemas.openxmlformats.org/drawingml/2006/main" noGrp="1"/>
+          </p:cNvSpPr>
+          <p:nvPr>
+            <p:ph type="sldImg" idx="0"/>
+          </p:nvPr>
+        </p:nvSpPr>
+        <p:spPr/>
+      </p:sp>
+      <p:sp>
+        <p:nvSpPr>
+          <p:cNvPr id="3" name="Notes Placeholder 2"/>
+          <p:cNvSpPr>
+            <a:spLocks xmlns:a="http://schemas.openxmlformats.org/drawingml/2006/main" noGrp="1"/>
+          </p:cNvSpPr>
+          <p:nvPr>
+            <p:ph type="body" idx="1"/>
+          </p:nvPr>
+        </p:nvSpPr>
+        <p:spPr/>
+        <p:txBody>
+          <a:bodyPr xmlns:a="http://schemas.openxmlformats.org/drawingml/2006/main"/>
+          <a:lstStyle xmlns:a="http://schemas.openxmlformats.org/drawingml/2006/main"/>
+          <a:p xmlns:a="http://schemas.openxmlformats.org/drawingml/2006/main">
+            <a:r>
+              <a:t>Các stage dùng cùng 100 train engines. Window 30 được chọn ở cả 5 vòng. Hai vòng chọn cấu hình HGB khác, ba vòng giữ baseline. Không vòng nào chọn thêm trọng số. Chênh lệch MAE RUL thấp +0,0054 cycles, CI [-0,0506;0,0639]. Tỷ lệ cảnh báo trễ tăng 4 điểm phần trăm, CI [1;8]. Các CI điều kiện trên predictions đã fit.</a:t>
+            </a:r>
+          </a:p>
+        </p:txBody>
+      </p:sp>
+      <p:sp>
+        <p:nvSpPr>
+          <p:cNvPr id="4" name="Slide Number Placeholder 3"/>
+          <p:cNvSpPr>
+            <a:spLocks xmlns:a="http://schemas.openxmlformats.org/drawingml/2006/main" noGrp="1"/>
+          </p:cNvSpPr>
+          <p:nvPr>
+            <p:ph type="sldNum" idx="5"/>
+          </p:nvPr>
+        </p:nvSpPr>
+        <p:spPr/>
+        <p:txBody>
+          <a:bodyPr xmlns:a="http://schemas.openxmlformats.org/drawingml/2006/main"/>
+          <a:lstStyle xmlns:a="http://schemas.openxmlformats.org/drawingml/2006/main"/>
+          <a:p xmlns:a="http://schemas.openxmlformats.org/drawingml/2006/main"/>
+        </p:txBody>
+      </p:sp>
+    </p:spTree>
+  </p:cSld>
+  <p:clrMapOvr>
+    <a:masterClrMapping xmlns:a="http://schemas.openxmlformats.org/drawingml/2006/main"/>
+  </p:clrMapOvr>
+</p:notes>
+</file>
+
+<file path=ppt/notesSlides/notesSlide16.xml><?xml version="1.0" encoding="utf-8"?>
+<p:notes xmlns:p="http://schemas.openxmlformats.org/presentationml/2006/main">
+  <p:cSld>
+    <p:spTree>
+      <p:nvGrpSpPr>
+        <p:cNvPr id="1" name=""/>
+        <p:cNvGrpSpPr/>
+        <p:nvPr/>
+      </p:nvGrpSpPr>
+      <p:grpSpPr>
+        <a:xfrm xmlns:a="http://schemas.openxmlformats.org/drawingml/2006/main"/>
+      </p:grpSpPr>
+      <p:sp>
+        <p:nvSpPr>
+          <p:cNvPr id="2" name="Slide Image Placeholder 1"/>
+          <p:cNvSpPr>
+            <a:spLocks xmlns:a="http://schemas.openxmlformats.org/drawingml/2006/main" noGrp="1"/>
+          </p:cNvSpPr>
+          <p:nvPr>
+            <p:ph type="sldImg" idx="0"/>
+          </p:nvPr>
+        </p:nvSpPr>
+        <p:spPr/>
+      </p:sp>
+      <p:sp>
+        <p:nvSpPr>
+          <p:cNvPr id="3" name="Notes Placeholder 2"/>
+          <p:cNvSpPr>
+            <a:spLocks xmlns:a="http://schemas.openxmlformats.org/drawingml/2006/main" noGrp="1"/>
+          </p:cNvSpPr>
+          <p:nvPr>
+            <p:ph type="body" idx="1"/>
+          </p:nvPr>
+        </p:nvSpPr>
+        <p:spPr/>
+        <p:txBody>
+          <a:bodyPr xmlns:a="http://schemas.openxmlformats.org/drawingml/2006/main"/>
+          <a:lstStyle xmlns:a="http://schemas.openxmlformats.org/drawingml/2006/main"/>
+          <a:p xmlns:a="http://schemas.openxmlformats.org/drawingml/2006/main">
+            <a:r>
+              <a:t>Đây là ví dụ từ inner selection, không phải outer evaluation độc lập của ứng viên hgb_08. hgb_08 giảm MAE RUL thấp khoảng 9,75% nhưng MAE toàn bộ tăng 0,3233 cycles. Strong weights giảm low-RUL MAE và cảnh báo trễ nhưng tăng MAE toàn bộ và alarm burden. Luật đã chốt không cho phép tăng chỉ số kiểm soát. Không tuning tiếp theo test.</a:t>
+            </a:r>
+          </a:p>
+        </p:txBody>
+      </p:sp>
+      <p:sp>
+        <p:nvSpPr>
+          <p:cNvPr id="4" name="Slide Number Placeholder 3"/>
+          <p:cNvSpPr>
+            <a:spLocks xmlns:a="http://schemas.openxmlformats.org/drawingml/2006/main" noGrp="1"/>
+          </p:cNvSpPr>
+          <p:nvPr>
+            <p:ph type="sldNum" idx="5"/>
+          </p:nvPr>
+        </p:nvSpPr>
+        <p:spPr/>
+        <p:txBody>
+          <a:bodyPr xmlns:a="http://schemas.openxmlformats.org/drawingml/2006/main"/>
+          <a:lstStyle xmlns:a="http://schemas.openxmlformats.org/drawingml/2006/main"/>
+          <a:p xmlns:a="http://schemas.openxmlformats.org/drawingml/2006/main"/>
+        </p:txBody>
+      </p:sp>
+    </p:spTree>
+  </p:cSld>
+  <p:clrMapOvr>
+    <a:masterClrMapping xmlns:a="http://schemas.openxmlformats.org/drawingml/2006/main"/>
+  </p:clrMapOvr>
+</p:notes>
+</file>
+
+<file path=ppt/notesSlides/notesSlide17.xml><?xml version="1.0" encoding="utf-8"?>
+<p:notes xmlns:p="http://schemas.openxmlformats.org/presentationml/2006/main">
+  <p:cSld>
+    <p:spTree>
+      <p:nvGrpSpPr>
+        <p:cNvPr id="1" name=""/>
+        <p:cNvGrpSpPr/>
+        <p:nvPr/>
+      </p:nvGrpSpPr>
+      <p:grpSpPr>
+        <a:xfrm xmlns:a="http://schemas.openxmlformats.org/drawingml/2006/main"/>
+      </p:grpSpPr>
+      <p:sp>
+        <p:nvSpPr>
+          <p:cNvPr id="2" name="Slide Image Placeholder 1"/>
+          <p:cNvSpPr>
+            <a:spLocks xmlns:a="http://schemas.openxmlformats.org/drawingml/2006/main" noGrp="1"/>
+          </p:cNvSpPr>
+          <p:nvPr>
+            <p:ph type="sldImg" idx="0"/>
+          </p:nvPr>
+        </p:nvSpPr>
+        <p:spPr/>
+      </p:sp>
+      <p:sp>
+        <p:nvSpPr>
+          <p:cNvPr id="3" name="Notes Placeholder 2"/>
+          <p:cNvSpPr>
+            <a:spLocks xmlns:a="http://schemas.openxmlformats.org/drawingml/2006/main" noGrp="1"/>
+          </p:cNvSpPr>
+          <p:nvPr>
+            <p:ph type="body" idx="1"/>
+          </p:nvPr>
+        </p:nvSpPr>
+        <p:spPr/>
+        <p:txBody>
+          <a:bodyPr xmlns:a="http://schemas.openxmlformats.org/drawingml/2006/main"/>
+          <a:lstStyle xmlns:a="http://schemas.openxmlformats.org/drawingml/2006/main"/>
+          <a:p xmlns:a="http://schemas.openxmlformats.org/drawingml/2006/main">
+            <a:r>
+              <a:t>Kết luận: HistGradientBoosting được chọn theo GroupKFold, final MAE 15,3490 cycles với window 30 trên FD001. Ma trận bổ sung dùng window 10 cho bốn subset. Transfer từ FD001 sang FD002–FD004 có MAE 60,3215; 47,3949; 58,5731 cycles. Cảnh báo OOF vẫn là mô tả nội bộ. Health Index forecast là phân tích phụ.</a:t>
+            </a:r>
+          </a:p>
+        </p:txBody>
+      </p:sp>
+      <p:sp>
+        <p:nvSpPr>
+          <p:cNvPr id="4" name="Slide Number Placeholder 3"/>
+          <p:cNvSpPr>
+            <a:spLocks xmlns:a="http://schemas.openxmlformats.org/drawingml/2006/main" noGrp="1"/>
+          </p:cNvSpPr>
+          <p:nvPr>
+            <p:ph type="sldNum" idx="5"/>
+          </p:nvPr>
+        </p:nvSpPr>
+        <p:spPr/>
+        <p:txBody>
+          <a:bodyPr xmlns:a="http://schemas.openxmlformats.org/drawingml/2006/main"/>
+          <a:lstStyle xmlns:a="http://schemas.openxmlformats.org/drawingml/2006/main"/>
+          <a:p xmlns:a="http://schemas.openxmlformats.org/drawingml/2006/main"/>
+        </p:txBody>
+      </p:sp>
+    </p:spTree>
+  </p:cSld>
+  <p:clrMapOvr>
+    <a:masterClrMapping xmlns:a="http://schemas.openxmlformats.org/drawingml/2006/main"/>
+  </p:clrMapOvr>
+</p:notes>
+</file>
+
+<file path=ppt/notesSlides/notesSlide18.xml><?xml version="1.0" encoding="utf-8"?>
 <p:notes xmlns:p="http://schemas.openxmlformats.org/presentationml/2006/main">
   <p:cSld>
     <p:spTree>
@@ -1504,7 +1717,7 @@
   </p:cSld>
   <p:clrMap bg1="lt1" tx1="dk1" bg2="lt2" tx2="dk2" accent1="accent1" accent2="accent2" accent3="accent3" accent4="accent4" accent5="accent5" accent6="accent6" hlink="hlink" folHlink="folHlink"/>
   <p:sldLayoutIdLst>
-    <p:sldLayoutId xmlns:r="http://schemas.openxmlformats.org/officeDocument/2006/relationships" id="2147483649" r:id="Rfeb52146435948a4"/>
+    <p:sldLayoutId xmlns:r="http://schemas.openxmlformats.org/officeDocument/2006/relationships" id="2147483649" r:id="Re41c164fe7e74f1a"/>
   </p:sldLayoutIdLst>
   <p:txStyles>
     <p:titleStyle>
@@ -1827,16 +2040,16 @@
         <a:srgbClr val="96607D"/>
       </a:folHlink>
     </a:clrScheme>
-    <a:fontScheme name="">
+    <a:fontScheme name="Office">
       <a:majorFont>
-        <a:latin typeface="Aptos"/>
-        <a:ea typeface=""/>
-        <a:cs typeface=""/>
+        <a:latin typeface="Calibri Light"/>
+        <a:ea typeface="Calibri Light"/>
+        <a:cs typeface="Calibri Light"/>
       </a:majorFont>
       <a:minorFont>
-        <a:latin typeface="Aptos"/>
-        <a:ea typeface=""/>
-        <a:cs typeface=""/>
+        <a:latin typeface="Calibri"/>
+        <a:ea typeface="Calibri"/>
+        <a:cs typeface="Calibri"/>
       </a:minorFont>
     </a:fontScheme>
     <a:fmtScheme name="ChatGPT">
@@ -2055,7 +2268,7 @@
           <p:cNvPr id="5" name="">
             <a:extLst xmlns:a="http://schemas.openxmlformats.org/drawingml/2006/main">
               <a:ext uri="{FF2B5EF4-FFF2-40B4-BE49-F238E27FC236}">
-                <a16:creationId xmlns:a16="http://schemas.microsoft.com/office/drawing/2014/main" id="{927EF06E-C9A1-4A81-89DC-2E07BB092B60}"/>
+                <a16:creationId xmlns:a16="http://schemas.microsoft.com/office/drawing/2014/main" id="{591BE462-9FA0-45FD-979B-4D3032FB84FF}"/>
               </a:ext>
             </a:extLst>
           </p:cNvPr>
@@ -2116,7 +2329,7 @@
           <p:cNvPr id="2" name="">
             <a:extLst xmlns:a="http://schemas.openxmlformats.org/drawingml/2006/main">
               <a:ext uri="{FF2B5EF4-FFF2-40B4-BE49-F238E27FC236}">
-                <a16:creationId xmlns:a16="http://schemas.microsoft.com/office/drawing/2014/main" id="{FDDB1FA9-6792-4728-9E94-64BF01354FA6}"/>
+                <a16:creationId xmlns:a16="http://schemas.microsoft.com/office/drawing/2014/main" id="{788FEA61-D633-4599-B032-C746A875AEAC}"/>
               </a:ext>
             </a:extLst>
           </p:cNvPr>
@@ -2177,7 +2390,7 @@
           <p:cNvPr id="3" name="">
             <a:extLst xmlns:a="http://schemas.openxmlformats.org/drawingml/2006/main">
               <a:ext uri="{FF2B5EF4-FFF2-40B4-BE49-F238E27FC236}">
-                <a16:creationId xmlns:a16="http://schemas.microsoft.com/office/drawing/2014/main" id="{7801A303-D3DC-4F37-8091-8E9CC48CAA08}"/>
+                <a16:creationId xmlns:a16="http://schemas.microsoft.com/office/drawing/2014/main" id="{8154D036-4F90-4FAC-81C6-058551F233EE}"/>
               </a:ext>
             </a:extLst>
           </p:cNvPr>
@@ -2238,7 +2451,7 @@
           <p:cNvPr id="4" name="">
             <a:extLst xmlns:a="http://schemas.openxmlformats.org/drawingml/2006/main">
               <a:ext uri="{FF2B5EF4-FFF2-40B4-BE49-F238E27FC236}">
-                <a16:creationId xmlns:a16="http://schemas.microsoft.com/office/drawing/2014/main" id="{451471F4-B042-4B20-B46F-488BAE637294}"/>
+                <a16:creationId xmlns:a16="http://schemas.microsoft.com/office/drawing/2014/main" id="{105A829B-F7DE-47C0-AE60-B15984C20EDC}"/>
               </a:ext>
             </a:extLst>
           </p:cNvPr>
@@ -2297,7 +2510,7 @@
     </p:spTree>
     <p:extLst>
       <p:ext uri="{BB962C8B-B14F-4D97-AF65-F5344CB8AC3E}">
-        <p14:creationId xmlns:p14="http://schemas.microsoft.com/office/powerpoint/2010/main" val="1047789355"/>
+        <p14:creationId xmlns:p14="http://schemas.microsoft.com/office/powerpoint/2010/main" val="2147292593"/>
       </p:ext>
     </p:extLst>
   </p:cSld>
@@ -2328,7 +2541,7 @@
           <p:cNvPr id="11" name="">
             <a:extLst xmlns:a="http://schemas.openxmlformats.org/drawingml/2006/main">
               <a:ext uri="{FF2B5EF4-FFF2-40B4-BE49-F238E27FC236}">
-                <a16:creationId xmlns:a16="http://schemas.microsoft.com/office/drawing/2014/main" id="{47698572-812E-4089-B50D-8FAC3C7A01DE}"/>
+                <a16:creationId xmlns:a16="http://schemas.microsoft.com/office/drawing/2014/main" id="{0B7B2763-2B1C-49A2-8210-19EB93D6623E}"/>
               </a:ext>
             </a:extLst>
           </p:cNvPr>
@@ -2389,7 +2602,7 @@
           <p:cNvPr id="2" name="">
             <a:extLst xmlns:a="http://schemas.openxmlformats.org/drawingml/2006/main">
               <a:ext uri="{FF2B5EF4-FFF2-40B4-BE49-F238E27FC236}">
-                <a16:creationId xmlns:a16="http://schemas.microsoft.com/office/drawing/2014/main" id="{667F8BBC-FA84-4631-9C2B-9B6A97AF9655}"/>
+                <a16:creationId xmlns:a16="http://schemas.microsoft.com/office/drawing/2014/main" id="{F382C42A-C11B-456B-92D5-4B0E2FDB1312}"/>
               </a:ext>
             </a:extLst>
           </p:cNvPr>
@@ -2450,7 +2663,7 @@
           <p:cNvPr id="3" name="">
             <a:extLst xmlns:a="http://schemas.openxmlformats.org/drawingml/2006/main">
               <a:ext uri="{FF2B5EF4-FFF2-40B4-BE49-F238E27FC236}">
-                <a16:creationId xmlns:a16="http://schemas.microsoft.com/office/drawing/2014/main" id="{36F083A1-9FC1-4BED-838C-F8B4B2397B10}"/>
+                <a16:creationId xmlns:a16="http://schemas.microsoft.com/office/drawing/2014/main" id="{BE352025-3334-416E-8AFE-7DDA1E1B2C1E}"/>
               </a:ext>
             </a:extLst>
           </p:cNvPr>
@@ -2511,7 +2724,7 @@
           <p:cNvPr id="4" name="">
             <a:extLst xmlns:a="http://schemas.openxmlformats.org/drawingml/2006/main">
               <a:ext uri="{FF2B5EF4-FFF2-40B4-BE49-F238E27FC236}">
-                <a16:creationId xmlns:a16="http://schemas.microsoft.com/office/drawing/2014/main" id="{7730D7A9-F966-4E66-A7B4-95D0B0252623}"/>
+                <a16:creationId xmlns:a16="http://schemas.microsoft.com/office/drawing/2014/main" id="{B958C523-A7B3-45E7-A69A-0AC5FDDD9A1D}"/>
               </a:ext>
             </a:extLst>
           </p:cNvPr>
@@ -2576,7 +2789,7 @@
           <p:nvPr/>
         </p:nvPicPr>
         <p:blipFill>
-          <a:blip xmlns:r="http://schemas.openxmlformats.org/officeDocument/2006/relationships" xmlns:a="http://schemas.openxmlformats.org/drawingml/2006/main" r:embed="R3399447ea500454d"/>
+          <a:blip xmlns:r="http://schemas.openxmlformats.org/officeDocument/2006/relationships" xmlns:a="http://schemas.openxmlformats.org/drawingml/2006/main" r:embed="R07eda72a577d4fd1"/>
           <a:stretch xmlns:a="http://schemas.openxmlformats.org/drawingml/2006/main"/>
         </p:blipFill>
         <p:spPr>
@@ -2594,7 +2807,7 @@
           <p:cNvPr id="6" name="">
             <a:extLst xmlns:a="http://schemas.openxmlformats.org/drawingml/2006/main">
               <a:ext uri="{FF2B5EF4-FFF2-40B4-BE49-F238E27FC236}">
-                <a16:creationId xmlns:a16="http://schemas.microsoft.com/office/drawing/2014/main" id="{B112DE29-FB5A-491D-A668-8D4715FC38F9}"/>
+                <a16:creationId xmlns:a16="http://schemas.microsoft.com/office/drawing/2014/main" id="{E3154D58-B44A-488F-B7D7-A714C5E875A6}"/>
               </a:ext>
             </a:extLst>
           </p:cNvPr>
@@ -2655,7 +2868,7 @@
           <p:cNvPr id="7" name="">
             <a:extLst xmlns:a="http://schemas.openxmlformats.org/drawingml/2006/main">
               <a:ext uri="{FF2B5EF4-FFF2-40B4-BE49-F238E27FC236}">
-                <a16:creationId xmlns:a16="http://schemas.microsoft.com/office/drawing/2014/main" id="{D2957864-38FD-45BC-9B22-706E4893DCD3}"/>
+                <a16:creationId xmlns:a16="http://schemas.microsoft.com/office/drawing/2014/main" id="{09420CCD-2AAF-414D-BD93-D577DD610489}"/>
               </a:ext>
             </a:extLst>
           </p:cNvPr>
@@ -2716,7 +2929,7 @@
           <p:cNvPr id="8" name="">
             <a:extLst xmlns:a="http://schemas.openxmlformats.org/drawingml/2006/main">
               <a:ext uri="{FF2B5EF4-FFF2-40B4-BE49-F238E27FC236}">
-                <a16:creationId xmlns:a16="http://schemas.microsoft.com/office/drawing/2014/main" id="{EE570D63-FDE4-45F5-A671-2696963D0B39}"/>
+                <a16:creationId xmlns:a16="http://schemas.microsoft.com/office/drawing/2014/main" id="{F1E077B3-F368-4BA3-B22E-9193E0C7E8BF}"/>
               </a:ext>
             </a:extLst>
           </p:cNvPr>
@@ -2777,7 +2990,7 @@
           <p:cNvPr id="9" name="">
             <a:extLst xmlns:a="http://schemas.openxmlformats.org/drawingml/2006/main">
               <a:ext uri="{FF2B5EF4-FFF2-40B4-BE49-F238E27FC236}">
-                <a16:creationId xmlns:a16="http://schemas.microsoft.com/office/drawing/2014/main" id="{B0E2050E-EC51-4E02-9132-FCCEAC89F1BC}"/>
+                <a16:creationId xmlns:a16="http://schemas.microsoft.com/office/drawing/2014/main" id="{509D60E5-95A0-4A44-A79C-6C00DB6584F0}"/>
               </a:ext>
             </a:extLst>
           </p:cNvPr>
@@ -2838,7 +3051,7 @@
           <p:cNvPr id="10" name="">
             <a:extLst xmlns:a="http://schemas.openxmlformats.org/drawingml/2006/main">
               <a:ext uri="{FF2B5EF4-FFF2-40B4-BE49-F238E27FC236}">
-                <a16:creationId xmlns:a16="http://schemas.microsoft.com/office/drawing/2014/main" id="{1ACD2C81-16BE-4E77-B527-218FE8A6B48D}"/>
+                <a16:creationId xmlns:a16="http://schemas.microsoft.com/office/drawing/2014/main" id="{006635FA-73B8-42AD-98DF-1458F3B29814}"/>
               </a:ext>
             </a:extLst>
           </p:cNvPr>
@@ -2897,7 +3110,7 @@
     </p:spTree>
     <p:extLst>
       <p:ext uri="{BB962C8B-B14F-4D97-AF65-F5344CB8AC3E}">
-        <p14:creationId xmlns:p14="http://schemas.microsoft.com/office/powerpoint/2010/main" val="1092815356"/>
+        <p14:creationId xmlns:p14="http://schemas.microsoft.com/office/powerpoint/2010/main" val="1868418869"/>
       </p:ext>
     </p:extLst>
   </p:cSld>
@@ -2928,7 +3141,7 @@
           <p:cNvPr id="9" name="">
             <a:extLst xmlns:a="http://schemas.openxmlformats.org/drawingml/2006/main">
               <a:ext uri="{FF2B5EF4-FFF2-40B4-BE49-F238E27FC236}">
-                <a16:creationId xmlns:a16="http://schemas.microsoft.com/office/drawing/2014/main" id="{101F21FC-22B0-417B-870A-DCD5764240E5}"/>
+                <a16:creationId xmlns:a16="http://schemas.microsoft.com/office/drawing/2014/main" id="{3EC9F2C1-F152-4CE9-937E-F971EA43AD7A}"/>
               </a:ext>
             </a:extLst>
           </p:cNvPr>
@@ -2989,7 +3202,7 @@
           <p:cNvPr id="2" name="">
             <a:extLst xmlns:a="http://schemas.openxmlformats.org/drawingml/2006/main">
               <a:ext uri="{FF2B5EF4-FFF2-40B4-BE49-F238E27FC236}">
-                <a16:creationId xmlns:a16="http://schemas.microsoft.com/office/drawing/2014/main" id="{524F88FB-598A-4256-B96A-14AB7AFEDBDA}"/>
+                <a16:creationId xmlns:a16="http://schemas.microsoft.com/office/drawing/2014/main" id="{10D721F9-239E-46EB-9E9C-3D0C4AEB0BE6}"/>
               </a:ext>
             </a:extLst>
           </p:cNvPr>
@@ -3050,7 +3263,7 @@
           <p:cNvPr id="3" name="">
             <a:extLst xmlns:a="http://schemas.openxmlformats.org/drawingml/2006/main">
               <a:ext uri="{FF2B5EF4-FFF2-40B4-BE49-F238E27FC236}">
-                <a16:creationId xmlns:a16="http://schemas.microsoft.com/office/drawing/2014/main" id="{FE5EEAB3-61F5-4E0A-984A-E1FF3762010F}"/>
+                <a16:creationId xmlns:a16="http://schemas.microsoft.com/office/drawing/2014/main" id="{742FF340-4519-4800-BCD7-33A9518CD9C8}"/>
               </a:ext>
             </a:extLst>
           </p:cNvPr>
@@ -3111,7 +3324,7 @@
           <p:cNvPr id="4" name="">
             <a:extLst xmlns:a="http://schemas.openxmlformats.org/drawingml/2006/main">
               <a:ext uri="{FF2B5EF4-FFF2-40B4-BE49-F238E27FC236}">
-                <a16:creationId xmlns:a16="http://schemas.microsoft.com/office/drawing/2014/main" id="{F43108CE-F9E4-4194-834D-205A39265E44}"/>
+                <a16:creationId xmlns:a16="http://schemas.microsoft.com/office/drawing/2014/main" id="{1AE2B875-A107-4DF6-BB1F-92E48E319857}"/>
               </a:ext>
             </a:extLst>
           </p:cNvPr>
@@ -3176,7 +3389,7 @@
           <p:nvPr/>
         </p:nvPicPr>
         <p:blipFill>
-          <a:blip xmlns:r="http://schemas.openxmlformats.org/officeDocument/2006/relationships" xmlns:a="http://schemas.openxmlformats.org/drawingml/2006/main" r:embed="R7e561f812e9d4ffd"/>
+          <a:blip xmlns:r="http://schemas.openxmlformats.org/officeDocument/2006/relationships" xmlns:a="http://schemas.openxmlformats.org/drawingml/2006/main" r:embed="Ra8012491e5fa4881"/>
           <a:stretch xmlns:a="http://schemas.openxmlformats.org/drawingml/2006/main"/>
         </p:blipFill>
         <p:spPr>
@@ -3477,7 +3690,7 @@
           <p:cNvPr id="7" name="">
             <a:extLst xmlns:a="http://schemas.openxmlformats.org/drawingml/2006/main">
               <a:ext uri="{FF2B5EF4-FFF2-40B4-BE49-F238E27FC236}">
-                <a16:creationId xmlns:a16="http://schemas.microsoft.com/office/drawing/2014/main" id="{109BAA9B-C0A8-43DD-9086-F2DA9BC4B376}"/>
+                <a16:creationId xmlns:a16="http://schemas.microsoft.com/office/drawing/2014/main" id="{AC3A8413-A1CD-4408-B8C9-A2DB11AB76A2}"/>
               </a:ext>
             </a:extLst>
           </p:cNvPr>
@@ -3538,7 +3751,7 @@
           <p:cNvPr id="8" name="">
             <a:extLst xmlns:a="http://schemas.openxmlformats.org/drawingml/2006/main">
               <a:ext uri="{FF2B5EF4-FFF2-40B4-BE49-F238E27FC236}">
-                <a16:creationId xmlns:a16="http://schemas.microsoft.com/office/drawing/2014/main" id="{D286B8E3-FF9E-43B0-9332-8BDBB5B83719}"/>
+                <a16:creationId xmlns:a16="http://schemas.microsoft.com/office/drawing/2014/main" id="{33C0F27D-1983-4B9D-84F8-B46BE16E874F}"/>
               </a:ext>
             </a:extLst>
           </p:cNvPr>
@@ -3597,7 +3810,7 @@
     </p:spTree>
     <p:extLst>
       <p:ext uri="{BB962C8B-B14F-4D97-AF65-F5344CB8AC3E}">
-        <p14:creationId xmlns:p14="http://schemas.microsoft.com/office/powerpoint/2010/main" val="962487007"/>
+        <p14:creationId xmlns:p14="http://schemas.microsoft.com/office/powerpoint/2010/main" val="1285266853"/>
       </p:ext>
     </p:extLst>
   </p:cSld>
@@ -3628,7 +3841,7 @@
           <p:cNvPr id="11" name="">
             <a:extLst xmlns:a="http://schemas.openxmlformats.org/drawingml/2006/main">
               <a:ext uri="{FF2B5EF4-FFF2-40B4-BE49-F238E27FC236}">
-                <a16:creationId xmlns:a16="http://schemas.microsoft.com/office/drawing/2014/main" id="{53F45AD6-27C2-47D4-8356-19EAB122AA29}"/>
+                <a16:creationId xmlns:a16="http://schemas.microsoft.com/office/drawing/2014/main" id="{D66A9032-5BC0-4149-A4D4-DC146B0CDF97}"/>
               </a:ext>
             </a:extLst>
           </p:cNvPr>
@@ -3689,7 +3902,7 @@
           <p:cNvPr id="2" name="">
             <a:extLst xmlns:a="http://schemas.openxmlformats.org/drawingml/2006/main">
               <a:ext uri="{FF2B5EF4-FFF2-40B4-BE49-F238E27FC236}">
-                <a16:creationId xmlns:a16="http://schemas.microsoft.com/office/drawing/2014/main" id="{0EADE791-4FAA-4F32-9071-29B9D2BCBEED}"/>
+                <a16:creationId xmlns:a16="http://schemas.microsoft.com/office/drawing/2014/main" id="{E78E9B39-E68B-4F8F-BFCA-D4ACEEF6029C}"/>
               </a:ext>
             </a:extLst>
           </p:cNvPr>
@@ -3750,7 +3963,7 @@
           <p:cNvPr id="3" name="">
             <a:extLst xmlns:a="http://schemas.openxmlformats.org/drawingml/2006/main">
               <a:ext uri="{FF2B5EF4-FFF2-40B4-BE49-F238E27FC236}">
-                <a16:creationId xmlns:a16="http://schemas.microsoft.com/office/drawing/2014/main" id="{186CF75D-FBDC-4E76-9063-A16132647638}"/>
+                <a16:creationId xmlns:a16="http://schemas.microsoft.com/office/drawing/2014/main" id="{A62E885C-4229-4B73-8D9B-BBD72B5883FD}"/>
               </a:ext>
             </a:extLst>
           </p:cNvPr>
@@ -3811,7 +4024,7 @@
           <p:cNvPr id="4" name="">
             <a:extLst xmlns:a="http://schemas.openxmlformats.org/drawingml/2006/main">
               <a:ext uri="{FF2B5EF4-FFF2-40B4-BE49-F238E27FC236}">
-                <a16:creationId xmlns:a16="http://schemas.microsoft.com/office/drawing/2014/main" id="{BD92A017-42F9-4065-9282-D686DCCC079E}"/>
+                <a16:creationId xmlns:a16="http://schemas.microsoft.com/office/drawing/2014/main" id="{733545AF-1603-41C4-9686-37559E5C0246}"/>
               </a:ext>
             </a:extLst>
           </p:cNvPr>
@@ -3876,7 +4089,7 @@
           <p:nvPr/>
         </p:nvPicPr>
         <p:blipFill>
-          <a:blip xmlns:r="http://schemas.openxmlformats.org/officeDocument/2006/relationships" xmlns:a="http://schemas.openxmlformats.org/drawingml/2006/main" r:embed="Re5adfd0927524c3f"/>
+          <a:blip xmlns:r="http://schemas.openxmlformats.org/officeDocument/2006/relationships" xmlns:a="http://schemas.openxmlformats.org/drawingml/2006/main" r:embed="Rbb433cb00d7b4833"/>
           <a:stretch xmlns:a="http://schemas.openxmlformats.org/drawingml/2006/main"/>
         </p:blipFill>
         <p:spPr>
@@ -3894,7 +4107,7 @@
           <p:cNvPr id="6" name="">
             <a:extLst xmlns:a="http://schemas.openxmlformats.org/drawingml/2006/main">
               <a:ext uri="{FF2B5EF4-FFF2-40B4-BE49-F238E27FC236}">
-                <a16:creationId xmlns:a16="http://schemas.microsoft.com/office/drawing/2014/main" id="{80311430-8A99-4431-8455-AC527F2070E1}"/>
+                <a16:creationId xmlns:a16="http://schemas.microsoft.com/office/drawing/2014/main" id="{F05CDF73-F686-4CDD-8238-1AF2CA3D7DCC}"/>
               </a:ext>
             </a:extLst>
           </p:cNvPr>
@@ -3955,7 +4168,7 @@
           <p:cNvPr id="7" name="">
             <a:extLst xmlns:a="http://schemas.openxmlformats.org/drawingml/2006/main">
               <a:ext uri="{FF2B5EF4-FFF2-40B4-BE49-F238E27FC236}">
-                <a16:creationId xmlns:a16="http://schemas.microsoft.com/office/drawing/2014/main" id="{89FF4AD3-4052-4DC9-B75F-75CFBF952FAB}"/>
+                <a16:creationId xmlns:a16="http://schemas.microsoft.com/office/drawing/2014/main" id="{7E2E8D65-C249-4F4B-BF39-F39203AB9E61}"/>
               </a:ext>
             </a:extLst>
           </p:cNvPr>
@@ -4016,7 +4229,7 @@
           <p:cNvPr id="8" name="">
             <a:extLst xmlns:a="http://schemas.openxmlformats.org/drawingml/2006/main">
               <a:ext uri="{FF2B5EF4-FFF2-40B4-BE49-F238E27FC236}">
-                <a16:creationId xmlns:a16="http://schemas.microsoft.com/office/drawing/2014/main" id="{7A25FBE1-789F-413A-B9C2-887414E52262}"/>
+                <a16:creationId xmlns:a16="http://schemas.microsoft.com/office/drawing/2014/main" id="{A0887943-1E8C-47A2-9441-CF4D8AA0513C}"/>
               </a:ext>
             </a:extLst>
           </p:cNvPr>
@@ -4077,7 +4290,7 @@
           <p:cNvPr id="9" name="">
             <a:extLst xmlns:a="http://schemas.openxmlformats.org/drawingml/2006/main">
               <a:ext uri="{FF2B5EF4-FFF2-40B4-BE49-F238E27FC236}">
-                <a16:creationId xmlns:a16="http://schemas.microsoft.com/office/drawing/2014/main" id="{73C41910-DC76-4B5A-B440-56ADCB35F7EC}"/>
+                <a16:creationId xmlns:a16="http://schemas.microsoft.com/office/drawing/2014/main" id="{92DA953E-1CC1-4BAB-9D18-EA51B3F586F0}"/>
               </a:ext>
             </a:extLst>
           </p:cNvPr>
@@ -4138,7 +4351,7 @@
           <p:cNvPr id="10" name="">
             <a:extLst xmlns:a="http://schemas.openxmlformats.org/drawingml/2006/main">
               <a:ext uri="{FF2B5EF4-FFF2-40B4-BE49-F238E27FC236}">
-                <a16:creationId xmlns:a16="http://schemas.microsoft.com/office/drawing/2014/main" id="{DDD94A43-2862-4BEF-B542-F5DB448DF5C3}"/>
+                <a16:creationId xmlns:a16="http://schemas.microsoft.com/office/drawing/2014/main" id="{354254A1-FEE5-44C9-8644-CA0F9A9FC9EA}"/>
               </a:ext>
             </a:extLst>
           </p:cNvPr>
@@ -4197,7 +4410,7 @@
     </p:spTree>
     <p:extLst>
       <p:ext uri="{BB962C8B-B14F-4D97-AF65-F5344CB8AC3E}">
-        <p14:creationId xmlns:p14="http://schemas.microsoft.com/office/powerpoint/2010/main" val="902753178"/>
+        <p14:creationId xmlns:p14="http://schemas.microsoft.com/office/powerpoint/2010/main" val="1283968221"/>
       </p:ext>
     </p:extLst>
   </p:cSld>
@@ -4228,7 +4441,7 @@
           <p:cNvPr id="11" name="">
             <a:extLst xmlns:a="http://schemas.openxmlformats.org/drawingml/2006/main">
               <a:ext uri="{FF2B5EF4-FFF2-40B4-BE49-F238E27FC236}">
-                <a16:creationId xmlns:a16="http://schemas.microsoft.com/office/drawing/2014/main" id="{612CA299-438F-4EA7-BC8E-0AC62AD3BBDF}"/>
+                <a16:creationId xmlns:a16="http://schemas.microsoft.com/office/drawing/2014/main" id="{9AF86465-26BF-4B6D-80A9-F865018FA73A}"/>
               </a:ext>
             </a:extLst>
           </p:cNvPr>
@@ -4289,7 +4502,7 @@
           <p:cNvPr id="2" name="">
             <a:extLst xmlns:a="http://schemas.openxmlformats.org/drawingml/2006/main">
               <a:ext uri="{FF2B5EF4-FFF2-40B4-BE49-F238E27FC236}">
-                <a16:creationId xmlns:a16="http://schemas.microsoft.com/office/drawing/2014/main" id="{F50A51F0-5D97-4A06-BFD2-E1F1EF3E0E17}"/>
+                <a16:creationId xmlns:a16="http://schemas.microsoft.com/office/drawing/2014/main" id="{21616687-F611-4A1F-A22D-E921354BCD1A}"/>
               </a:ext>
             </a:extLst>
           </p:cNvPr>
@@ -4350,7 +4563,7 @@
           <p:cNvPr id="3" name="">
             <a:extLst xmlns:a="http://schemas.openxmlformats.org/drawingml/2006/main">
               <a:ext uri="{FF2B5EF4-FFF2-40B4-BE49-F238E27FC236}">
-                <a16:creationId xmlns:a16="http://schemas.microsoft.com/office/drawing/2014/main" id="{B39EBB06-64D3-4603-B78F-4C906C62B289}"/>
+                <a16:creationId xmlns:a16="http://schemas.microsoft.com/office/drawing/2014/main" id="{E19651D2-8038-480A-A5CF-7A4E7A25FEBB}"/>
               </a:ext>
             </a:extLst>
           </p:cNvPr>
@@ -4411,7 +4624,7 @@
           <p:cNvPr id="4" name="">
             <a:extLst xmlns:a="http://schemas.openxmlformats.org/drawingml/2006/main">
               <a:ext uri="{FF2B5EF4-FFF2-40B4-BE49-F238E27FC236}">
-                <a16:creationId xmlns:a16="http://schemas.microsoft.com/office/drawing/2014/main" id="{0880C7A2-E9DC-430E-A387-0F64A2069C1A}"/>
+                <a16:creationId xmlns:a16="http://schemas.microsoft.com/office/drawing/2014/main" id="{A6EA5691-CA52-4B16-8E64-92D81147FCBB}"/>
               </a:ext>
             </a:extLst>
           </p:cNvPr>
@@ -4472,7 +4685,7 @@
           <p:cNvPr id="5" name="">
             <a:extLst xmlns:a="http://schemas.openxmlformats.org/drawingml/2006/main">
               <a:ext uri="{FF2B5EF4-FFF2-40B4-BE49-F238E27FC236}">
-                <a16:creationId xmlns:a16="http://schemas.microsoft.com/office/drawing/2014/main" id="{84E7AC98-9DB2-4E48-8B77-36AA0C204DA3}"/>
+                <a16:creationId xmlns:a16="http://schemas.microsoft.com/office/drawing/2014/main" id="{3FF8AF82-F680-4BE8-9BEB-98D01363A119}"/>
               </a:ext>
             </a:extLst>
           </p:cNvPr>
@@ -4533,7 +4746,7 @@
           <p:cNvPr id="6" name="">
             <a:extLst xmlns:a="http://schemas.openxmlformats.org/drawingml/2006/main">
               <a:ext uri="{FF2B5EF4-FFF2-40B4-BE49-F238E27FC236}">
-                <a16:creationId xmlns:a16="http://schemas.microsoft.com/office/drawing/2014/main" id="{27A5F1E5-0A22-4625-BC74-166DD924F156}"/>
+                <a16:creationId xmlns:a16="http://schemas.microsoft.com/office/drawing/2014/main" id="{03200E5A-9980-4632-8EEE-314941AEF9AF}"/>
               </a:ext>
             </a:extLst>
           </p:cNvPr>
@@ -4594,7 +4807,7 @@
           <p:cNvPr id="7" name="">
             <a:extLst xmlns:a="http://schemas.openxmlformats.org/drawingml/2006/main">
               <a:ext uri="{FF2B5EF4-FFF2-40B4-BE49-F238E27FC236}">
-                <a16:creationId xmlns:a16="http://schemas.microsoft.com/office/drawing/2014/main" id="{D01D68E0-2A4B-4864-895C-2C760D7F70A6}"/>
+                <a16:creationId xmlns:a16="http://schemas.microsoft.com/office/drawing/2014/main" id="{5F72297F-4D0D-40FA-A36C-EDE0585F8129}"/>
               </a:ext>
             </a:extLst>
           </p:cNvPr>
@@ -4655,7 +4868,7 @@
           <p:cNvPr id="8" name="">
             <a:extLst xmlns:a="http://schemas.openxmlformats.org/drawingml/2006/main">
               <a:ext uri="{FF2B5EF4-FFF2-40B4-BE49-F238E27FC236}">
-                <a16:creationId xmlns:a16="http://schemas.microsoft.com/office/drawing/2014/main" id="{C0B7D0C3-9EF0-47EA-B063-FB894B76B384}"/>
+                <a16:creationId xmlns:a16="http://schemas.microsoft.com/office/drawing/2014/main" id="{D4FB69E5-9C9B-4F0A-B26E-1F83BA5AAE7F}"/>
               </a:ext>
             </a:extLst>
           </p:cNvPr>
@@ -4716,7 +4929,7 @@
           <p:cNvPr id="9" name="">
             <a:extLst xmlns:a="http://schemas.openxmlformats.org/drawingml/2006/main">
               <a:ext uri="{FF2B5EF4-FFF2-40B4-BE49-F238E27FC236}">
-                <a16:creationId xmlns:a16="http://schemas.microsoft.com/office/drawing/2014/main" id="{48B81768-7D53-482A-A939-4AEF7CEC43E8}"/>
+                <a16:creationId xmlns:a16="http://schemas.microsoft.com/office/drawing/2014/main" id="{626200E8-6309-4504-B7FB-D7EEA85E2F62}"/>
               </a:ext>
             </a:extLst>
           </p:cNvPr>
@@ -4777,7 +4990,7 @@
           <p:cNvPr id="10" name="">
             <a:extLst xmlns:a="http://schemas.openxmlformats.org/drawingml/2006/main">
               <a:ext uri="{FF2B5EF4-FFF2-40B4-BE49-F238E27FC236}">
-                <a16:creationId xmlns:a16="http://schemas.microsoft.com/office/drawing/2014/main" id="{72C258E8-DA4D-4B6F-8674-6FD175205BC5}"/>
+                <a16:creationId xmlns:a16="http://schemas.microsoft.com/office/drawing/2014/main" id="{8663E835-E9AE-42AB-9C2B-AAEA35FF51E8}"/>
               </a:ext>
             </a:extLst>
           </p:cNvPr>
@@ -4828,7 +5041,7 @@
                 <a:ea typeface="Arial"/>
                 <a:cs typeface="Arial"/>
               </a:rPr>
-              <a:t>Chạy lại từ raw: 18 bảng khớp nội dung, 5 hình byte-identical, raw hash không đổi; 151 tests pass.</a:t>
+              <a:t>Chạy lại từ raw: 18 bảng khớp nội dung, 5 hình byte-identical, raw hash không đổi; 175 tests pass.</a:t>
             </a:r>
           </a:p>
         </p:txBody>
@@ -4836,7 +5049,7 @@
     </p:spTree>
     <p:extLst>
       <p:ext uri="{BB962C8B-B14F-4D97-AF65-F5344CB8AC3E}">
-        <p14:creationId xmlns:p14="http://schemas.microsoft.com/office/powerpoint/2010/main" val="1246094989"/>
+        <p14:creationId xmlns:p14="http://schemas.microsoft.com/office/powerpoint/2010/main" val="1156684681"/>
       </p:ext>
     </p:extLst>
   </p:cSld>
@@ -4867,7 +5080,7 @@
           <p:cNvPr id="11" name="">
             <a:extLst xmlns:a="http://schemas.openxmlformats.org/drawingml/2006/main">
               <a:ext uri="{FF2B5EF4-FFF2-40B4-BE49-F238E27FC236}">
-                <a16:creationId xmlns:a16="http://schemas.microsoft.com/office/drawing/2014/main" id="{FE99ADE9-6E43-40E5-9A07-0D28D32734B7}"/>
+                <a16:creationId xmlns:a16="http://schemas.microsoft.com/office/drawing/2014/main" id="{741B6DE7-7A63-4AF3-9983-83FFC99F88CD}"/>
               </a:ext>
             </a:extLst>
           </p:cNvPr>
@@ -4918,7 +5131,7 @@
                 <a:ea typeface="Arial"/>
                 <a:cs typeface="Arial"/>
               </a:rPr>
-              <a:t>Kết luận và giới hạn</a:t>
+              <a:t>Thiết kế thử nghiệm cải thiện RUL</a:t>
             </a:r>
           </a:p>
         </p:txBody>
@@ -4928,7 +5141,7 @@
           <p:cNvPr id="2" name="">
             <a:extLst xmlns:a="http://schemas.openxmlformats.org/drawingml/2006/main">
               <a:ext uri="{FF2B5EF4-FFF2-40B4-BE49-F238E27FC236}">
-                <a16:creationId xmlns:a16="http://schemas.microsoft.com/office/drawing/2014/main" id="{0BEAC2FC-B75D-45F1-BE73-6BA45DC6A7AF}"/>
+                <a16:creationId xmlns:a16="http://schemas.microsoft.com/office/drawing/2014/main" id="{B62F893C-F757-46A0-9F98-93A277EAD64D}"/>
               </a:ext>
             </a:extLst>
           </p:cNvPr>
@@ -4979,7 +5192,7 @@
                 <a:ea typeface="Arial"/>
                 <a:cs typeface="Arial"/>
               </a:rPr>
-              <a:t>Kết quả chính trên FD001 và bằng chứng chuyển miền trong C-MAPSS</a:t>
+              <a:t>100 train engines, cùng 17.731 khóa từ cycle 30</a:t>
             </a:r>
           </a:p>
         </p:txBody>
@@ -4989,7 +5202,7 @@
           <p:cNvPr id="3" name="">
             <a:extLst xmlns:a="http://schemas.openxmlformats.org/drawingml/2006/main">
               <a:ext uri="{FF2B5EF4-FFF2-40B4-BE49-F238E27FC236}">
-                <a16:creationId xmlns:a16="http://schemas.microsoft.com/office/drawing/2014/main" id="{860E286B-B181-4E8C-99BE-D84D7FD87D46}"/>
+                <a16:creationId xmlns:a16="http://schemas.microsoft.com/office/drawing/2014/main" id="{75E74F10-65F1-4BC6-B141-3F32FAD3961B}"/>
               </a:ext>
             </a:extLst>
           </p:cNvPr>
@@ -5040,7 +5253,7 @@
                 <a:ea typeface="Arial"/>
                 <a:cs typeface="Arial"/>
               </a:rPr>
-              <a:t>Nguồn: report/sections/conclusion.tex; outputs/cross_dataset/matrix.json</a:t>
+              <a:t>Nguồn: experiments/README.md; 20260927_full/search_manifest.json</a:t>
             </a:r>
           </a:p>
         </p:txBody>
@@ -5050,7 +5263,7 @@
           <p:cNvPr id="4" name="">
             <a:extLst xmlns:a="http://schemas.openxmlformats.org/drawingml/2006/main">
               <a:ext uri="{FF2B5EF4-FFF2-40B4-BE49-F238E27FC236}">
-                <a16:creationId xmlns:a16="http://schemas.microsoft.com/office/drawing/2014/main" id="{5C395A74-A573-490E-851D-8D8F875D6A8E}"/>
+                <a16:creationId xmlns:a16="http://schemas.microsoft.com/office/drawing/2014/main" id="{D825E92B-7EBF-4F7A-826F-B4623816CD14}"/>
               </a:ext>
             </a:extLst>
           </p:cNvPr>
@@ -5111,7 +5324,7 @@
           <p:cNvPr id="5" name="">
             <a:extLst xmlns:a="http://schemas.openxmlformats.org/drawingml/2006/main">
               <a:ext uri="{FF2B5EF4-FFF2-40B4-BE49-F238E27FC236}">
-                <a16:creationId xmlns:a16="http://schemas.microsoft.com/office/drawing/2014/main" id="{2EDB35F8-C77A-4480-85E2-0EDB447A8C5A}"/>
+                <a16:creationId xmlns:a16="http://schemas.microsoft.com/office/drawing/2014/main" id="{D67CFE22-F841-4976-B8F8-BA76DF82A9C9}"/>
               </a:ext>
             </a:extLst>
           </p:cNvPr>
@@ -5162,7 +5375,7 @@
                 <a:ea typeface="Arial"/>
                 <a:cs typeface="Arial"/>
               </a:rPr>
-              <a:t>Kết quả chính</a:t>
+              <a:t>Phạm vi đã chạy</a:t>
             </a:r>
           </a:p>
         </p:txBody>
@@ -5172,7 +5385,7 @@
           <p:cNvPr id="6" name="">
             <a:extLst xmlns:a="http://schemas.openxmlformats.org/drawingml/2006/main">
               <a:ext uri="{FF2B5EF4-FFF2-40B4-BE49-F238E27FC236}">
-                <a16:creationId xmlns:a16="http://schemas.microsoft.com/office/drawing/2014/main" id="{A9B32345-8541-4949-8AA1-C840DF0AC4A3}"/>
+                <a16:creationId xmlns:a16="http://schemas.microsoft.com/office/drawing/2014/main" id="{C1568799-9501-4390-9EFA-7B6B3E645D0D}"/>
               </a:ext>
             </a:extLst>
           </p:cNvPr>
@@ -5184,7 +5397,7 @@
         <p:spPr>
           <a:xfrm xmlns:a="http://schemas.openxmlformats.org/drawingml/2006/main">
             <a:off x="714375" y="2000250"/>
-            <a:ext cx="10477500" cy="952500"/>
+            <a:ext cx="10477500" cy="857250"/>
           </a:xfrm>
           <a:prstGeom xmlns:a="http://schemas.openxmlformats.org/drawingml/2006/main" prst="rect">
             <a:avLst/>
@@ -5223,7 +5436,7 @@
                 <a:ea typeface="Arial"/>
                 <a:cs typeface="Arial"/>
               </a:rPr>
-              <a:t>HistGradientBoosting đạt MAE 15,3490 cycles trên 100 test engines; CI 95% [12,7286; 18,0866].</a:t>
+              <a:t>Window 10 / 20 / 30, 24 cấu hình HistGradientBoosting và 3 phương án trọng số RUL.</a:t>
             </a:r>
           </a:p>
         </p:txBody>
@@ -5233,7 +5446,7 @@
           <p:cNvPr id="7" name="">
             <a:extLst xmlns:a="http://schemas.openxmlformats.org/drawingml/2006/main">
               <a:ext uri="{FF2B5EF4-FFF2-40B4-BE49-F238E27FC236}">
-                <a16:creationId xmlns:a16="http://schemas.microsoft.com/office/drawing/2014/main" id="{F4F76635-2364-4D51-8C21-35DCEF207B77}"/>
+                <a16:creationId xmlns:a16="http://schemas.microsoft.com/office/drawing/2014/main" id="{8C0EA479-D9AC-4D05-8D1F-DD4F25B4E415}"/>
               </a:ext>
             </a:extLst>
           </p:cNvPr>
@@ -5244,7 +5457,7 @@
         </p:nvSpPr>
         <p:spPr>
           <a:xfrm xmlns:a="http://schemas.openxmlformats.org/drawingml/2006/main">
-            <a:off x="714375" y="3143250"/>
+            <a:off x="714375" y="3000375"/>
             <a:ext cx="10477500" cy="304800"/>
           </a:xfrm>
           <a:prstGeom xmlns:a="http://schemas.openxmlformats.org/drawingml/2006/main" prst="rect">
@@ -5284,7 +5497,7 @@
                 <a:ea typeface="Arial"/>
                 <a:cs typeface="Arial"/>
               </a:rPr>
-              <a:t>Giới hạn cần nhớ</a:t>
+              <a:t>Tách lựa chọn và đánh giá</a:t>
             </a:r>
           </a:p>
         </p:txBody>
@@ -5294,7 +5507,7 @@
           <p:cNvPr id="8" name="">
             <a:extLst xmlns:a="http://schemas.openxmlformats.org/drawingml/2006/main">
               <a:ext uri="{FF2B5EF4-FFF2-40B4-BE49-F238E27FC236}">
-                <a16:creationId xmlns:a16="http://schemas.microsoft.com/office/drawing/2014/main" id="{5AF317AD-8650-41BA-AECB-FAE561DDB14A}"/>
+                <a16:creationId xmlns:a16="http://schemas.microsoft.com/office/drawing/2014/main" id="{2E2DC638-765D-4F57-8328-6339EDABDBDD}"/>
               </a:ext>
             </a:extLst>
           </p:cNvPr>
@@ -5305,8 +5518,8 @@
         </p:nvSpPr>
         <p:spPr>
           <a:xfrm xmlns:a="http://schemas.openxmlformats.org/drawingml/2006/main">
-            <a:off x="714375" y="3524250"/>
-            <a:ext cx="10477500" cy="1190625"/>
+            <a:off x="714375" y="3381375"/>
+            <a:ext cx="10477500" cy="1047750"/>
           </a:xfrm>
           <a:prstGeom xmlns:a="http://schemas.openxmlformats.org/drawingml/2006/main" prst="rect">
             <a:avLst/>
@@ -5345,7 +5558,7 @@
                 <a:ea typeface="Arial"/>
                 <a:cs typeface="Arial"/>
               </a:rPr>
-              <a:t>Kết quả chính FD001 dùng window 30; ma trận transfer dùng window 10. Test chỉ đánh giá một điểm cắt mỗi engine. Cảnh báo OOF chưa độc lập với model selection.</a:t>
+              <a:t>5 outer folds đánh giá trên engine được giữ riêng. Mỗi outer train dùng 3 inner folds để chọn cấu hình.</a:t>
             </a:r>
           </a:p>
         </p:txBody>
@@ -5355,7 +5568,7 @@
           <p:cNvPr id="9" name="">
             <a:extLst xmlns:a="http://schemas.openxmlformats.org/drawingml/2006/main">
               <a:ext uri="{FF2B5EF4-FFF2-40B4-BE49-F238E27FC236}">
-                <a16:creationId xmlns:a16="http://schemas.microsoft.com/office/drawing/2014/main" id="{6C40BD18-613E-4DAA-87DF-D2B2B16AA747}"/>
+                <a16:creationId xmlns:a16="http://schemas.microsoft.com/office/drawing/2014/main" id="{96D07D62-715D-4A15-9DBB-5D3BB3204F9D}"/>
               </a:ext>
             </a:extLst>
           </p:cNvPr>
@@ -5366,7 +5579,7 @@
         </p:nvSpPr>
         <p:spPr>
           <a:xfrm xmlns:a="http://schemas.openxmlformats.org/drawingml/2006/main">
-            <a:off x="714375" y="4905375"/>
+            <a:off x="714375" y="4667250"/>
             <a:ext cx="10477500" cy="304800"/>
           </a:xfrm>
           <a:prstGeom xmlns:a="http://schemas.openxmlformats.org/drawingml/2006/main" prst="rect">
@@ -5406,7 +5619,7 @@
                 <a:ea typeface="Arial"/>
                 <a:cs typeface="Arial"/>
               </a:rPr>
-              <a:t>Bước nghiên cứu tiếp</a:t>
+              <a:t>Tiêu chí đã chốt</a:t>
             </a:r>
           </a:p>
         </p:txBody>
@@ -5416,7 +5629,7 @@
           <p:cNvPr id="10" name="">
             <a:extLst xmlns:a="http://schemas.openxmlformats.org/drawingml/2006/main">
               <a:ext uri="{FF2B5EF4-FFF2-40B4-BE49-F238E27FC236}">
-                <a16:creationId xmlns:a16="http://schemas.microsoft.com/office/drawing/2014/main" id="{896BC5FD-8AE6-4940-8036-042C16E9CE65}"/>
+                <a16:creationId xmlns:a16="http://schemas.microsoft.com/office/drawing/2014/main" id="{8ABEF3A2-D842-434F-9A25-9346899A7F08}"/>
               </a:ext>
             </a:extLst>
           </p:cNvPr>
@@ -5427,8 +5640,8 @@
         </p:nvSpPr>
         <p:spPr>
           <a:xfrm xmlns:a="http://schemas.openxmlformats.org/drawingml/2006/main">
-            <a:off x="714375" y="5286375"/>
-            <a:ext cx="10477500" cy="904875"/>
+            <a:off x="714375" y="5048250"/>
+            <a:ext cx="10477500" cy="1047750"/>
           </a:xfrm>
           <a:prstGeom xmlns:a="http://schemas.openxmlformats.org/drawingml/2006/main" prst="rect">
             <a:avLst/>
@@ -5467,7 +5680,7 @@
                 <a:ea typeface="Arial"/>
                 <a:cs typeface="Arial"/>
               </a:rPr>
-              <a:t>Retrain hoặc domain adaptation cho subset mới; sau đó kiểm tra cảnh báo bằng outer split theo engine.</a:t>
+              <a:t>Ưu tiên MAE khi RUL ≤ 30. MAE toàn bộ, tỷ lệ cảnh báo trễ và thời gian báo sớm phải không tăng.</a:t>
             </a:r>
           </a:p>
         </p:txBody>
@@ -5475,7 +5688,7 @@
     </p:spTree>
     <p:extLst>
       <p:ext uri="{BB962C8B-B14F-4D97-AF65-F5344CB8AC3E}">
-        <p14:creationId xmlns:p14="http://schemas.microsoft.com/office/powerpoint/2010/main" val="1298656101"/>
+        <p14:creationId xmlns:p14="http://schemas.microsoft.com/office/powerpoint/2010/main" val="249231885"/>
       </p:ext>
     </p:extLst>
   </p:cSld>
@@ -5506,7 +5719,7 @@
           <p:cNvPr id="8" name="">
             <a:extLst xmlns:a="http://schemas.openxmlformats.org/drawingml/2006/main">
               <a:ext uri="{FF2B5EF4-FFF2-40B4-BE49-F238E27FC236}">
-                <a16:creationId xmlns:a16="http://schemas.microsoft.com/office/drawing/2014/main" id="{AEE5FF50-1E48-4912-8A87-8CF56B2B91E1}"/>
+                <a16:creationId xmlns:a16="http://schemas.microsoft.com/office/drawing/2014/main" id="{3B6F23E5-6510-4160-88AE-1A2EB8C41C60}"/>
               </a:ext>
             </a:extLst>
           </p:cNvPr>
@@ -5557,7 +5770,7 @@
                 <a:ea typeface="Arial"/>
                 <a:cs typeface="Arial"/>
               </a:rPr>
-              <a:t>Transfer giữa các subset C-MAPSS</a:t>
+              <a:t>Kết quả chưa đạt tiêu chí cải thiện</a:t>
             </a:r>
           </a:p>
         </p:txBody>
@@ -5567,7 +5780,7 @@
           <p:cNvPr id="2" name="">
             <a:extLst xmlns:a="http://schemas.openxmlformats.org/drawingml/2006/main">
               <a:ext uri="{FF2B5EF4-FFF2-40B4-BE49-F238E27FC236}">
-                <a16:creationId xmlns:a16="http://schemas.microsoft.com/office/drawing/2014/main" id="{925D4280-F31D-4F34-AE76-948637F66BB3}"/>
+                <a16:creationId xmlns:a16="http://schemas.microsoft.com/office/drawing/2014/main" id="{3F99A810-D2F7-44C9-B03B-E2B4F1A87005}"/>
               </a:ext>
             </a:extLst>
           </p:cNvPr>
@@ -5618,7 +5831,7 @@
                 <a:ea typeface="Arial"/>
                 <a:cs typeface="Arial"/>
               </a:rPr>
-              <a:t>Window 10 cho phép giữ đủ test engines trong FD001–FD004</a:t>
+              <a:t>Outer evaluation của cả quy trình chọn cấu hình</a:t>
             </a:r>
           </a:p>
         </p:txBody>
@@ -5628,7 +5841,7 @@
           <p:cNvPr id="3" name="">
             <a:extLst xmlns:a="http://schemas.openxmlformats.org/drawingml/2006/main">
               <a:ext uri="{FF2B5EF4-FFF2-40B4-BE49-F238E27FC236}">
-                <a16:creationId xmlns:a16="http://schemas.microsoft.com/office/drawing/2014/main" id="{5FBE9F83-F46E-4175-82F8-DC483E43992E}"/>
+                <a16:creationId xmlns:a16="http://schemas.microsoft.com/office/drawing/2014/main" id="{64B9C10B-569A-482A-A6B1-20C32F8E8C46}"/>
               </a:ext>
             </a:extLst>
           </p:cNvPr>
@@ -5679,7 +5892,7 @@
                 <a:ea typeface="Arial"/>
                 <a:cs typeface="Arial"/>
               </a:rPr>
-              <a:t>Nguồn: outputs/cross_dataset/matrix.json; outputs/cross_dataset/README.md</a:t>
+              <a:t>Nguồn: 20260927_full/ablation_metrics.csv; paired_comparison.csv</a:t>
             </a:r>
           </a:p>
         </p:txBody>
@@ -5689,7 +5902,7 @@
           <p:cNvPr id="4" name="">
             <a:extLst xmlns:a="http://schemas.openxmlformats.org/drawingml/2006/main">
               <a:ext uri="{FF2B5EF4-FFF2-40B4-BE49-F238E27FC236}">
-                <a16:creationId xmlns:a16="http://schemas.microsoft.com/office/drawing/2014/main" id="{714768BA-4736-45C6-80C2-5BC6BB125AB8}"/>
+                <a16:creationId xmlns:a16="http://schemas.microsoft.com/office/drawing/2014/main" id="{274FDC0F-639A-4DC6-BBDE-E409E6458741}"/>
               </a:ext>
             </a:extLst>
           </p:cNvPr>
@@ -5741,6 +5954,2314 @@
                 <a:cs typeface="Arial"/>
               </a:rPr>
               <a:t>15</a:t>
+            </a:r>
+          </a:p>
+        </p:txBody>
+      </p:sp>
+      <p:graphicFrame>
+        <p:nvGraphicFramePr>
+          <p:cNvPr id="12" name=""/>
+          <p:cNvGraphicFramePr/>
+          <p:nvPr/>
+        </p:nvGraphicFramePr>
+        <p:xfrm>
+          <a:off xmlns:a="http://schemas.openxmlformats.org/drawingml/2006/main" x="666750" y="1619250"/>
+          <a:ext xmlns:a="http://schemas.openxmlformats.org/drawingml/2006/main" cx="10858500" cy="2571750"/>
+        </p:xfrm>
+        <a:graphic xmlns:a="http://schemas.openxmlformats.org/drawingml/2006/main">
+          <a:graphicData uri="http://schemas.openxmlformats.org/drawingml/2006/table">
+            <a:tbl>
+              <a:tblPr firstRow="1" bandRow="1"/>
+              <a:tblGrid>
+                <a:gridCol w="2714625"/>
+                <a:gridCol w="2714625"/>
+                <a:gridCol w="2714625"/>
+                <a:gridCol w="2714625"/>
+              </a:tblGrid>
+              <a:tr h="514350">
+                <a:tc>
+                  <a:txBody>
+                    <a:bodyPr/>
+                    <a:lstStyle/>
+                    <a:p>
+                      <a:r>
+                        <a:rPr sz="1575" b="1">
+                          <a:solidFill>
+                            <a:srgbClr val="FFFFFF"/>
+                          </a:solidFill>
+                          <a:latin typeface="Arial"/>
+                          <a:ea typeface="Arial"/>
+                          <a:cs typeface="Arial"/>
+                        </a:rPr>
+                        <a:t>Phương án</a:t>
+                      </a:r>
+                    </a:p>
+                  </a:txBody>
+                  <a:tcPr marL="91440" marR="91440" marT="45720" marB="45720">
+                    <a:solidFill>
+                      <a:srgbClr val="0F243E"/>
+                    </a:solidFill>
+                  </a:tcPr>
+                </a:tc>
+                <a:tc>
+                  <a:txBody>
+                    <a:bodyPr/>
+                    <a:lstStyle/>
+                    <a:p>
+                      <a:r>
+                        <a:rPr sz="1575" b="1">
+                          <a:solidFill>
+                            <a:srgbClr val="FFFFFF"/>
+                          </a:solidFill>
+                          <a:latin typeface="Arial"/>
+                          <a:ea typeface="Arial"/>
+                          <a:cs typeface="Arial"/>
+                        </a:rPr>
+                        <a:t>MAE toàn bộ</a:t>
+                      </a:r>
+                    </a:p>
+                  </a:txBody>
+                  <a:tcPr marL="91440" marR="91440" marT="45720" marB="45720">
+                    <a:solidFill>
+                      <a:srgbClr val="0F243E"/>
+                    </a:solidFill>
+                  </a:tcPr>
+                </a:tc>
+                <a:tc>
+                  <a:txBody>
+                    <a:bodyPr/>
+                    <a:lstStyle/>
+                    <a:p>
+                      <a:r>
+                        <a:rPr sz="1575" b="1">
+                          <a:solidFill>
+                            <a:srgbClr val="FFFFFF"/>
+                          </a:solidFill>
+                          <a:latin typeface="Arial"/>
+                          <a:ea typeface="Arial"/>
+                          <a:cs typeface="Arial"/>
+                        </a:rPr>
+                        <a:t>MAE RUL ≤ 30</a:t>
+                      </a:r>
+                    </a:p>
+                  </a:txBody>
+                  <a:tcPr marL="91440" marR="91440" marT="45720" marB="45720">
+                    <a:solidFill>
+                      <a:srgbClr val="0F243E"/>
+                    </a:solidFill>
+                  </a:tcPr>
+                </a:tc>
+                <a:tc>
+                  <a:txBody>
+                    <a:bodyPr/>
+                    <a:lstStyle/>
+                    <a:p>
+                      <a:r>
+                        <a:rPr sz="1575" b="1">
+                          <a:solidFill>
+                            <a:srgbClr val="FFFFFF"/>
+                          </a:solidFill>
+                          <a:latin typeface="Arial"/>
+                          <a:ea typeface="Arial"/>
+                          <a:cs typeface="Arial"/>
+                        </a:rPr>
+                        <a:t>Trễ / bỏ lỡ</a:t>
+                      </a:r>
+                    </a:p>
+                  </a:txBody>
+                  <a:tcPr marL="91440" marR="91440" marT="45720" marB="45720">
+                    <a:solidFill>
+                      <a:srgbClr val="0F243E"/>
+                    </a:solidFill>
+                  </a:tcPr>
+                </a:tc>
+              </a:tr>
+              <a:tr h="514350">
+                <a:tc>
+                  <a:txBody>
+                    <a:bodyPr/>
+                    <a:lstStyle/>
+                    <a:p>
+                      <a:r>
+                        <a:rPr sz="1575" b="0">
+                          <a:solidFill>
+                            <a:srgbClr val="16202A"/>
+                          </a:solidFill>
+                          <a:latin typeface="Arial"/>
+                          <a:ea typeface="Arial"/>
+                          <a:cs typeface="Arial"/>
+                        </a:rPr>
+                        <a:t>Baseline</a:t>
+                      </a:r>
+                    </a:p>
+                  </a:txBody>
+                  <a:tcPr marL="91440" marR="91440" marT="45720" marB="45720"/>
+                </a:tc>
+                <a:tc>
+                  <a:txBody>
+                    <a:bodyPr/>
+                    <a:lstStyle/>
+                    <a:p>
+                      <a:r>
+                        <a:rPr sz="1575" b="0">
+                          <a:solidFill>
+                            <a:srgbClr val="16202A"/>
+                          </a:solidFill>
+                          <a:latin typeface="Arial"/>
+                          <a:ea typeface="Arial"/>
+                          <a:cs typeface="Arial"/>
+                        </a:rPr>
+                        <a:t>20,2143</a:t>
+                      </a:r>
+                    </a:p>
+                  </a:txBody>
+                  <a:tcPr marL="91440" marR="91440" marT="45720" marB="45720"/>
+                </a:tc>
+                <a:tc>
+                  <a:txBody>
+                    <a:bodyPr/>
+                    <a:lstStyle/>
+                    <a:p>
+                      <a:r>
+                        <a:rPr sz="1575" b="0">
+                          <a:solidFill>
+                            <a:srgbClr val="16202A"/>
+                          </a:solidFill>
+                          <a:latin typeface="Arial"/>
+                          <a:ea typeface="Arial"/>
+                          <a:cs typeface="Arial"/>
+                        </a:rPr>
+                        <a:t>3,6676</a:t>
+                      </a:r>
+                    </a:p>
+                  </a:txBody>
+                  <a:tcPr marL="91440" marR="91440" marT="45720" marB="45720"/>
+                </a:tc>
+                <a:tc>
+                  <a:txBody>
+                    <a:bodyPr/>
+                    <a:lstStyle/>
+                    <a:p>
+                      <a:r>
+                        <a:rPr sz="1575" b="0">
+                          <a:solidFill>
+                            <a:srgbClr val="16202A"/>
+                          </a:solidFill>
+                          <a:latin typeface="Arial"/>
+                          <a:ea typeface="Arial"/>
+                          <a:cs typeface="Arial"/>
+                        </a:rPr>
+                        <a:t>49 / 100</a:t>
+                      </a:r>
+                    </a:p>
+                  </a:txBody>
+                  <a:tcPr marL="91440" marR="91440" marT="45720" marB="45720"/>
+                </a:tc>
+              </a:tr>
+              <a:tr h="514350">
+                <a:tc>
+                  <a:txBody>
+                    <a:bodyPr/>
+                    <a:lstStyle/>
+                    <a:p>
+                      <a:r>
+                        <a:rPr sz="1575" b="0">
+                          <a:solidFill>
+                            <a:srgbClr val="16202A"/>
+                          </a:solidFill>
+                          <a:latin typeface="Arial"/>
+                          <a:ea typeface="Arial"/>
+                          <a:cs typeface="Arial"/>
+                        </a:rPr>
+                        <a:t>Chọn window</a:t>
+                      </a:r>
+                    </a:p>
+                  </a:txBody>
+                  <a:tcPr marL="91440" marR="91440" marT="45720" marB="45720"/>
+                </a:tc>
+                <a:tc>
+                  <a:txBody>
+                    <a:bodyPr/>
+                    <a:lstStyle/>
+                    <a:p>
+                      <a:r>
+                        <a:rPr sz="1575" b="0">
+                          <a:solidFill>
+                            <a:srgbClr val="16202A"/>
+                          </a:solidFill>
+                          <a:latin typeface="Arial"/>
+                          <a:ea typeface="Arial"/>
+                          <a:cs typeface="Arial"/>
+                        </a:rPr>
+                        <a:t>20,2143</a:t>
+                      </a:r>
+                    </a:p>
+                  </a:txBody>
+                  <a:tcPr marL="91440" marR="91440" marT="45720" marB="45720"/>
+                </a:tc>
+                <a:tc>
+                  <a:txBody>
+                    <a:bodyPr/>
+                    <a:lstStyle/>
+                    <a:p>
+                      <a:r>
+                        <a:rPr sz="1575" b="0">
+                          <a:solidFill>
+                            <a:srgbClr val="16202A"/>
+                          </a:solidFill>
+                          <a:latin typeface="Arial"/>
+                          <a:ea typeface="Arial"/>
+                          <a:cs typeface="Arial"/>
+                        </a:rPr>
+                        <a:t>3,6676</a:t>
+                      </a:r>
+                    </a:p>
+                  </a:txBody>
+                  <a:tcPr marL="91440" marR="91440" marT="45720" marB="45720"/>
+                </a:tc>
+                <a:tc>
+                  <a:txBody>
+                    <a:bodyPr/>
+                    <a:lstStyle/>
+                    <a:p>
+                      <a:r>
+                        <a:rPr sz="1575" b="0">
+                          <a:solidFill>
+                            <a:srgbClr val="16202A"/>
+                          </a:solidFill>
+                          <a:latin typeface="Arial"/>
+                          <a:ea typeface="Arial"/>
+                          <a:cs typeface="Arial"/>
+                        </a:rPr>
+                        <a:t>49 / 100</a:t>
+                      </a:r>
+                    </a:p>
+                  </a:txBody>
+                  <a:tcPr marL="91440" marR="91440" marT="45720" marB="45720"/>
+                </a:tc>
+              </a:tr>
+              <a:tr h="514350">
+                <a:tc>
+                  <a:txBody>
+                    <a:bodyPr/>
+                    <a:lstStyle/>
+                    <a:p>
+                      <a:r>
+                        <a:rPr sz="1575" b="0">
+                          <a:solidFill>
+                            <a:srgbClr val="16202A"/>
+                          </a:solidFill>
+                          <a:latin typeface="Arial"/>
+                          <a:ea typeface="Arial"/>
+                          <a:cs typeface="Arial"/>
+                        </a:rPr>
+                        <a:t>Chỉnh tham số</a:t>
+                      </a:r>
+                    </a:p>
+                  </a:txBody>
+                  <a:tcPr marL="91440" marR="91440" marT="45720" marB="45720"/>
+                </a:tc>
+                <a:tc>
+                  <a:txBody>
+                    <a:bodyPr/>
+                    <a:lstStyle/>
+                    <a:p>
+                      <a:r>
+                        <a:rPr sz="1575" b="0">
+                          <a:solidFill>
+                            <a:srgbClr val="16202A"/>
+                          </a:solidFill>
+                          <a:latin typeface="Arial"/>
+                          <a:ea typeface="Arial"/>
+                          <a:cs typeface="Arial"/>
+                        </a:rPr>
+                        <a:t>20,2459</a:t>
+                      </a:r>
+                    </a:p>
+                  </a:txBody>
+                  <a:tcPr marL="91440" marR="91440" marT="45720" marB="45720"/>
+                </a:tc>
+                <a:tc>
+                  <a:txBody>
+                    <a:bodyPr/>
+                    <a:lstStyle/>
+                    <a:p>
+                      <a:r>
+                        <a:rPr sz="1575" b="0">
+                          <a:solidFill>
+                            <a:srgbClr val="16202A"/>
+                          </a:solidFill>
+                          <a:latin typeface="Arial"/>
+                          <a:ea typeface="Arial"/>
+                          <a:cs typeface="Arial"/>
+                        </a:rPr>
+                        <a:t>3,6730</a:t>
+                      </a:r>
+                    </a:p>
+                  </a:txBody>
+                  <a:tcPr marL="91440" marR="91440" marT="45720" marB="45720"/>
+                </a:tc>
+                <a:tc>
+                  <a:txBody>
+                    <a:bodyPr/>
+                    <a:lstStyle/>
+                    <a:p>
+                      <a:r>
+                        <a:rPr sz="1575" b="0">
+                          <a:solidFill>
+                            <a:srgbClr val="16202A"/>
+                          </a:solidFill>
+                          <a:latin typeface="Arial"/>
+                          <a:ea typeface="Arial"/>
+                          <a:cs typeface="Arial"/>
+                        </a:rPr>
+                        <a:t>53 / 100</a:t>
+                      </a:r>
+                    </a:p>
+                  </a:txBody>
+                  <a:tcPr marL="91440" marR="91440" marT="45720" marB="45720"/>
+                </a:tc>
+              </a:tr>
+              <a:tr h="514350">
+                <a:tc>
+                  <a:txBody>
+                    <a:bodyPr/>
+                    <a:lstStyle/>
+                    <a:p>
+                      <a:r>
+                        <a:rPr sz="1575" b="0">
+                          <a:solidFill>
+                            <a:srgbClr val="16202A"/>
+                          </a:solidFill>
+                          <a:latin typeface="Arial"/>
+                          <a:ea typeface="Arial"/>
+                          <a:cs typeface="Arial"/>
+                        </a:rPr>
+                        <a:t>Chọn trọng số</a:t>
+                      </a:r>
+                    </a:p>
+                  </a:txBody>
+                  <a:tcPr marL="91440" marR="91440" marT="45720" marB="45720"/>
+                </a:tc>
+                <a:tc>
+                  <a:txBody>
+                    <a:bodyPr/>
+                    <a:lstStyle/>
+                    <a:p>
+                      <a:r>
+                        <a:rPr sz="1575" b="0">
+                          <a:solidFill>
+                            <a:srgbClr val="16202A"/>
+                          </a:solidFill>
+                          <a:latin typeface="Arial"/>
+                          <a:ea typeface="Arial"/>
+                          <a:cs typeface="Arial"/>
+                        </a:rPr>
+                        <a:t>20,2459</a:t>
+                      </a:r>
+                    </a:p>
+                  </a:txBody>
+                  <a:tcPr marL="91440" marR="91440" marT="45720" marB="45720"/>
+                </a:tc>
+                <a:tc>
+                  <a:txBody>
+                    <a:bodyPr/>
+                    <a:lstStyle/>
+                    <a:p>
+                      <a:r>
+                        <a:rPr sz="1575" b="0">
+                          <a:solidFill>
+                            <a:srgbClr val="16202A"/>
+                          </a:solidFill>
+                          <a:latin typeface="Arial"/>
+                          <a:ea typeface="Arial"/>
+                          <a:cs typeface="Arial"/>
+                        </a:rPr>
+                        <a:t>3,6730</a:t>
+                      </a:r>
+                    </a:p>
+                  </a:txBody>
+                  <a:tcPr marL="91440" marR="91440" marT="45720" marB="45720"/>
+                </a:tc>
+                <a:tc>
+                  <a:txBody>
+                    <a:bodyPr/>
+                    <a:lstStyle/>
+                    <a:p>
+                      <a:r>
+                        <a:rPr sz="1575" b="0">
+                          <a:solidFill>
+                            <a:srgbClr val="16202A"/>
+                          </a:solidFill>
+                          <a:latin typeface="Arial"/>
+                          <a:ea typeface="Arial"/>
+                          <a:cs typeface="Arial"/>
+                        </a:rPr>
+                        <a:t>53 / 100</a:t>
+                      </a:r>
+                    </a:p>
+                  </a:txBody>
+                  <a:tcPr marL="91440" marR="91440" marT="45720" marB="45720"/>
+                </a:tc>
+              </a:tr>
+            </a:tbl>
+          </a:graphicData>
+        </a:graphic>
+      </p:graphicFrame>
+      <p:sp>
+        <p:nvSpPr>
+          <p:cNvPr id="6" name="">
+            <a:extLst xmlns:a="http://schemas.openxmlformats.org/drawingml/2006/main">
+              <a:ext uri="{FF2B5EF4-FFF2-40B4-BE49-F238E27FC236}">
+                <a16:creationId xmlns:a16="http://schemas.microsoft.com/office/drawing/2014/main" id="{8B2031A4-0830-47A4-99C1-F54918297302}"/>
+              </a:ext>
+            </a:extLst>
+          </p:cNvPr>
+          <p:cNvSpPr>
+            <a:spLocks xmlns:a="http://schemas.openxmlformats.org/drawingml/2006/main" noGrp="1"/>
+          </p:cNvSpPr>
+          <p:nvPr/>
+        </p:nvSpPr>
+        <p:spPr>
+          <a:xfrm xmlns:a="http://schemas.openxmlformats.org/drawingml/2006/main">
+            <a:off x="714375" y="4619625"/>
+            <a:ext cx="10572750" cy="523875"/>
+          </a:xfrm>
+          <a:prstGeom xmlns:a="http://schemas.openxmlformats.org/drawingml/2006/main" prst="rect">
+            <a:avLst/>
+          </a:prstGeom>
+          <a:noFill xmlns:a="http://schemas.openxmlformats.org/drawingml/2006/main"/>
+          <a:ln xmlns:a="http://schemas.openxmlformats.org/drawingml/2006/main" w="0">
+            <a:noFill/>
+          </a:ln>
+        </p:spPr>
+        <p:txBody>
+          <a:bodyPr xmlns:a="http://schemas.openxmlformats.org/drawingml/2006/main" lIns="0" tIns="0" rIns="0" bIns="0" anchor="t">
+            <a:normAutofit fontScale="100000"/>
+          </a:bodyPr>
+          <a:lstStyle xmlns:a="http://schemas.openxmlformats.org/drawingml/2006/main"/>
+          <a:p xmlns:a="http://schemas.openxmlformats.org/drawingml/2006/main">
+            <a:pPr algn="l">
+              <a:lnSpc>
+                <a:spcPct val="108000"/>
+              </a:lnSpc>
+              <a:buNone/>
+              <a:defRPr sz="1725" b="1">
+                <a:solidFill>
+                  <a:srgbClr val="0F243E"/>
+                </a:solidFill>
+                <a:latin typeface="Arial"/>
+                <a:ea typeface="Arial"/>
+                <a:cs typeface="Arial"/>
+              </a:defRPr>
+            </a:pPr>
+            <a:r>
+              <a:rPr sz="1725" b="1">
+                <a:solidFill>
+                  <a:srgbClr val="0F243E"/>
+                </a:solidFill>
+                <a:latin typeface="Arial"/>
+                <a:ea typeface="Arial"/>
+                <a:cs typeface="Arial"/>
+              </a:rPr>
+              <a:t>MAE RUL thấp thay đổi +0,0054 cycles, CI 95% [−0,0506; 0,0639].</a:t>
+            </a:r>
+          </a:p>
+        </p:txBody>
+      </p:sp>
+      <p:sp>
+        <p:nvSpPr>
+          <p:cNvPr id="7" name="">
+            <a:extLst xmlns:a="http://schemas.openxmlformats.org/drawingml/2006/main">
+              <a:ext uri="{FF2B5EF4-FFF2-40B4-BE49-F238E27FC236}">
+                <a16:creationId xmlns:a16="http://schemas.microsoft.com/office/drawing/2014/main" id="{20EC9E5F-B840-4E12-9781-52E7F074A5DE}"/>
+              </a:ext>
+            </a:extLst>
+          </p:cNvPr>
+          <p:cNvSpPr>
+            <a:spLocks xmlns:a="http://schemas.openxmlformats.org/drawingml/2006/main" noGrp="1"/>
+          </p:cNvSpPr>
+          <p:nvPr/>
+        </p:nvSpPr>
+        <p:spPr>
+          <a:xfrm xmlns:a="http://schemas.openxmlformats.org/drawingml/2006/main">
+            <a:off x="714375" y="5334000"/>
+            <a:ext cx="10572750" cy="571500"/>
+          </a:xfrm>
+          <a:prstGeom xmlns:a="http://schemas.openxmlformats.org/drawingml/2006/main" prst="rect">
+            <a:avLst/>
+          </a:prstGeom>
+          <a:noFill xmlns:a="http://schemas.openxmlformats.org/drawingml/2006/main"/>
+          <a:ln xmlns:a="http://schemas.openxmlformats.org/drawingml/2006/main" w="0">
+            <a:noFill/>
+          </a:ln>
+        </p:spPr>
+        <p:txBody>
+          <a:bodyPr xmlns:a="http://schemas.openxmlformats.org/drawingml/2006/main" lIns="0" tIns="0" rIns="0" bIns="0" anchor="t">
+            <a:normAutofit fontScale="100000"/>
+          </a:bodyPr>
+          <a:lstStyle xmlns:a="http://schemas.openxmlformats.org/drawingml/2006/main"/>
+          <a:p xmlns:a="http://schemas.openxmlformats.org/drawingml/2006/main">
+            <a:pPr algn="l">
+              <a:lnSpc>
+                <a:spcPct val="108000"/>
+              </a:lnSpc>
+              <a:buNone/>
+              <a:defRPr sz="1800" b="0">
+                <a:solidFill>
+                  <a:srgbClr val="16202A"/>
+                </a:solidFill>
+                <a:latin typeface="Arial"/>
+                <a:ea typeface="Arial"/>
+                <a:cs typeface="Arial"/>
+              </a:defRPr>
+            </a:pPr>
+            <a:r>
+              <a:rPr sz="1800" b="0">
+                <a:solidFill>
+                  <a:srgbClr val="16202A"/>
+                </a:solidFill>
+                <a:latin typeface="Arial"/>
+                <a:ea typeface="Arial"/>
+                <a:cs typeface="Arial"/>
+              </a:rPr>
+              <a:t>Cấu hình cuối trùng baseline. Test MAE giữ nguyên 15,3490 cycles.</a:t>
+            </a:r>
+          </a:p>
+        </p:txBody>
+      </p:sp>
+    </p:spTree>
+    <p:extLst>
+      <p:ext uri="{BB962C8B-B14F-4D97-AF65-F5344CB8AC3E}">
+        <p14:creationId xmlns:p14="http://schemas.microsoft.com/office/powerpoint/2010/main" val="1064156394"/>
+      </p:ext>
+    </p:extLst>
+  </p:cSld>
+</p:sld>
+</file>
+
+<file path=ppt/slides/slide16.xml><?xml version="1.0" encoding="utf-8"?>
+<p:sld xmlns:p="http://schemas.openxmlformats.org/presentationml/2006/main">
+  <p:cSld>
+    <p:bg>
+      <p:bgPr>
+        <a:solidFill xmlns:a="http://schemas.openxmlformats.org/drawingml/2006/main">
+          <a:srgbClr val="FFFFFF"/>
+        </a:solidFill>
+      </p:bgPr>
+    </p:bg>
+    <p:spTree>
+      <p:nvGrpSpPr>
+        <p:cNvPr id="1" name=""/>
+        <p:cNvGrpSpPr/>
+        <p:nvPr/>
+      </p:nvGrpSpPr>
+      <p:grpSpPr>
+        <a:xfrm xmlns:a="http://schemas.openxmlformats.org/drawingml/2006/main"/>
+      </p:grpSpPr>
+      <p:sp>
+        <p:nvSpPr>
+          <p:cNvPr id="9" name="">
+            <a:extLst xmlns:a="http://schemas.openxmlformats.org/drawingml/2006/main">
+              <a:ext uri="{FF2B5EF4-FFF2-40B4-BE49-F238E27FC236}">
+                <a16:creationId xmlns:a16="http://schemas.microsoft.com/office/drawing/2014/main" id="{3891DEB7-210D-4453-B81C-FC32A6BDF26C}"/>
+              </a:ext>
+            </a:extLst>
+          </p:cNvPr>
+          <p:cNvSpPr>
+            <a:spLocks xmlns:a="http://schemas.openxmlformats.org/drawingml/2006/main" noGrp="1"/>
+          </p:cNvSpPr>
+          <p:nvPr/>
+        </p:nvSpPr>
+        <p:spPr>
+          <a:xfrm xmlns:a="http://schemas.openxmlformats.org/drawingml/2006/main">
+            <a:off x="609600" y="361950"/>
+            <a:ext cx="10953750" cy="495300"/>
+          </a:xfrm>
+          <a:prstGeom xmlns:a="http://schemas.openxmlformats.org/drawingml/2006/main" prst="rect">
+            <a:avLst/>
+          </a:prstGeom>
+          <a:noFill xmlns:a="http://schemas.openxmlformats.org/drawingml/2006/main"/>
+          <a:ln xmlns:a="http://schemas.openxmlformats.org/drawingml/2006/main" w="0">
+            <a:noFill/>
+          </a:ln>
+        </p:spPr>
+        <p:txBody>
+          <a:bodyPr xmlns:a="http://schemas.openxmlformats.org/drawingml/2006/main" lIns="0" tIns="0" rIns="0" bIns="0" anchor="t">
+            <a:normAutofit fontScale="100000"/>
+          </a:bodyPr>
+          <a:lstStyle xmlns:a="http://schemas.openxmlformats.org/drawingml/2006/main"/>
+          <a:p xmlns:a="http://schemas.openxmlformats.org/drawingml/2006/main">
+            <a:pPr algn="l">
+              <a:lnSpc>
+                <a:spcPct val="108000"/>
+              </a:lnSpc>
+              <a:buNone/>
+              <a:defRPr sz="2550" b="1">
+                <a:solidFill>
+                  <a:srgbClr val="0F243E"/>
+                </a:solidFill>
+                <a:latin typeface="Arial"/>
+                <a:ea typeface="Arial"/>
+                <a:cs typeface="Arial"/>
+              </a:defRPr>
+            </a:pPr>
+            <a:r>
+              <a:rPr sz="2550" b="1">
+                <a:solidFill>
+                  <a:srgbClr val="0F243E"/>
+                </a:solidFill>
+                <a:latin typeface="Arial"/>
+                <a:ea typeface="Arial"/>
+                <a:cs typeface="Arial"/>
+              </a:rPr>
+              <a:t>Giảm sai số có thể đi kèm đánh đổi</a:t>
+            </a:r>
+          </a:p>
+        </p:txBody>
+      </p:sp>
+      <p:sp>
+        <p:nvSpPr>
+          <p:cNvPr id="2" name="">
+            <a:extLst xmlns:a="http://schemas.openxmlformats.org/drawingml/2006/main">
+              <a:ext uri="{FF2B5EF4-FFF2-40B4-BE49-F238E27FC236}">
+                <a16:creationId xmlns:a16="http://schemas.microsoft.com/office/drawing/2014/main" id="{1DC390D2-F4E5-4535-BF34-2D3BA53E2407}"/>
+              </a:ext>
+            </a:extLst>
+          </p:cNvPr>
+          <p:cNvSpPr>
+            <a:spLocks xmlns:a="http://schemas.openxmlformats.org/drawingml/2006/main" noGrp="1"/>
+          </p:cNvSpPr>
+          <p:nvPr/>
+        </p:nvSpPr>
+        <p:spPr>
+          <a:xfrm xmlns:a="http://schemas.openxmlformats.org/drawingml/2006/main">
+            <a:off x="628650" y="914400"/>
+            <a:ext cx="10858500" cy="333375"/>
+          </a:xfrm>
+          <a:prstGeom xmlns:a="http://schemas.openxmlformats.org/drawingml/2006/main" prst="rect">
+            <a:avLst/>
+          </a:prstGeom>
+          <a:noFill xmlns:a="http://schemas.openxmlformats.org/drawingml/2006/main"/>
+          <a:ln xmlns:a="http://schemas.openxmlformats.org/drawingml/2006/main" w="0">
+            <a:noFill/>
+          </a:ln>
+        </p:spPr>
+        <p:txBody>
+          <a:bodyPr xmlns:a="http://schemas.openxmlformats.org/drawingml/2006/main" lIns="0" tIns="0" rIns="0" bIns="0" anchor="t">
+            <a:normAutofit fontScale="100000"/>
+          </a:bodyPr>
+          <a:lstStyle xmlns:a="http://schemas.openxmlformats.org/drawingml/2006/main"/>
+          <a:p xmlns:a="http://schemas.openxmlformats.org/drawingml/2006/main">
+            <a:pPr algn="l">
+              <a:lnSpc>
+                <a:spcPct val="108000"/>
+              </a:lnSpc>
+              <a:buNone/>
+              <a:defRPr sz="1425" b="0">
+                <a:solidFill>
+                  <a:srgbClr val="52606D"/>
+                </a:solidFill>
+                <a:latin typeface="Arial"/>
+                <a:ea typeface="Arial"/>
+                <a:cs typeface="Arial"/>
+              </a:defRPr>
+            </a:pPr>
+            <a:r>
+              <a:rPr sz="1425" b="0">
+                <a:solidFill>
+                  <a:srgbClr val="52606D"/>
+                </a:solidFill>
+                <a:latin typeface="Arial"/>
+                <a:ea typeface="Arial"/>
+                <a:cs typeface="Arial"/>
+              </a:rPr>
+              <a:t>Ví dụ trong inner CV trên toàn train, phục vụ chọn cấu hình</a:t>
+            </a:r>
+          </a:p>
+        </p:txBody>
+      </p:sp>
+      <p:sp>
+        <p:nvSpPr>
+          <p:cNvPr id="3" name="">
+            <a:extLst xmlns:a="http://schemas.openxmlformats.org/drawingml/2006/main">
+              <a:ext uri="{FF2B5EF4-FFF2-40B4-BE49-F238E27FC236}">
+                <a16:creationId xmlns:a16="http://schemas.microsoft.com/office/drawing/2014/main" id="{687B6976-B8EB-4637-A0ED-CA870B44884D}"/>
+              </a:ext>
+            </a:extLst>
+          </p:cNvPr>
+          <p:cNvSpPr>
+            <a:spLocks xmlns:a="http://schemas.openxmlformats.org/drawingml/2006/main" noGrp="1"/>
+          </p:cNvSpPr>
+          <p:nvPr/>
+        </p:nvSpPr>
+        <p:spPr>
+          <a:xfrm xmlns:a="http://schemas.openxmlformats.org/drawingml/2006/main">
+            <a:off x="609600" y="6248400"/>
+            <a:ext cx="10287000" cy="285750"/>
+          </a:xfrm>
+          <a:prstGeom xmlns:a="http://schemas.openxmlformats.org/drawingml/2006/main" prst="rect">
+            <a:avLst/>
+          </a:prstGeom>
+          <a:noFill xmlns:a="http://schemas.openxmlformats.org/drawingml/2006/main"/>
+          <a:ln xmlns:a="http://schemas.openxmlformats.org/drawingml/2006/main" w="0">
+            <a:noFill/>
+          </a:ln>
+        </p:spPr>
+        <p:txBody>
+          <a:bodyPr xmlns:a="http://schemas.openxmlformats.org/drawingml/2006/main" lIns="0" tIns="0" rIns="0" bIns="0" anchor="t">
+            <a:normAutofit fontScale="100000"/>
+          </a:bodyPr>
+          <a:lstStyle xmlns:a="http://schemas.openxmlformats.org/drawingml/2006/main"/>
+          <a:p xmlns:a="http://schemas.openxmlformats.org/drawingml/2006/main">
+            <a:pPr algn="l">
+              <a:lnSpc>
+                <a:spcPct val="108000"/>
+              </a:lnSpc>
+              <a:buNone/>
+              <a:defRPr sz="900" b="0">
+                <a:solidFill>
+                  <a:srgbClr val="52606D"/>
+                </a:solidFill>
+                <a:latin typeface="Arial"/>
+                <a:ea typeface="Arial"/>
+                <a:cs typeface="Arial"/>
+              </a:defRPr>
+            </a:pPr>
+            <a:r>
+              <a:rPr sz="900" b="0">
+                <a:solidFill>
+                  <a:srgbClr val="52606D"/>
+                </a:solidFill>
+                <a:latin typeface="Arial"/>
+                <a:ea typeface="Arial"/>
+                <a:cs typeface="Arial"/>
+              </a:rPr>
+              <a:t>Nguồn: 20260927_full/final_selection_metrics.csv</a:t>
+            </a:r>
+          </a:p>
+        </p:txBody>
+      </p:sp>
+      <p:sp>
+        <p:nvSpPr>
+          <p:cNvPr id="4" name="">
+            <a:extLst xmlns:a="http://schemas.openxmlformats.org/drawingml/2006/main">
+              <a:ext uri="{FF2B5EF4-FFF2-40B4-BE49-F238E27FC236}">
+                <a16:creationId xmlns:a16="http://schemas.microsoft.com/office/drawing/2014/main" id="{4B6B763B-0D56-4C5D-81A8-84F21C240DE1}"/>
+              </a:ext>
+            </a:extLst>
+          </p:cNvPr>
+          <p:cNvSpPr>
+            <a:spLocks xmlns:a="http://schemas.openxmlformats.org/drawingml/2006/main" noGrp="1"/>
+          </p:cNvSpPr>
+          <p:nvPr/>
+        </p:nvSpPr>
+        <p:spPr>
+          <a:xfrm xmlns:a="http://schemas.openxmlformats.org/drawingml/2006/main">
+            <a:off x="11096625" y="6391275"/>
+            <a:ext cx="476250" cy="238125"/>
+          </a:xfrm>
+          <a:prstGeom xmlns:a="http://schemas.openxmlformats.org/drawingml/2006/main" prst="rect">
+            <a:avLst/>
+          </a:prstGeom>
+          <a:noFill xmlns:a="http://schemas.openxmlformats.org/drawingml/2006/main"/>
+          <a:ln xmlns:a="http://schemas.openxmlformats.org/drawingml/2006/main" w="0">
+            <a:noFill/>
+          </a:ln>
+        </p:spPr>
+        <p:txBody>
+          <a:bodyPr xmlns:a="http://schemas.openxmlformats.org/drawingml/2006/main" lIns="0" tIns="0" rIns="0" bIns="0" anchor="t">
+            <a:normAutofit fontScale="100000"/>
+          </a:bodyPr>
+          <a:lstStyle xmlns:a="http://schemas.openxmlformats.org/drawingml/2006/main"/>
+          <a:p xmlns:a="http://schemas.openxmlformats.org/drawingml/2006/main">
+            <a:pPr algn="r">
+              <a:lnSpc>
+                <a:spcPct val="108000"/>
+              </a:lnSpc>
+              <a:buNone/>
+              <a:defRPr sz="1050" b="1">
+                <a:solidFill>
+                  <a:srgbClr val="52606D"/>
+                </a:solidFill>
+                <a:latin typeface="Arial"/>
+                <a:ea typeface="Arial"/>
+                <a:cs typeface="Arial"/>
+              </a:defRPr>
+            </a:pPr>
+            <a:r>
+              <a:rPr sz="1050" b="1">
+                <a:solidFill>
+                  <a:srgbClr val="52606D"/>
+                </a:solidFill>
+                <a:latin typeface="Arial"/>
+                <a:ea typeface="Arial"/>
+                <a:cs typeface="Arial"/>
+              </a:rPr>
+              <a:t>16</a:t>
+            </a:r>
+          </a:p>
+        </p:txBody>
+      </p:sp>
+      <p:graphicFrame>
+        <p:nvGraphicFramePr>
+          <p:cNvPr id="13" name=""/>
+          <p:cNvGraphicFramePr/>
+          <p:nvPr/>
+        </p:nvGraphicFramePr>
+        <p:xfrm>
+          <a:off xmlns:a="http://schemas.openxmlformats.org/drawingml/2006/main" x="666750" y="1619250"/>
+          <a:ext xmlns:a="http://schemas.openxmlformats.org/drawingml/2006/main" cx="10858500" cy="2190750"/>
+        </p:xfrm>
+        <a:graphic xmlns:a="http://schemas.openxmlformats.org/drawingml/2006/main">
+          <a:graphicData uri="http://schemas.openxmlformats.org/drawingml/2006/table">
+            <a:tbl>
+              <a:tblPr firstRow="1" bandRow="1"/>
+              <a:tblGrid>
+                <a:gridCol w="2714625"/>
+                <a:gridCol w="2714625"/>
+                <a:gridCol w="2714625"/>
+                <a:gridCol w="2714625"/>
+              </a:tblGrid>
+              <a:tr h="547688">
+                <a:tc>
+                  <a:txBody>
+                    <a:bodyPr/>
+                    <a:lstStyle/>
+                    <a:p>
+                      <a:r>
+                        <a:rPr sz="1575" b="1">
+                          <a:solidFill>
+                            <a:srgbClr val="FFFFFF"/>
+                          </a:solidFill>
+                          <a:latin typeface="Arial"/>
+                          <a:ea typeface="Arial"/>
+                          <a:cs typeface="Arial"/>
+                        </a:rPr>
+                        <a:t>Ứng viên</a:t>
+                      </a:r>
+                    </a:p>
+                  </a:txBody>
+                  <a:tcPr marL="91440" marR="91440" marT="45720" marB="45720">
+                    <a:solidFill>
+                      <a:srgbClr val="0F243E"/>
+                    </a:solidFill>
+                  </a:tcPr>
+                </a:tc>
+                <a:tc>
+                  <a:txBody>
+                    <a:bodyPr/>
+                    <a:lstStyle/>
+                    <a:p>
+                      <a:r>
+                        <a:rPr sz="1575" b="1">
+                          <a:solidFill>
+                            <a:srgbClr val="FFFFFF"/>
+                          </a:solidFill>
+                          <a:latin typeface="Arial"/>
+                          <a:ea typeface="Arial"/>
+                          <a:cs typeface="Arial"/>
+                        </a:rPr>
+                        <a:t>MAE RUL ≤ 30</a:t>
+                      </a:r>
+                    </a:p>
+                  </a:txBody>
+                  <a:tcPr marL="91440" marR="91440" marT="45720" marB="45720">
+                    <a:solidFill>
+                      <a:srgbClr val="0F243E"/>
+                    </a:solidFill>
+                  </a:tcPr>
+                </a:tc>
+                <a:tc>
+                  <a:txBody>
+                    <a:bodyPr/>
+                    <a:lstStyle/>
+                    <a:p>
+                      <a:r>
+                        <a:rPr sz="1575" b="1">
+                          <a:solidFill>
+                            <a:srgbClr val="FFFFFF"/>
+                          </a:solidFill>
+                          <a:latin typeface="Arial"/>
+                          <a:ea typeface="Arial"/>
+                          <a:cs typeface="Arial"/>
+                        </a:rPr>
+                        <a:t>MAE toàn bộ</a:t>
+                      </a:r>
+                    </a:p>
+                  </a:txBody>
+                  <a:tcPr marL="91440" marR="91440" marT="45720" marB="45720">
+                    <a:solidFill>
+                      <a:srgbClr val="0F243E"/>
+                    </a:solidFill>
+                  </a:tcPr>
+                </a:tc>
+                <a:tc>
+                  <a:txBody>
+                    <a:bodyPr/>
+                    <a:lstStyle/>
+                    <a:p>
+                      <a:r>
+                        <a:rPr sz="1575" b="1">
+                          <a:solidFill>
+                            <a:srgbClr val="FFFFFF"/>
+                          </a:solidFill>
+                          <a:latin typeface="Arial"/>
+                          <a:ea typeface="Arial"/>
+                          <a:cs typeface="Arial"/>
+                        </a:rPr>
+                        <a:t>Trễ / bỏ lỡ</a:t>
+                      </a:r>
+                    </a:p>
+                  </a:txBody>
+                  <a:tcPr marL="91440" marR="91440" marT="45720" marB="45720">
+                    <a:solidFill>
+                      <a:srgbClr val="0F243E"/>
+                    </a:solidFill>
+                  </a:tcPr>
+                </a:tc>
+              </a:tr>
+              <a:tr h="547688">
+                <a:tc>
+                  <a:txBody>
+                    <a:bodyPr/>
+                    <a:lstStyle/>
+                    <a:p>
+                      <a:r>
+                        <a:rPr sz="1575" b="0">
+                          <a:solidFill>
+                            <a:srgbClr val="16202A"/>
+                          </a:solidFill>
+                          <a:latin typeface="Arial"/>
+                          <a:ea typeface="Arial"/>
+                          <a:cs typeface="Arial"/>
+                        </a:rPr>
+                        <a:t>Baseline</a:t>
+                      </a:r>
+                    </a:p>
+                  </a:txBody>
+                  <a:tcPr marL="91440" marR="91440" marT="45720" marB="45720"/>
+                </a:tc>
+                <a:tc>
+                  <a:txBody>
+                    <a:bodyPr/>
+                    <a:lstStyle/>
+                    <a:p>
+                      <a:r>
+                        <a:rPr sz="1575" b="0">
+                          <a:solidFill>
+                            <a:srgbClr val="16202A"/>
+                          </a:solidFill>
+                          <a:latin typeface="Arial"/>
+                          <a:ea typeface="Arial"/>
+                          <a:cs typeface="Arial"/>
+                        </a:rPr>
+                        <a:t>3,6148</a:t>
+                      </a:r>
+                    </a:p>
+                  </a:txBody>
+                  <a:tcPr marL="91440" marR="91440" marT="45720" marB="45720"/>
+                </a:tc>
+                <a:tc>
+                  <a:txBody>
+                    <a:bodyPr/>
+                    <a:lstStyle/>
+                    <a:p>
+                      <a:r>
+                        <a:rPr sz="1575" b="0">
+                          <a:solidFill>
+                            <a:srgbClr val="16202A"/>
+                          </a:solidFill>
+                          <a:latin typeface="Arial"/>
+                          <a:ea typeface="Arial"/>
+                          <a:cs typeface="Arial"/>
+                        </a:rPr>
+                        <a:t>20,3613</a:t>
+                      </a:r>
+                    </a:p>
+                  </a:txBody>
+                  <a:tcPr marL="91440" marR="91440" marT="45720" marB="45720"/>
+                </a:tc>
+                <a:tc>
+                  <a:txBody>
+                    <a:bodyPr/>
+                    <a:lstStyle/>
+                    <a:p>
+                      <a:r>
+                        <a:rPr sz="1575" b="0">
+                          <a:solidFill>
+                            <a:srgbClr val="16202A"/>
+                          </a:solidFill>
+                          <a:latin typeface="Arial"/>
+                          <a:ea typeface="Arial"/>
+                          <a:cs typeface="Arial"/>
+                        </a:rPr>
+                        <a:t>50 / 100</a:t>
+                      </a:r>
+                    </a:p>
+                  </a:txBody>
+                  <a:tcPr marL="91440" marR="91440" marT="45720" marB="45720"/>
+                </a:tc>
+              </a:tr>
+              <a:tr h="547688">
+                <a:tc>
+                  <a:txBody>
+                    <a:bodyPr/>
+                    <a:lstStyle/>
+                    <a:p>
+                      <a:r>
+                        <a:rPr sz="1575" b="0">
+                          <a:solidFill>
+                            <a:srgbClr val="16202A"/>
+                          </a:solidFill>
+                          <a:latin typeface="Arial"/>
+                          <a:ea typeface="Arial"/>
+                          <a:cs typeface="Arial"/>
+                        </a:rPr>
+                        <a:t>hgb_08</a:t>
+                      </a:r>
+                    </a:p>
+                  </a:txBody>
+                  <a:tcPr marL="91440" marR="91440" marT="45720" marB="45720"/>
+                </a:tc>
+                <a:tc>
+                  <a:txBody>
+                    <a:bodyPr/>
+                    <a:lstStyle/>
+                    <a:p>
+                      <a:r>
+                        <a:rPr sz="1575" b="0">
+                          <a:solidFill>
+                            <a:srgbClr val="16202A"/>
+                          </a:solidFill>
+                          <a:latin typeface="Arial"/>
+                          <a:ea typeface="Arial"/>
+                          <a:cs typeface="Arial"/>
+                        </a:rPr>
+                        <a:t>3,2625</a:t>
+                      </a:r>
+                    </a:p>
+                  </a:txBody>
+                  <a:tcPr marL="91440" marR="91440" marT="45720" marB="45720"/>
+                </a:tc>
+                <a:tc>
+                  <a:txBody>
+                    <a:bodyPr/>
+                    <a:lstStyle/>
+                    <a:p>
+                      <a:r>
+                        <a:rPr sz="1575" b="0">
+                          <a:solidFill>
+                            <a:srgbClr val="16202A"/>
+                          </a:solidFill>
+                          <a:latin typeface="Arial"/>
+                          <a:ea typeface="Arial"/>
+                          <a:cs typeface="Arial"/>
+                        </a:rPr>
+                        <a:t>20,6846</a:t>
+                      </a:r>
+                    </a:p>
+                  </a:txBody>
+                  <a:tcPr marL="91440" marR="91440" marT="45720" marB="45720"/>
+                </a:tc>
+                <a:tc>
+                  <a:txBody>
+                    <a:bodyPr/>
+                    <a:lstStyle/>
+                    <a:p>
+                      <a:r>
+                        <a:rPr sz="1575" b="0">
+                          <a:solidFill>
+                            <a:srgbClr val="16202A"/>
+                          </a:solidFill>
+                          <a:latin typeface="Arial"/>
+                          <a:ea typeface="Arial"/>
+                          <a:cs typeface="Arial"/>
+                        </a:rPr>
+                        <a:t>49 / 100</a:t>
+                      </a:r>
+                    </a:p>
+                  </a:txBody>
+                  <a:tcPr marL="91440" marR="91440" marT="45720" marB="45720"/>
+                </a:tc>
+              </a:tr>
+              <a:tr h="547688">
+                <a:tc>
+                  <a:txBody>
+                    <a:bodyPr/>
+                    <a:lstStyle/>
+                    <a:p>
+                      <a:r>
+                        <a:rPr sz="1575" b="0">
+                          <a:solidFill>
+                            <a:srgbClr val="16202A"/>
+                          </a:solidFill>
+                          <a:latin typeface="Arial"/>
+                          <a:ea typeface="Arial"/>
+                          <a:cs typeface="Arial"/>
+                        </a:rPr>
+                        <a:t>Ưu tiên RUL thấp cao</a:t>
+                      </a:r>
+                    </a:p>
+                  </a:txBody>
+                  <a:tcPr marL="91440" marR="91440" marT="45720" marB="45720"/>
+                </a:tc>
+                <a:tc>
+                  <a:txBody>
+                    <a:bodyPr/>
+                    <a:lstStyle/>
+                    <a:p>
+                      <a:r>
+                        <a:rPr sz="1575" b="0">
+                          <a:solidFill>
+                            <a:srgbClr val="16202A"/>
+                          </a:solidFill>
+                          <a:latin typeface="Arial"/>
+                          <a:ea typeface="Arial"/>
+                          <a:cs typeface="Arial"/>
+                        </a:rPr>
+                        <a:t>3,3901</a:t>
+                      </a:r>
+                    </a:p>
+                  </a:txBody>
+                  <a:tcPr marL="91440" marR="91440" marT="45720" marB="45720"/>
+                </a:tc>
+                <a:tc>
+                  <a:txBody>
+                    <a:bodyPr/>
+                    <a:lstStyle/>
+                    <a:p>
+                      <a:r>
+                        <a:rPr sz="1575" b="0">
+                          <a:solidFill>
+                            <a:srgbClr val="16202A"/>
+                          </a:solidFill>
+                          <a:latin typeface="Arial"/>
+                          <a:ea typeface="Arial"/>
+                          <a:cs typeface="Arial"/>
+                        </a:rPr>
+                        <a:t>20,4072</a:t>
+                      </a:r>
+                    </a:p>
+                  </a:txBody>
+                  <a:tcPr marL="91440" marR="91440" marT="45720" marB="45720"/>
+                </a:tc>
+                <a:tc>
+                  <a:txBody>
+                    <a:bodyPr/>
+                    <a:lstStyle/>
+                    <a:p>
+                      <a:r>
+                        <a:rPr sz="1575" b="0">
+                          <a:solidFill>
+                            <a:srgbClr val="16202A"/>
+                          </a:solidFill>
+                          <a:latin typeface="Arial"/>
+                          <a:ea typeface="Arial"/>
+                          <a:cs typeface="Arial"/>
+                        </a:rPr>
+                        <a:t>47 / 100</a:t>
+                      </a:r>
+                    </a:p>
+                  </a:txBody>
+                  <a:tcPr marL="91440" marR="91440" marT="45720" marB="45720"/>
+                </a:tc>
+              </a:tr>
+            </a:tbl>
+          </a:graphicData>
+        </a:graphic>
+      </p:graphicFrame>
+      <p:sp>
+        <p:nvSpPr>
+          <p:cNvPr id="6" name="">
+            <a:extLst xmlns:a="http://schemas.openxmlformats.org/drawingml/2006/main">
+              <a:ext uri="{FF2B5EF4-FFF2-40B4-BE49-F238E27FC236}">
+                <a16:creationId xmlns:a16="http://schemas.microsoft.com/office/drawing/2014/main" id="{140675A1-B358-47D9-8211-685E961051A7}"/>
+              </a:ext>
+            </a:extLst>
+          </p:cNvPr>
+          <p:cNvSpPr>
+            <a:spLocks xmlns:a="http://schemas.openxmlformats.org/drawingml/2006/main" noGrp="1"/>
+          </p:cNvSpPr>
+          <p:nvPr/>
+        </p:nvSpPr>
+        <p:spPr>
+          <a:xfrm xmlns:a="http://schemas.openxmlformats.org/drawingml/2006/main">
+            <a:off x="714375" y="4286250"/>
+            <a:ext cx="10477500" cy="304800"/>
+          </a:xfrm>
+          <a:prstGeom xmlns:a="http://schemas.openxmlformats.org/drawingml/2006/main" prst="rect">
+            <a:avLst/>
+          </a:prstGeom>
+          <a:noFill xmlns:a="http://schemas.openxmlformats.org/drawingml/2006/main"/>
+          <a:ln xmlns:a="http://schemas.openxmlformats.org/drawingml/2006/main" w="0">
+            <a:noFill/>
+          </a:ln>
+        </p:spPr>
+        <p:txBody>
+          <a:bodyPr xmlns:a="http://schemas.openxmlformats.org/drawingml/2006/main" lIns="0" tIns="0" rIns="0" bIns="0" anchor="t">
+            <a:normAutofit fontScale="100000"/>
+          </a:bodyPr>
+          <a:lstStyle xmlns:a="http://schemas.openxmlformats.org/drawingml/2006/main"/>
+          <a:p xmlns:a="http://schemas.openxmlformats.org/drawingml/2006/main">
+            <a:pPr algn="l">
+              <a:lnSpc>
+                <a:spcPct val="108000"/>
+              </a:lnSpc>
+              <a:buNone/>
+              <a:defRPr sz="1500" b="1">
+                <a:solidFill>
+                  <a:srgbClr val="1F7A8C"/>
+                </a:solidFill>
+                <a:latin typeface="Arial"/>
+                <a:ea typeface="Arial"/>
+                <a:cs typeface="Arial"/>
+              </a:defRPr>
+            </a:pPr>
+            <a:r>
+              <a:rPr sz="1500" b="1">
+                <a:solidFill>
+                  <a:srgbClr val="1F7A8C"/>
+                </a:solidFill>
+                <a:latin typeface="Arial"/>
+                <a:ea typeface="Arial"/>
+                <a:cs typeface="Arial"/>
+              </a:rPr>
+              <a:t>Lý do chưa thay model</a:t>
+            </a:r>
+          </a:p>
+        </p:txBody>
+      </p:sp>
+      <p:sp>
+        <p:nvSpPr>
+          <p:cNvPr id="7" name="">
+            <a:extLst xmlns:a="http://schemas.openxmlformats.org/drawingml/2006/main">
+              <a:ext uri="{FF2B5EF4-FFF2-40B4-BE49-F238E27FC236}">
+                <a16:creationId xmlns:a16="http://schemas.microsoft.com/office/drawing/2014/main" id="{B9ED52AE-F227-42DA-8037-D8EC0D01FA36}"/>
+              </a:ext>
+            </a:extLst>
+          </p:cNvPr>
+          <p:cNvSpPr>
+            <a:spLocks xmlns:a="http://schemas.openxmlformats.org/drawingml/2006/main" noGrp="1"/>
+          </p:cNvSpPr>
+          <p:nvPr/>
+        </p:nvSpPr>
+        <p:spPr>
+          <a:xfrm xmlns:a="http://schemas.openxmlformats.org/drawingml/2006/main">
+            <a:off x="714375" y="4667250"/>
+            <a:ext cx="10477500" cy="1143000"/>
+          </a:xfrm>
+          <a:prstGeom xmlns:a="http://schemas.openxmlformats.org/drawingml/2006/main" prst="rect">
+            <a:avLst/>
+          </a:prstGeom>
+          <a:noFill xmlns:a="http://schemas.openxmlformats.org/drawingml/2006/main"/>
+          <a:ln xmlns:a="http://schemas.openxmlformats.org/drawingml/2006/main" w="0">
+            <a:noFill/>
+          </a:ln>
+        </p:spPr>
+        <p:txBody>
+          <a:bodyPr xmlns:a="http://schemas.openxmlformats.org/drawingml/2006/main" lIns="0" tIns="0" rIns="0" bIns="0" anchor="t">
+            <a:normAutofit fontScale="100000"/>
+          </a:bodyPr>
+          <a:lstStyle xmlns:a="http://schemas.openxmlformats.org/drawingml/2006/main"/>
+          <a:p xmlns:a="http://schemas.openxmlformats.org/drawingml/2006/main">
+            <a:pPr algn="l">
+              <a:lnSpc>
+                <a:spcPct val="108000"/>
+              </a:lnSpc>
+              <a:buNone/>
+              <a:defRPr sz="1725" b="0">
+                <a:solidFill>
+                  <a:srgbClr val="16202A"/>
+                </a:solidFill>
+                <a:latin typeface="Arial"/>
+                <a:ea typeface="Arial"/>
+                <a:cs typeface="Arial"/>
+              </a:defRPr>
+            </a:pPr>
+            <a:r>
+              <a:rPr sz="1725" b="0">
+                <a:solidFill>
+                  <a:srgbClr val="16202A"/>
+                </a:solidFill>
+                <a:latin typeface="Arial"/>
+                <a:ea typeface="Arial"/>
+                <a:cs typeface="Arial"/>
+              </a:rPr>
+              <a:t>hgb_08 giảm sai số RUL thấp khoảng 9,75% nhưng tăng MAE toàn bộ. Phương án trọng số cao còn tăng thời gian báo sớm.</a:t>
+            </a:r>
+          </a:p>
+        </p:txBody>
+      </p:sp>
+      <p:sp>
+        <p:nvSpPr>
+          <p:cNvPr id="8" name="">
+            <a:extLst xmlns:a="http://schemas.openxmlformats.org/drawingml/2006/main">
+              <a:ext uri="{FF2B5EF4-FFF2-40B4-BE49-F238E27FC236}">
+                <a16:creationId xmlns:a16="http://schemas.microsoft.com/office/drawing/2014/main" id="{1C821484-2E9A-489A-901A-677C734ED3E6}"/>
+              </a:ext>
+            </a:extLst>
+          </p:cNvPr>
+          <p:cNvSpPr>
+            <a:spLocks xmlns:a="http://schemas.openxmlformats.org/drawingml/2006/main" noGrp="1"/>
+          </p:cNvSpPr>
+          <p:nvPr/>
+        </p:nvSpPr>
+        <p:spPr>
+          <a:xfrm xmlns:a="http://schemas.openxmlformats.org/drawingml/2006/main">
+            <a:off x="714375" y="5762625"/>
+            <a:ext cx="10572750" cy="333375"/>
+          </a:xfrm>
+          <a:prstGeom xmlns:a="http://schemas.openxmlformats.org/drawingml/2006/main" prst="rect">
+            <a:avLst/>
+          </a:prstGeom>
+          <a:noFill xmlns:a="http://schemas.openxmlformats.org/drawingml/2006/main"/>
+          <a:ln xmlns:a="http://schemas.openxmlformats.org/drawingml/2006/main" w="0">
+            <a:noFill/>
+          </a:ln>
+        </p:spPr>
+        <p:txBody>
+          <a:bodyPr xmlns:a="http://schemas.openxmlformats.org/drawingml/2006/main" lIns="0" tIns="0" rIns="0" bIns="0" anchor="t">
+            <a:normAutofit fontScale="100000"/>
+          </a:bodyPr>
+          <a:lstStyle xmlns:a="http://schemas.openxmlformats.org/drawingml/2006/main"/>
+          <a:p xmlns:a="http://schemas.openxmlformats.org/drawingml/2006/main">
+            <a:pPr algn="l">
+              <a:lnSpc>
+                <a:spcPct val="108000"/>
+              </a:lnSpc>
+              <a:buNone/>
+              <a:defRPr sz="1575" b="1">
+                <a:solidFill>
+                  <a:srgbClr val="0F243E"/>
+                </a:solidFill>
+                <a:latin typeface="Arial"/>
+                <a:ea typeface="Arial"/>
+                <a:cs typeface="Arial"/>
+              </a:defRPr>
+            </a:pPr>
+            <a:r>
+              <a:rPr sz="1575" b="1">
+                <a:solidFill>
+                  <a:srgbClr val="0F243E"/>
+                </a:solidFill>
+                <a:latin typeface="Arial"/>
+                <a:ea typeface="Arial"/>
+                <a:cs typeface="Arial"/>
+              </a:rPr>
+              <a:t>Đợt tiếp theo cần chốt mức đánh đổi chấp nhận được trước khi thử lại.</a:t>
+            </a:r>
+          </a:p>
+        </p:txBody>
+      </p:sp>
+    </p:spTree>
+    <p:extLst>
+      <p:ext uri="{BB962C8B-B14F-4D97-AF65-F5344CB8AC3E}">
+        <p14:creationId xmlns:p14="http://schemas.microsoft.com/office/powerpoint/2010/main" val="1172673718"/>
+      </p:ext>
+    </p:extLst>
+  </p:cSld>
+</p:sld>
+</file>
+
+<file path=ppt/slides/slide17.xml><?xml version="1.0" encoding="utf-8"?>
+<p:sld xmlns:p="http://schemas.openxmlformats.org/presentationml/2006/main">
+  <p:cSld>
+    <p:bg>
+      <p:bgPr>
+        <a:solidFill xmlns:a="http://schemas.openxmlformats.org/drawingml/2006/main">
+          <a:srgbClr val="FFFFFF"/>
+        </a:solidFill>
+      </p:bgPr>
+    </p:bg>
+    <p:spTree>
+      <p:nvGrpSpPr>
+        <p:cNvPr id="1" name=""/>
+        <p:cNvGrpSpPr/>
+        <p:nvPr/>
+      </p:nvGrpSpPr>
+      <p:grpSpPr>
+        <a:xfrm xmlns:a="http://schemas.openxmlformats.org/drawingml/2006/main"/>
+      </p:grpSpPr>
+      <p:sp>
+        <p:nvSpPr>
+          <p:cNvPr id="11" name="">
+            <a:extLst xmlns:a="http://schemas.openxmlformats.org/drawingml/2006/main">
+              <a:ext uri="{FF2B5EF4-FFF2-40B4-BE49-F238E27FC236}">
+                <a16:creationId xmlns:a16="http://schemas.microsoft.com/office/drawing/2014/main" id="{4FE6F597-DE63-406E-86A8-782AB3392698}"/>
+              </a:ext>
+            </a:extLst>
+          </p:cNvPr>
+          <p:cNvSpPr>
+            <a:spLocks xmlns:a="http://schemas.openxmlformats.org/drawingml/2006/main" noGrp="1"/>
+          </p:cNvSpPr>
+          <p:nvPr/>
+        </p:nvSpPr>
+        <p:spPr>
+          <a:xfrm xmlns:a="http://schemas.openxmlformats.org/drawingml/2006/main">
+            <a:off x="609600" y="361950"/>
+            <a:ext cx="10953750" cy="495300"/>
+          </a:xfrm>
+          <a:prstGeom xmlns:a="http://schemas.openxmlformats.org/drawingml/2006/main" prst="rect">
+            <a:avLst/>
+          </a:prstGeom>
+          <a:noFill xmlns:a="http://schemas.openxmlformats.org/drawingml/2006/main"/>
+          <a:ln xmlns:a="http://schemas.openxmlformats.org/drawingml/2006/main" w="0">
+            <a:noFill/>
+          </a:ln>
+        </p:spPr>
+        <p:txBody>
+          <a:bodyPr xmlns:a="http://schemas.openxmlformats.org/drawingml/2006/main" lIns="0" tIns="0" rIns="0" bIns="0" anchor="t">
+            <a:normAutofit fontScale="100000"/>
+          </a:bodyPr>
+          <a:lstStyle xmlns:a="http://schemas.openxmlformats.org/drawingml/2006/main"/>
+          <a:p xmlns:a="http://schemas.openxmlformats.org/drawingml/2006/main">
+            <a:pPr algn="l">
+              <a:lnSpc>
+                <a:spcPct val="108000"/>
+              </a:lnSpc>
+              <a:buNone/>
+              <a:defRPr sz="2550" b="1">
+                <a:solidFill>
+                  <a:srgbClr val="0F243E"/>
+                </a:solidFill>
+                <a:latin typeface="Arial"/>
+                <a:ea typeface="Arial"/>
+                <a:cs typeface="Arial"/>
+              </a:defRPr>
+            </a:pPr>
+            <a:r>
+              <a:rPr sz="2550" b="1">
+                <a:solidFill>
+                  <a:srgbClr val="0F243E"/>
+                </a:solidFill>
+                <a:latin typeface="Arial"/>
+                <a:ea typeface="Arial"/>
+                <a:cs typeface="Arial"/>
+              </a:rPr>
+              <a:t>Kết luận và giới hạn</a:t>
+            </a:r>
+          </a:p>
+        </p:txBody>
+      </p:sp>
+      <p:sp>
+        <p:nvSpPr>
+          <p:cNvPr id="2" name="">
+            <a:extLst xmlns:a="http://schemas.openxmlformats.org/drawingml/2006/main">
+              <a:ext uri="{FF2B5EF4-FFF2-40B4-BE49-F238E27FC236}">
+                <a16:creationId xmlns:a16="http://schemas.microsoft.com/office/drawing/2014/main" id="{DD68E398-3833-4AD0-B74C-D8C90ADCB691}"/>
+              </a:ext>
+            </a:extLst>
+          </p:cNvPr>
+          <p:cNvSpPr>
+            <a:spLocks xmlns:a="http://schemas.openxmlformats.org/drawingml/2006/main" noGrp="1"/>
+          </p:cNvSpPr>
+          <p:nvPr/>
+        </p:nvSpPr>
+        <p:spPr>
+          <a:xfrm xmlns:a="http://schemas.openxmlformats.org/drawingml/2006/main">
+            <a:off x="628650" y="914400"/>
+            <a:ext cx="10858500" cy="333375"/>
+          </a:xfrm>
+          <a:prstGeom xmlns:a="http://schemas.openxmlformats.org/drawingml/2006/main" prst="rect">
+            <a:avLst/>
+          </a:prstGeom>
+          <a:noFill xmlns:a="http://schemas.openxmlformats.org/drawingml/2006/main"/>
+          <a:ln xmlns:a="http://schemas.openxmlformats.org/drawingml/2006/main" w="0">
+            <a:noFill/>
+          </a:ln>
+        </p:spPr>
+        <p:txBody>
+          <a:bodyPr xmlns:a="http://schemas.openxmlformats.org/drawingml/2006/main" lIns="0" tIns="0" rIns="0" bIns="0" anchor="t">
+            <a:normAutofit fontScale="100000"/>
+          </a:bodyPr>
+          <a:lstStyle xmlns:a="http://schemas.openxmlformats.org/drawingml/2006/main"/>
+          <a:p xmlns:a="http://schemas.openxmlformats.org/drawingml/2006/main">
+            <a:pPr algn="l">
+              <a:lnSpc>
+                <a:spcPct val="108000"/>
+              </a:lnSpc>
+              <a:buNone/>
+              <a:defRPr sz="1425" b="0">
+                <a:solidFill>
+                  <a:srgbClr val="52606D"/>
+                </a:solidFill>
+                <a:latin typeface="Arial"/>
+                <a:ea typeface="Arial"/>
+                <a:cs typeface="Arial"/>
+              </a:defRPr>
+            </a:pPr>
+            <a:r>
+              <a:rPr sz="1425" b="0">
+                <a:solidFill>
+                  <a:srgbClr val="52606D"/>
+                </a:solidFill>
+                <a:latin typeface="Arial"/>
+                <a:ea typeface="Arial"/>
+                <a:cs typeface="Arial"/>
+              </a:rPr>
+              <a:t>Kết quả chính trên FD001 và bằng chứng chuyển miền trong C-MAPSS</a:t>
+            </a:r>
+          </a:p>
+        </p:txBody>
+      </p:sp>
+      <p:sp>
+        <p:nvSpPr>
+          <p:cNvPr id="3" name="">
+            <a:extLst xmlns:a="http://schemas.openxmlformats.org/drawingml/2006/main">
+              <a:ext uri="{FF2B5EF4-FFF2-40B4-BE49-F238E27FC236}">
+                <a16:creationId xmlns:a16="http://schemas.microsoft.com/office/drawing/2014/main" id="{F07D4E4B-81DC-4841-B9B5-485D13C6908A}"/>
+              </a:ext>
+            </a:extLst>
+          </p:cNvPr>
+          <p:cNvSpPr>
+            <a:spLocks xmlns:a="http://schemas.openxmlformats.org/drawingml/2006/main" noGrp="1"/>
+          </p:cNvSpPr>
+          <p:nvPr/>
+        </p:nvSpPr>
+        <p:spPr>
+          <a:xfrm xmlns:a="http://schemas.openxmlformats.org/drawingml/2006/main">
+            <a:off x="609600" y="6248400"/>
+            <a:ext cx="10287000" cy="285750"/>
+          </a:xfrm>
+          <a:prstGeom xmlns:a="http://schemas.openxmlformats.org/drawingml/2006/main" prst="rect">
+            <a:avLst/>
+          </a:prstGeom>
+          <a:noFill xmlns:a="http://schemas.openxmlformats.org/drawingml/2006/main"/>
+          <a:ln xmlns:a="http://schemas.openxmlformats.org/drawingml/2006/main" w="0">
+            <a:noFill/>
+          </a:ln>
+        </p:spPr>
+        <p:txBody>
+          <a:bodyPr xmlns:a="http://schemas.openxmlformats.org/drawingml/2006/main" lIns="0" tIns="0" rIns="0" bIns="0" anchor="t">
+            <a:normAutofit fontScale="100000"/>
+          </a:bodyPr>
+          <a:lstStyle xmlns:a="http://schemas.openxmlformats.org/drawingml/2006/main"/>
+          <a:p xmlns:a="http://schemas.openxmlformats.org/drawingml/2006/main">
+            <a:pPr algn="l">
+              <a:lnSpc>
+                <a:spcPct val="108000"/>
+              </a:lnSpc>
+              <a:buNone/>
+              <a:defRPr sz="900" b="0">
+                <a:solidFill>
+                  <a:srgbClr val="52606D"/>
+                </a:solidFill>
+                <a:latin typeface="Arial"/>
+                <a:ea typeface="Arial"/>
+                <a:cs typeface="Arial"/>
+              </a:defRPr>
+            </a:pPr>
+            <a:r>
+              <a:rPr sz="900" b="0">
+                <a:solidFill>
+                  <a:srgbClr val="52606D"/>
+                </a:solidFill>
+                <a:latin typeface="Arial"/>
+                <a:ea typeface="Arial"/>
+                <a:cs typeface="Arial"/>
+              </a:rPr>
+              <a:t>Nguồn: report/sections/conclusion.tex; outputs/cross_dataset/matrix.json</a:t>
+            </a:r>
+          </a:p>
+        </p:txBody>
+      </p:sp>
+      <p:sp>
+        <p:nvSpPr>
+          <p:cNvPr id="4" name="">
+            <a:extLst xmlns:a="http://schemas.openxmlformats.org/drawingml/2006/main">
+              <a:ext uri="{FF2B5EF4-FFF2-40B4-BE49-F238E27FC236}">
+                <a16:creationId xmlns:a16="http://schemas.microsoft.com/office/drawing/2014/main" id="{B84F7688-69DA-4792-9184-8D407A66DB35}"/>
+              </a:ext>
+            </a:extLst>
+          </p:cNvPr>
+          <p:cNvSpPr>
+            <a:spLocks xmlns:a="http://schemas.openxmlformats.org/drawingml/2006/main" noGrp="1"/>
+          </p:cNvSpPr>
+          <p:nvPr/>
+        </p:nvSpPr>
+        <p:spPr>
+          <a:xfrm xmlns:a="http://schemas.openxmlformats.org/drawingml/2006/main">
+            <a:off x="11096625" y="6391275"/>
+            <a:ext cx="476250" cy="238125"/>
+          </a:xfrm>
+          <a:prstGeom xmlns:a="http://schemas.openxmlformats.org/drawingml/2006/main" prst="rect">
+            <a:avLst/>
+          </a:prstGeom>
+          <a:noFill xmlns:a="http://schemas.openxmlformats.org/drawingml/2006/main"/>
+          <a:ln xmlns:a="http://schemas.openxmlformats.org/drawingml/2006/main" w="0">
+            <a:noFill/>
+          </a:ln>
+        </p:spPr>
+        <p:txBody>
+          <a:bodyPr xmlns:a="http://schemas.openxmlformats.org/drawingml/2006/main" lIns="0" tIns="0" rIns="0" bIns="0" anchor="t">
+            <a:normAutofit fontScale="100000"/>
+          </a:bodyPr>
+          <a:lstStyle xmlns:a="http://schemas.openxmlformats.org/drawingml/2006/main"/>
+          <a:p xmlns:a="http://schemas.openxmlformats.org/drawingml/2006/main">
+            <a:pPr algn="r">
+              <a:lnSpc>
+                <a:spcPct val="108000"/>
+              </a:lnSpc>
+              <a:buNone/>
+              <a:defRPr sz="1050" b="1">
+                <a:solidFill>
+                  <a:srgbClr val="52606D"/>
+                </a:solidFill>
+                <a:latin typeface="Arial"/>
+                <a:ea typeface="Arial"/>
+                <a:cs typeface="Arial"/>
+              </a:defRPr>
+            </a:pPr>
+            <a:r>
+              <a:rPr sz="1050" b="1">
+                <a:solidFill>
+                  <a:srgbClr val="52606D"/>
+                </a:solidFill>
+                <a:latin typeface="Arial"/>
+                <a:ea typeface="Arial"/>
+                <a:cs typeface="Arial"/>
+              </a:rPr>
+              <a:t>17</a:t>
+            </a:r>
+          </a:p>
+        </p:txBody>
+      </p:sp>
+      <p:sp>
+        <p:nvSpPr>
+          <p:cNvPr id="5" name="">
+            <a:extLst xmlns:a="http://schemas.openxmlformats.org/drawingml/2006/main">
+              <a:ext uri="{FF2B5EF4-FFF2-40B4-BE49-F238E27FC236}">
+                <a16:creationId xmlns:a16="http://schemas.microsoft.com/office/drawing/2014/main" id="{EB40D202-ACA0-49F1-B359-1A9A78D147B4}"/>
+              </a:ext>
+            </a:extLst>
+          </p:cNvPr>
+          <p:cNvSpPr>
+            <a:spLocks xmlns:a="http://schemas.openxmlformats.org/drawingml/2006/main" noGrp="1"/>
+          </p:cNvSpPr>
+          <p:nvPr/>
+        </p:nvSpPr>
+        <p:spPr>
+          <a:xfrm xmlns:a="http://schemas.openxmlformats.org/drawingml/2006/main">
+            <a:off x="714375" y="1619250"/>
+            <a:ext cx="10477500" cy="304800"/>
+          </a:xfrm>
+          <a:prstGeom xmlns:a="http://schemas.openxmlformats.org/drawingml/2006/main" prst="rect">
+            <a:avLst/>
+          </a:prstGeom>
+          <a:noFill xmlns:a="http://schemas.openxmlformats.org/drawingml/2006/main"/>
+          <a:ln xmlns:a="http://schemas.openxmlformats.org/drawingml/2006/main" w="0">
+            <a:noFill/>
+          </a:ln>
+        </p:spPr>
+        <p:txBody>
+          <a:bodyPr xmlns:a="http://schemas.openxmlformats.org/drawingml/2006/main" lIns="0" tIns="0" rIns="0" bIns="0" anchor="t">
+            <a:normAutofit fontScale="100000"/>
+          </a:bodyPr>
+          <a:lstStyle xmlns:a="http://schemas.openxmlformats.org/drawingml/2006/main"/>
+          <a:p xmlns:a="http://schemas.openxmlformats.org/drawingml/2006/main">
+            <a:pPr algn="l">
+              <a:lnSpc>
+                <a:spcPct val="108000"/>
+              </a:lnSpc>
+              <a:buNone/>
+              <a:defRPr sz="1500" b="1">
+                <a:solidFill>
+                  <a:srgbClr val="1F7A8C"/>
+                </a:solidFill>
+                <a:latin typeface="Arial"/>
+                <a:ea typeface="Arial"/>
+                <a:cs typeface="Arial"/>
+              </a:defRPr>
+            </a:pPr>
+            <a:r>
+              <a:rPr sz="1500" b="1">
+                <a:solidFill>
+                  <a:srgbClr val="1F7A8C"/>
+                </a:solidFill>
+                <a:latin typeface="Arial"/>
+                <a:ea typeface="Arial"/>
+                <a:cs typeface="Arial"/>
+              </a:rPr>
+              <a:t>Kết quả chính</a:t>
+            </a:r>
+          </a:p>
+        </p:txBody>
+      </p:sp>
+      <p:sp>
+        <p:nvSpPr>
+          <p:cNvPr id="6" name="">
+            <a:extLst xmlns:a="http://schemas.openxmlformats.org/drawingml/2006/main">
+              <a:ext uri="{FF2B5EF4-FFF2-40B4-BE49-F238E27FC236}">
+                <a16:creationId xmlns:a16="http://schemas.microsoft.com/office/drawing/2014/main" id="{EC55127C-CFC4-4B0D-AA75-EDBE546144B5}"/>
+              </a:ext>
+            </a:extLst>
+          </p:cNvPr>
+          <p:cNvSpPr>
+            <a:spLocks xmlns:a="http://schemas.openxmlformats.org/drawingml/2006/main" noGrp="1"/>
+          </p:cNvSpPr>
+          <p:nvPr/>
+        </p:nvSpPr>
+        <p:spPr>
+          <a:xfrm xmlns:a="http://schemas.openxmlformats.org/drawingml/2006/main">
+            <a:off x="714375" y="2000250"/>
+            <a:ext cx="10477500" cy="952500"/>
+          </a:xfrm>
+          <a:prstGeom xmlns:a="http://schemas.openxmlformats.org/drawingml/2006/main" prst="rect">
+            <a:avLst/>
+          </a:prstGeom>
+          <a:noFill xmlns:a="http://schemas.openxmlformats.org/drawingml/2006/main"/>
+          <a:ln xmlns:a="http://schemas.openxmlformats.org/drawingml/2006/main" w="0">
+            <a:noFill/>
+          </a:ln>
+        </p:spPr>
+        <p:txBody>
+          <a:bodyPr xmlns:a="http://schemas.openxmlformats.org/drawingml/2006/main" lIns="0" tIns="0" rIns="0" bIns="0" anchor="t">
+            <a:normAutofit fontScale="100000"/>
+          </a:bodyPr>
+          <a:lstStyle xmlns:a="http://schemas.openxmlformats.org/drawingml/2006/main"/>
+          <a:p xmlns:a="http://schemas.openxmlformats.org/drawingml/2006/main">
+            <a:pPr algn="l">
+              <a:lnSpc>
+                <a:spcPct val="108000"/>
+              </a:lnSpc>
+              <a:buNone/>
+              <a:defRPr sz="1725" b="0">
+                <a:solidFill>
+                  <a:srgbClr val="16202A"/>
+                </a:solidFill>
+                <a:latin typeface="Arial"/>
+                <a:ea typeface="Arial"/>
+                <a:cs typeface="Arial"/>
+              </a:defRPr>
+            </a:pPr>
+            <a:r>
+              <a:rPr sz="1725" b="0">
+                <a:solidFill>
+                  <a:srgbClr val="16202A"/>
+                </a:solidFill>
+                <a:latin typeface="Arial"/>
+                <a:ea typeface="Arial"/>
+                <a:cs typeface="Arial"/>
+              </a:rPr>
+              <a:t>HistGradientBoosting đạt MAE 15,3490 cycles trên 100 test engines; CI 95% [12,7286; 18,0866].</a:t>
+            </a:r>
+          </a:p>
+        </p:txBody>
+      </p:sp>
+      <p:sp>
+        <p:nvSpPr>
+          <p:cNvPr id="7" name="">
+            <a:extLst xmlns:a="http://schemas.openxmlformats.org/drawingml/2006/main">
+              <a:ext uri="{FF2B5EF4-FFF2-40B4-BE49-F238E27FC236}">
+                <a16:creationId xmlns:a16="http://schemas.microsoft.com/office/drawing/2014/main" id="{653970EE-1659-4F02-BFBC-75A477C76F45}"/>
+              </a:ext>
+            </a:extLst>
+          </p:cNvPr>
+          <p:cNvSpPr>
+            <a:spLocks xmlns:a="http://schemas.openxmlformats.org/drawingml/2006/main" noGrp="1"/>
+          </p:cNvSpPr>
+          <p:nvPr/>
+        </p:nvSpPr>
+        <p:spPr>
+          <a:xfrm xmlns:a="http://schemas.openxmlformats.org/drawingml/2006/main">
+            <a:off x="714375" y="3143250"/>
+            <a:ext cx="10477500" cy="304800"/>
+          </a:xfrm>
+          <a:prstGeom xmlns:a="http://schemas.openxmlformats.org/drawingml/2006/main" prst="rect">
+            <a:avLst/>
+          </a:prstGeom>
+          <a:noFill xmlns:a="http://schemas.openxmlformats.org/drawingml/2006/main"/>
+          <a:ln xmlns:a="http://schemas.openxmlformats.org/drawingml/2006/main" w="0">
+            <a:noFill/>
+          </a:ln>
+        </p:spPr>
+        <p:txBody>
+          <a:bodyPr xmlns:a="http://schemas.openxmlformats.org/drawingml/2006/main" lIns="0" tIns="0" rIns="0" bIns="0" anchor="t">
+            <a:normAutofit fontScale="100000"/>
+          </a:bodyPr>
+          <a:lstStyle xmlns:a="http://schemas.openxmlformats.org/drawingml/2006/main"/>
+          <a:p xmlns:a="http://schemas.openxmlformats.org/drawingml/2006/main">
+            <a:pPr algn="l">
+              <a:lnSpc>
+                <a:spcPct val="108000"/>
+              </a:lnSpc>
+              <a:buNone/>
+              <a:defRPr sz="1500" b="1">
+                <a:solidFill>
+                  <a:srgbClr val="1F7A8C"/>
+                </a:solidFill>
+                <a:latin typeface="Arial"/>
+                <a:ea typeface="Arial"/>
+                <a:cs typeface="Arial"/>
+              </a:defRPr>
+            </a:pPr>
+            <a:r>
+              <a:rPr sz="1500" b="1">
+                <a:solidFill>
+                  <a:srgbClr val="1F7A8C"/>
+                </a:solidFill>
+                <a:latin typeface="Arial"/>
+                <a:ea typeface="Arial"/>
+                <a:cs typeface="Arial"/>
+              </a:rPr>
+              <a:t>Giới hạn cần nhớ</a:t>
+            </a:r>
+          </a:p>
+        </p:txBody>
+      </p:sp>
+      <p:sp>
+        <p:nvSpPr>
+          <p:cNvPr id="8" name="">
+            <a:extLst xmlns:a="http://schemas.openxmlformats.org/drawingml/2006/main">
+              <a:ext uri="{FF2B5EF4-FFF2-40B4-BE49-F238E27FC236}">
+                <a16:creationId xmlns:a16="http://schemas.microsoft.com/office/drawing/2014/main" id="{76F83EF9-4987-4C1C-8CAA-7330395B3F47}"/>
+              </a:ext>
+            </a:extLst>
+          </p:cNvPr>
+          <p:cNvSpPr>
+            <a:spLocks xmlns:a="http://schemas.openxmlformats.org/drawingml/2006/main" noGrp="1"/>
+          </p:cNvSpPr>
+          <p:nvPr/>
+        </p:nvSpPr>
+        <p:spPr>
+          <a:xfrm xmlns:a="http://schemas.openxmlformats.org/drawingml/2006/main">
+            <a:off x="714375" y="3524250"/>
+            <a:ext cx="10477500" cy="1190625"/>
+          </a:xfrm>
+          <a:prstGeom xmlns:a="http://schemas.openxmlformats.org/drawingml/2006/main" prst="rect">
+            <a:avLst/>
+          </a:prstGeom>
+          <a:noFill xmlns:a="http://schemas.openxmlformats.org/drawingml/2006/main"/>
+          <a:ln xmlns:a="http://schemas.openxmlformats.org/drawingml/2006/main" w="0">
+            <a:noFill/>
+          </a:ln>
+        </p:spPr>
+        <p:txBody>
+          <a:bodyPr xmlns:a="http://schemas.openxmlformats.org/drawingml/2006/main" lIns="0" tIns="0" rIns="0" bIns="0" anchor="t">
+            <a:normAutofit fontScale="100000"/>
+          </a:bodyPr>
+          <a:lstStyle xmlns:a="http://schemas.openxmlformats.org/drawingml/2006/main"/>
+          <a:p xmlns:a="http://schemas.openxmlformats.org/drawingml/2006/main">
+            <a:pPr algn="l">
+              <a:lnSpc>
+                <a:spcPct val="108000"/>
+              </a:lnSpc>
+              <a:buNone/>
+              <a:defRPr sz="1725" b="0">
+                <a:solidFill>
+                  <a:srgbClr val="16202A"/>
+                </a:solidFill>
+                <a:latin typeface="Arial"/>
+                <a:ea typeface="Arial"/>
+                <a:cs typeface="Arial"/>
+              </a:defRPr>
+            </a:pPr>
+            <a:r>
+              <a:rPr sz="1725" b="0">
+                <a:solidFill>
+                  <a:srgbClr val="16202A"/>
+                </a:solidFill>
+                <a:latin typeface="Arial"/>
+                <a:ea typeface="Arial"/>
+                <a:cs typeface="Arial"/>
+              </a:rPr>
+              <a:t>Kết quả chính FD001 dùng window 30; ma trận transfer dùng window 10. Test chỉ đánh giá một điểm cắt mỗi engine. Đợt nested CV bổ sung chưa cải thiện các tiêu chí đã chốt.</a:t>
+            </a:r>
+          </a:p>
+        </p:txBody>
+      </p:sp>
+      <p:sp>
+        <p:nvSpPr>
+          <p:cNvPr id="9" name="">
+            <a:extLst xmlns:a="http://schemas.openxmlformats.org/drawingml/2006/main">
+              <a:ext uri="{FF2B5EF4-FFF2-40B4-BE49-F238E27FC236}">
+                <a16:creationId xmlns:a16="http://schemas.microsoft.com/office/drawing/2014/main" id="{7C24A1F4-E6E3-413F-94FB-2E76A93B71D0}"/>
+              </a:ext>
+            </a:extLst>
+          </p:cNvPr>
+          <p:cNvSpPr>
+            <a:spLocks xmlns:a="http://schemas.openxmlformats.org/drawingml/2006/main" noGrp="1"/>
+          </p:cNvSpPr>
+          <p:nvPr/>
+        </p:nvSpPr>
+        <p:spPr>
+          <a:xfrm xmlns:a="http://schemas.openxmlformats.org/drawingml/2006/main">
+            <a:off x="714375" y="4905375"/>
+            <a:ext cx="10477500" cy="304800"/>
+          </a:xfrm>
+          <a:prstGeom xmlns:a="http://schemas.openxmlformats.org/drawingml/2006/main" prst="rect">
+            <a:avLst/>
+          </a:prstGeom>
+          <a:noFill xmlns:a="http://schemas.openxmlformats.org/drawingml/2006/main"/>
+          <a:ln xmlns:a="http://schemas.openxmlformats.org/drawingml/2006/main" w="0">
+            <a:noFill/>
+          </a:ln>
+        </p:spPr>
+        <p:txBody>
+          <a:bodyPr xmlns:a="http://schemas.openxmlformats.org/drawingml/2006/main" lIns="0" tIns="0" rIns="0" bIns="0" anchor="t">
+            <a:normAutofit fontScale="100000"/>
+          </a:bodyPr>
+          <a:lstStyle xmlns:a="http://schemas.openxmlformats.org/drawingml/2006/main"/>
+          <a:p xmlns:a="http://schemas.openxmlformats.org/drawingml/2006/main">
+            <a:pPr algn="l">
+              <a:lnSpc>
+                <a:spcPct val="108000"/>
+              </a:lnSpc>
+              <a:buNone/>
+              <a:defRPr sz="1500" b="1">
+                <a:solidFill>
+                  <a:srgbClr val="1F7A8C"/>
+                </a:solidFill>
+                <a:latin typeface="Arial"/>
+                <a:ea typeface="Arial"/>
+                <a:cs typeface="Arial"/>
+              </a:defRPr>
+            </a:pPr>
+            <a:r>
+              <a:rPr sz="1500" b="1">
+                <a:solidFill>
+                  <a:srgbClr val="1F7A8C"/>
+                </a:solidFill>
+                <a:latin typeface="Arial"/>
+                <a:ea typeface="Arial"/>
+                <a:cs typeface="Arial"/>
+              </a:rPr>
+              <a:t>Bước nghiên cứu tiếp</a:t>
+            </a:r>
+          </a:p>
+        </p:txBody>
+      </p:sp>
+      <p:sp>
+        <p:nvSpPr>
+          <p:cNvPr id="10" name="">
+            <a:extLst xmlns:a="http://schemas.openxmlformats.org/drawingml/2006/main">
+              <a:ext uri="{FF2B5EF4-FFF2-40B4-BE49-F238E27FC236}">
+                <a16:creationId xmlns:a16="http://schemas.microsoft.com/office/drawing/2014/main" id="{173E1E94-CA9A-41C9-8BAD-CB1D75F4D4F1}"/>
+              </a:ext>
+            </a:extLst>
+          </p:cNvPr>
+          <p:cNvSpPr>
+            <a:spLocks xmlns:a="http://schemas.openxmlformats.org/drawingml/2006/main" noGrp="1"/>
+          </p:cNvSpPr>
+          <p:nvPr/>
+        </p:nvSpPr>
+        <p:spPr>
+          <a:xfrm xmlns:a="http://schemas.openxmlformats.org/drawingml/2006/main">
+            <a:off x="714375" y="5286375"/>
+            <a:ext cx="10477500" cy="904875"/>
+          </a:xfrm>
+          <a:prstGeom xmlns:a="http://schemas.openxmlformats.org/drawingml/2006/main" prst="rect">
+            <a:avLst/>
+          </a:prstGeom>
+          <a:noFill xmlns:a="http://schemas.openxmlformats.org/drawingml/2006/main"/>
+          <a:ln xmlns:a="http://schemas.openxmlformats.org/drawingml/2006/main" w="0">
+            <a:noFill/>
+          </a:ln>
+        </p:spPr>
+        <p:txBody>
+          <a:bodyPr xmlns:a="http://schemas.openxmlformats.org/drawingml/2006/main" lIns="0" tIns="0" rIns="0" bIns="0" anchor="t">
+            <a:normAutofit fontScale="100000"/>
+          </a:bodyPr>
+          <a:lstStyle xmlns:a="http://schemas.openxmlformats.org/drawingml/2006/main"/>
+          <a:p xmlns:a="http://schemas.openxmlformats.org/drawingml/2006/main">
+            <a:pPr algn="l">
+              <a:lnSpc>
+                <a:spcPct val="108000"/>
+              </a:lnSpc>
+              <a:buNone/>
+              <a:defRPr sz="1725" b="0">
+                <a:solidFill>
+                  <a:srgbClr val="16202A"/>
+                </a:solidFill>
+                <a:latin typeface="Arial"/>
+                <a:ea typeface="Arial"/>
+                <a:cs typeface="Arial"/>
+              </a:defRPr>
+            </a:pPr>
+            <a:r>
+              <a:rPr sz="1725" b="0">
+                <a:solidFill>
+                  <a:srgbClr val="16202A"/>
+                </a:solidFill>
+                <a:latin typeface="Arial"/>
+                <a:ea typeface="Arial"/>
+                <a:cs typeface="Arial"/>
+              </a:rPr>
+              <a:t>Chốt mức đánh đổi cho vùng RUL thấp, thử đặc trưng mới trong training fold, rồi đánh giá bằng protocol mới đã công bố trước.</a:t>
+            </a:r>
+          </a:p>
+        </p:txBody>
+      </p:sp>
+    </p:spTree>
+    <p:extLst>
+      <p:ext uri="{BB962C8B-B14F-4D97-AF65-F5344CB8AC3E}">
+        <p14:creationId xmlns:p14="http://schemas.microsoft.com/office/powerpoint/2010/main" val="1067971343"/>
+      </p:ext>
+    </p:extLst>
+  </p:cSld>
+</p:sld>
+</file>
+
+<file path=ppt/slides/slide18.xml><?xml version="1.0" encoding="utf-8"?>
+<p:sld xmlns:p="http://schemas.openxmlformats.org/presentationml/2006/main">
+  <p:cSld>
+    <p:bg>
+      <p:bgPr>
+        <a:solidFill xmlns:a="http://schemas.openxmlformats.org/drawingml/2006/main">
+          <a:srgbClr val="FFFFFF"/>
+        </a:solidFill>
+      </p:bgPr>
+    </p:bg>
+    <p:spTree>
+      <p:nvGrpSpPr>
+        <p:cNvPr id="1" name=""/>
+        <p:cNvGrpSpPr/>
+        <p:nvPr/>
+      </p:nvGrpSpPr>
+      <p:grpSpPr>
+        <a:xfrm xmlns:a="http://schemas.openxmlformats.org/drawingml/2006/main"/>
+      </p:grpSpPr>
+      <p:sp>
+        <p:nvSpPr>
+          <p:cNvPr id="8" name="">
+            <a:extLst xmlns:a="http://schemas.openxmlformats.org/drawingml/2006/main">
+              <a:ext uri="{FF2B5EF4-FFF2-40B4-BE49-F238E27FC236}">
+                <a16:creationId xmlns:a16="http://schemas.microsoft.com/office/drawing/2014/main" id="{B4FFD5B0-FC5A-4C16-B698-FC3FC6CCC76A}"/>
+              </a:ext>
+            </a:extLst>
+          </p:cNvPr>
+          <p:cNvSpPr>
+            <a:spLocks xmlns:a="http://schemas.openxmlformats.org/drawingml/2006/main" noGrp="1"/>
+          </p:cNvSpPr>
+          <p:nvPr/>
+        </p:nvSpPr>
+        <p:spPr>
+          <a:xfrm xmlns:a="http://schemas.openxmlformats.org/drawingml/2006/main">
+            <a:off x="609600" y="361950"/>
+            <a:ext cx="10953750" cy="495300"/>
+          </a:xfrm>
+          <a:prstGeom xmlns:a="http://schemas.openxmlformats.org/drawingml/2006/main" prst="rect">
+            <a:avLst/>
+          </a:prstGeom>
+          <a:noFill xmlns:a="http://schemas.openxmlformats.org/drawingml/2006/main"/>
+          <a:ln xmlns:a="http://schemas.openxmlformats.org/drawingml/2006/main" w="0">
+            <a:noFill/>
+          </a:ln>
+        </p:spPr>
+        <p:txBody>
+          <a:bodyPr xmlns:a="http://schemas.openxmlformats.org/drawingml/2006/main" lIns="0" tIns="0" rIns="0" bIns="0" anchor="t">
+            <a:normAutofit fontScale="100000"/>
+          </a:bodyPr>
+          <a:lstStyle xmlns:a="http://schemas.openxmlformats.org/drawingml/2006/main"/>
+          <a:p xmlns:a="http://schemas.openxmlformats.org/drawingml/2006/main">
+            <a:pPr algn="l">
+              <a:lnSpc>
+                <a:spcPct val="108000"/>
+              </a:lnSpc>
+              <a:buNone/>
+              <a:defRPr sz="2550" b="1">
+                <a:solidFill>
+                  <a:srgbClr val="0F243E"/>
+                </a:solidFill>
+                <a:latin typeface="Arial"/>
+                <a:ea typeface="Arial"/>
+                <a:cs typeface="Arial"/>
+              </a:defRPr>
+            </a:pPr>
+            <a:r>
+              <a:rPr sz="2550" b="1">
+                <a:solidFill>
+                  <a:srgbClr val="0F243E"/>
+                </a:solidFill>
+                <a:latin typeface="Arial"/>
+                <a:ea typeface="Arial"/>
+                <a:cs typeface="Arial"/>
+              </a:rPr>
+              <a:t>Transfer giữa các subset C-MAPSS</a:t>
+            </a:r>
+          </a:p>
+        </p:txBody>
+      </p:sp>
+      <p:sp>
+        <p:nvSpPr>
+          <p:cNvPr id="2" name="">
+            <a:extLst xmlns:a="http://schemas.openxmlformats.org/drawingml/2006/main">
+              <a:ext uri="{FF2B5EF4-FFF2-40B4-BE49-F238E27FC236}">
+                <a16:creationId xmlns:a16="http://schemas.microsoft.com/office/drawing/2014/main" id="{05C2E80A-6720-4E45-B089-FCCBA1AAE482}"/>
+              </a:ext>
+            </a:extLst>
+          </p:cNvPr>
+          <p:cNvSpPr>
+            <a:spLocks xmlns:a="http://schemas.openxmlformats.org/drawingml/2006/main" noGrp="1"/>
+          </p:cNvSpPr>
+          <p:nvPr/>
+        </p:nvSpPr>
+        <p:spPr>
+          <a:xfrm xmlns:a="http://schemas.openxmlformats.org/drawingml/2006/main">
+            <a:off x="628650" y="914400"/>
+            <a:ext cx="10858500" cy="333375"/>
+          </a:xfrm>
+          <a:prstGeom xmlns:a="http://schemas.openxmlformats.org/drawingml/2006/main" prst="rect">
+            <a:avLst/>
+          </a:prstGeom>
+          <a:noFill xmlns:a="http://schemas.openxmlformats.org/drawingml/2006/main"/>
+          <a:ln xmlns:a="http://schemas.openxmlformats.org/drawingml/2006/main" w="0">
+            <a:noFill/>
+          </a:ln>
+        </p:spPr>
+        <p:txBody>
+          <a:bodyPr xmlns:a="http://schemas.openxmlformats.org/drawingml/2006/main" lIns="0" tIns="0" rIns="0" bIns="0" anchor="t">
+            <a:normAutofit fontScale="100000"/>
+          </a:bodyPr>
+          <a:lstStyle xmlns:a="http://schemas.openxmlformats.org/drawingml/2006/main"/>
+          <a:p xmlns:a="http://schemas.openxmlformats.org/drawingml/2006/main">
+            <a:pPr algn="l">
+              <a:lnSpc>
+                <a:spcPct val="108000"/>
+              </a:lnSpc>
+              <a:buNone/>
+              <a:defRPr sz="1425" b="0">
+                <a:solidFill>
+                  <a:srgbClr val="52606D"/>
+                </a:solidFill>
+                <a:latin typeface="Arial"/>
+                <a:ea typeface="Arial"/>
+                <a:cs typeface="Arial"/>
+              </a:defRPr>
+            </a:pPr>
+            <a:r>
+              <a:rPr sz="1425" b="0">
+                <a:solidFill>
+                  <a:srgbClr val="52606D"/>
+                </a:solidFill>
+                <a:latin typeface="Arial"/>
+                <a:ea typeface="Arial"/>
+                <a:cs typeface="Arial"/>
+              </a:rPr>
+              <a:t>Window 10 cho phép giữ đủ test engines trong FD001–FD004</a:t>
+            </a:r>
+          </a:p>
+        </p:txBody>
+      </p:sp>
+      <p:sp>
+        <p:nvSpPr>
+          <p:cNvPr id="3" name="">
+            <a:extLst xmlns:a="http://schemas.openxmlformats.org/drawingml/2006/main">
+              <a:ext uri="{FF2B5EF4-FFF2-40B4-BE49-F238E27FC236}">
+                <a16:creationId xmlns:a16="http://schemas.microsoft.com/office/drawing/2014/main" id="{40BC05FE-59E6-44E6-9E89-FBD66F4D7A7B}"/>
+              </a:ext>
+            </a:extLst>
+          </p:cNvPr>
+          <p:cNvSpPr>
+            <a:spLocks xmlns:a="http://schemas.openxmlformats.org/drawingml/2006/main" noGrp="1"/>
+          </p:cNvSpPr>
+          <p:nvPr/>
+        </p:nvSpPr>
+        <p:spPr>
+          <a:xfrm xmlns:a="http://schemas.openxmlformats.org/drawingml/2006/main">
+            <a:off x="609600" y="6248400"/>
+            <a:ext cx="10287000" cy="285750"/>
+          </a:xfrm>
+          <a:prstGeom xmlns:a="http://schemas.openxmlformats.org/drawingml/2006/main" prst="rect">
+            <a:avLst/>
+          </a:prstGeom>
+          <a:noFill xmlns:a="http://schemas.openxmlformats.org/drawingml/2006/main"/>
+          <a:ln xmlns:a="http://schemas.openxmlformats.org/drawingml/2006/main" w="0">
+            <a:noFill/>
+          </a:ln>
+        </p:spPr>
+        <p:txBody>
+          <a:bodyPr xmlns:a="http://schemas.openxmlformats.org/drawingml/2006/main" lIns="0" tIns="0" rIns="0" bIns="0" anchor="t">
+            <a:normAutofit fontScale="100000"/>
+          </a:bodyPr>
+          <a:lstStyle xmlns:a="http://schemas.openxmlformats.org/drawingml/2006/main"/>
+          <a:p xmlns:a="http://schemas.openxmlformats.org/drawingml/2006/main">
+            <a:pPr algn="l">
+              <a:lnSpc>
+                <a:spcPct val="108000"/>
+              </a:lnSpc>
+              <a:buNone/>
+              <a:defRPr sz="900" b="0">
+                <a:solidFill>
+                  <a:srgbClr val="52606D"/>
+                </a:solidFill>
+                <a:latin typeface="Arial"/>
+                <a:ea typeface="Arial"/>
+                <a:cs typeface="Arial"/>
+              </a:defRPr>
+            </a:pPr>
+            <a:r>
+              <a:rPr sz="900" b="0">
+                <a:solidFill>
+                  <a:srgbClr val="52606D"/>
+                </a:solidFill>
+                <a:latin typeface="Arial"/>
+                <a:ea typeface="Arial"/>
+                <a:cs typeface="Arial"/>
+              </a:rPr>
+              <a:t>Nguồn: outputs/cross_dataset/matrix.json; outputs/cross_dataset/README.md</a:t>
+            </a:r>
+          </a:p>
+        </p:txBody>
+      </p:sp>
+      <p:sp>
+        <p:nvSpPr>
+          <p:cNvPr id="4" name="">
+            <a:extLst xmlns:a="http://schemas.openxmlformats.org/drawingml/2006/main">
+              <a:ext uri="{FF2B5EF4-FFF2-40B4-BE49-F238E27FC236}">
+                <a16:creationId xmlns:a16="http://schemas.microsoft.com/office/drawing/2014/main" id="{796323EF-344A-43AF-9649-CF11804C2B71}"/>
+              </a:ext>
+            </a:extLst>
+          </p:cNvPr>
+          <p:cNvSpPr>
+            <a:spLocks xmlns:a="http://schemas.openxmlformats.org/drawingml/2006/main" noGrp="1"/>
+          </p:cNvSpPr>
+          <p:nvPr/>
+        </p:nvSpPr>
+        <p:spPr>
+          <a:xfrm xmlns:a="http://schemas.openxmlformats.org/drawingml/2006/main">
+            <a:off x="11096625" y="6391275"/>
+            <a:ext cx="476250" cy="238125"/>
+          </a:xfrm>
+          <a:prstGeom xmlns:a="http://schemas.openxmlformats.org/drawingml/2006/main" prst="rect">
+            <a:avLst/>
+          </a:prstGeom>
+          <a:noFill xmlns:a="http://schemas.openxmlformats.org/drawingml/2006/main"/>
+          <a:ln xmlns:a="http://schemas.openxmlformats.org/drawingml/2006/main" w="0">
+            <a:noFill/>
+          </a:ln>
+        </p:spPr>
+        <p:txBody>
+          <a:bodyPr xmlns:a="http://schemas.openxmlformats.org/drawingml/2006/main" lIns="0" tIns="0" rIns="0" bIns="0" anchor="t">
+            <a:normAutofit fontScale="100000"/>
+          </a:bodyPr>
+          <a:lstStyle xmlns:a="http://schemas.openxmlformats.org/drawingml/2006/main"/>
+          <a:p xmlns:a="http://schemas.openxmlformats.org/drawingml/2006/main">
+            <a:pPr algn="r">
+              <a:lnSpc>
+                <a:spcPct val="108000"/>
+              </a:lnSpc>
+              <a:buNone/>
+              <a:defRPr sz="1050" b="1">
+                <a:solidFill>
+                  <a:srgbClr val="52606D"/>
+                </a:solidFill>
+                <a:latin typeface="Arial"/>
+                <a:ea typeface="Arial"/>
+                <a:cs typeface="Arial"/>
+              </a:defRPr>
+            </a:pPr>
+            <a:r>
+              <a:rPr sz="1050" b="1">
+                <a:solidFill>
+                  <a:srgbClr val="52606D"/>
+                </a:solidFill>
+                <a:latin typeface="Arial"/>
+                <a:ea typeface="Arial"/>
+                <a:cs typeface="Arial"/>
+              </a:rPr>
+              <a:t>18</a:t>
             </a:r>
           </a:p>
         </p:txBody>
@@ -6446,7 +8967,7 @@
           <p:cNvPr id="6" name="">
             <a:extLst xmlns:a="http://schemas.openxmlformats.org/drawingml/2006/main">
               <a:ext uri="{FF2B5EF4-FFF2-40B4-BE49-F238E27FC236}">
-                <a16:creationId xmlns:a16="http://schemas.microsoft.com/office/drawing/2014/main" id="{1C635397-6341-4BA3-8E2F-395FE1488502}"/>
+                <a16:creationId xmlns:a16="http://schemas.microsoft.com/office/drawing/2014/main" id="{4864DE71-7875-4CF9-863B-BA5B52F6F6B3}"/>
               </a:ext>
             </a:extLst>
           </p:cNvPr>
@@ -6507,7 +9028,7 @@
           <p:cNvPr id="7" name="">
             <a:extLst xmlns:a="http://schemas.openxmlformats.org/drawingml/2006/main">
               <a:ext uri="{FF2B5EF4-FFF2-40B4-BE49-F238E27FC236}">
-                <a16:creationId xmlns:a16="http://schemas.microsoft.com/office/drawing/2014/main" id="{3E041642-F391-4432-B54E-D9176B6265B4}"/>
+                <a16:creationId xmlns:a16="http://schemas.microsoft.com/office/drawing/2014/main" id="{520178CD-CACA-4C48-90CF-07ACD6C5182C}"/>
               </a:ext>
             </a:extLst>
           </p:cNvPr>
@@ -6566,7 +9087,7 @@
     </p:spTree>
     <p:extLst>
       <p:ext uri="{BB962C8B-B14F-4D97-AF65-F5344CB8AC3E}">
-        <p14:creationId xmlns:p14="http://schemas.microsoft.com/office/powerpoint/2010/main" val="1439848869"/>
+        <p14:creationId xmlns:p14="http://schemas.microsoft.com/office/powerpoint/2010/main" val="429167047"/>
       </p:ext>
     </p:extLst>
   </p:cSld>
@@ -6597,7 +9118,7 @@
           <p:cNvPr id="11" name="">
             <a:extLst xmlns:a="http://schemas.openxmlformats.org/drawingml/2006/main">
               <a:ext uri="{FF2B5EF4-FFF2-40B4-BE49-F238E27FC236}">
-                <a16:creationId xmlns:a16="http://schemas.microsoft.com/office/drawing/2014/main" id="{A9C4FDF0-9279-4ECB-A371-0F1AA45A9A49}"/>
+                <a16:creationId xmlns:a16="http://schemas.microsoft.com/office/drawing/2014/main" id="{0C13A50A-D47C-41A7-845F-29B08513C4A0}"/>
               </a:ext>
             </a:extLst>
           </p:cNvPr>
@@ -6658,7 +9179,7 @@
           <p:cNvPr id="2" name="">
             <a:extLst xmlns:a="http://schemas.openxmlformats.org/drawingml/2006/main">
               <a:ext uri="{FF2B5EF4-FFF2-40B4-BE49-F238E27FC236}">
-                <a16:creationId xmlns:a16="http://schemas.microsoft.com/office/drawing/2014/main" id="{B61716AB-362C-45AE-8796-B58DF26F0A40}"/>
+                <a16:creationId xmlns:a16="http://schemas.microsoft.com/office/drawing/2014/main" id="{E37B7722-6877-49FB-B4B4-E30F6C2BAE24}"/>
               </a:ext>
             </a:extLst>
           </p:cNvPr>
@@ -6719,7 +9240,7 @@
           <p:cNvPr id="3" name="">
             <a:extLst xmlns:a="http://schemas.openxmlformats.org/drawingml/2006/main">
               <a:ext uri="{FF2B5EF4-FFF2-40B4-BE49-F238E27FC236}">
-                <a16:creationId xmlns:a16="http://schemas.microsoft.com/office/drawing/2014/main" id="{756085EA-F839-430E-AB46-9A63708C56BC}"/>
+                <a16:creationId xmlns:a16="http://schemas.microsoft.com/office/drawing/2014/main" id="{9C0FE028-CBEB-4676-B49B-004AC9F140C2}"/>
               </a:ext>
             </a:extLst>
           </p:cNvPr>
@@ -6780,7 +9301,7 @@
           <p:cNvPr id="4" name="">
             <a:extLst xmlns:a="http://schemas.openxmlformats.org/drawingml/2006/main">
               <a:ext uri="{FF2B5EF4-FFF2-40B4-BE49-F238E27FC236}">
-                <a16:creationId xmlns:a16="http://schemas.microsoft.com/office/drawing/2014/main" id="{CBA50FFD-AC04-4237-A751-E5A9A1A452F2}"/>
+                <a16:creationId xmlns:a16="http://schemas.microsoft.com/office/drawing/2014/main" id="{8411D093-FE7E-4CE2-B146-E28306519CB7}"/>
               </a:ext>
             </a:extLst>
           </p:cNvPr>
@@ -6841,7 +9362,7 @@
           <p:cNvPr id="5" name="">
             <a:extLst xmlns:a="http://schemas.openxmlformats.org/drawingml/2006/main">
               <a:ext uri="{FF2B5EF4-FFF2-40B4-BE49-F238E27FC236}">
-                <a16:creationId xmlns:a16="http://schemas.microsoft.com/office/drawing/2014/main" id="{9D47D0E5-2F79-4E44-A891-17C4DE4A1301}"/>
+                <a16:creationId xmlns:a16="http://schemas.microsoft.com/office/drawing/2014/main" id="{0A4D98CB-B6F1-4F22-BEFE-E2C8826055F9}"/>
               </a:ext>
             </a:extLst>
           </p:cNvPr>
@@ -6902,7 +9423,7 @@
           <p:cNvPr id="6" name="">
             <a:extLst xmlns:a="http://schemas.openxmlformats.org/drawingml/2006/main">
               <a:ext uri="{FF2B5EF4-FFF2-40B4-BE49-F238E27FC236}">
-                <a16:creationId xmlns:a16="http://schemas.microsoft.com/office/drawing/2014/main" id="{6C7164A7-43ED-4D0A-A482-17E145CC49AD}"/>
+                <a16:creationId xmlns:a16="http://schemas.microsoft.com/office/drawing/2014/main" id="{E46BBF7F-B03C-4070-BEE2-E151454091B1}"/>
               </a:ext>
             </a:extLst>
           </p:cNvPr>
@@ -6963,7 +9484,7 @@
           <p:cNvPr id="7" name="">
             <a:extLst xmlns:a="http://schemas.openxmlformats.org/drawingml/2006/main">
               <a:ext uri="{FF2B5EF4-FFF2-40B4-BE49-F238E27FC236}">
-                <a16:creationId xmlns:a16="http://schemas.microsoft.com/office/drawing/2014/main" id="{10897DDD-72E1-488B-8B0E-D9D523068338}"/>
+                <a16:creationId xmlns:a16="http://schemas.microsoft.com/office/drawing/2014/main" id="{C656E694-DFE8-43AC-8A74-BE241EC39633}"/>
               </a:ext>
             </a:extLst>
           </p:cNvPr>
@@ -7024,7 +9545,7 @@
           <p:cNvPr id="8" name="">
             <a:extLst xmlns:a="http://schemas.openxmlformats.org/drawingml/2006/main">
               <a:ext uri="{FF2B5EF4-FFF2-40B4-BE49-F238E27FC236}">
-                <a16:creationId xmlns:a16="http://schemas.microsoft.com/office/drawing/2014/main" id="{CEC72960-3AAB-4F6D-9E5D-0518B97F1877}"/>
+                <a16:creationId xmlns:a16="http://schemas.microsoft.com/office/drawing/2014/main" id="{FF579DFC-F8D3-4670-8CD0-A6559439BCED}"/>
               </a:ext>
             </a:extLst>
           </p:cNvPr>
@@ -7085,7 +9606,7 @@
           <p:cNvPr id="9" name="">
             <a:extLst xmlns:a="http://schemas.openxmlformats.org/drawingml/2006/main">
               <a:ext uri="{FF2B5EF4-FFF2-40B4-BE49-F238E27FC236}">
-                <a16:creationId xmlns:a16="http://schemas.microsoft.com/office/drawing/2014/main" id="{1622549A-210B-4C71-B6CE-D14D38BE98A5}"/>
+                <a16:creationId xmlns:a16="http://schemas.microsoft.com/office/drawing/2014/main" id="{9989521F-ACCB-4F1E-B4A4-E8E6A31384B3}"/>
               </a:ext>
             </a:extLst>
           </p:cNvPr>
@@ -7146,7 +9667,7 @@
           <p:cNvPr id="10" name="">
             <a:extLst xmlns:a="http://schemas.openxmlformats.org/drawingml/2006/main">
               <a:ext uri="{FF2B5EF4-FFF2-40B4-BE49-F238E27FC236}">
-                <a16:creationId xmlns:a16="http://schemas.microsoft.com/office/drawing/2014/main" id="{E8AE8DC1-DE0E-4457-9CF5-F05C9C0371C9}"/>
+                <a16:creationId xmlns:a16="http://schemas.microsoft.com/office/drawing/2014/main" id="{148196E8-687A-4F0F-BDAF-C084EB6DA55F}"/>
               </a:ext>
             </a:extLst>
           </p:cNvPr>
@@ -7205,7 +9726,7 @@
     </p:spTree>
     <p:extLst>
       <p:ext uri="{BB962C8B-B14F-4D97-AF65-F5344CB8AC3E}">
-        <p14:creationId xmlns:p14="http://schemas.microsoft.com/office/powerpoint/2010/main" val="597405302"/>
+        <p14:creationId xmlns:p14="http://schemas.microsoft.com/office/powerpoint/2010/main" val="1285167433"/>
       </p:ext>
     </p:extLst>
   </p:cSld>
@@ -7236,7 +9757,7 @@
           <p:cNvPr id="8" name="">
             <a:extLst xmlns:a="http://schemas.openxmlformats.org/drawingml/2006/main">
               <a:ext uri="{FF2B5EF4-FFF2-40B4-BE49-F238E27FC236}">
-                <a16:creationId xmlns:a16="http://schemas.microsoft.com/office/drawing/2014/main" id="{69DFB66A-E7BE-4EF9-A2DE-9D5CA81DDA91}"/>
+                <a16:creationId xmlns:a16="http://schemas.microsoft.com/office/drawing/2014/main" id="{58BA8F71-A922-423C-85D7-D73E89FB174A}"/>
               </a:ext>
             </a:extLst>
           </p:cNvPr>
@@ -7297,7 +9818,7 @@
           <p:cNvPr id="2" name="">
             <a:extLst xmlns:a="http://schemas.openxmlformats.org/drawingml/2006/main">
               <a:ext uri="{FF2B5EF4-FFF2-40B4-BE49-F238E27FC236}">
-                <a16:creationId xmlns:a16="http://schemas.microsoft.com/office/drawing/2014/main" id="{CF07B2AA-B348-4C85-9552-CE61463D1BD7}"/>
+                <a16:creationId xmlns:a16="http://schemas.microsoft.com/office/drawing/2014/main" id="{82D4D4BE-689C-4696-A358-3DCC26D56316}"/>
               </a:ext>
             </a:extLst>
           </p:cNvPr>
@@ -7358,7 +9879,7 @@
           <p:cNvPr id="3" name="">
             <a:extLst xmlns:a="http://schemas.openxmlformats.org/drawingml/2006/main">
               <a:ext uri="{FF2B5EF4-FFF2-40B4-BE49-F238E27FC236}">
-                <a16:creationId xmlns:a16="http://schemas.microsoft.com/office/drawing/2014/main" id="{503D5ABD-EF39-434F-BB8F-81DDCA3FD040}"/>
+                <a16:creationId xmlns:a16="http://schemas.microsoft.com/office/drawing/2014/main" id="{3DB052B9-0DDC-4E63-B06F-E1D173BF96D4}"/>
               </a:ext>
             </a:extLst>
           </p:cNvPr>
@@ -7419,7 +9940,7 @@
           <p:cNvPr id="4" name="">
             <a:extLst xmlns:a="http://schemas.openxmlformats.org/drawingml/2006/main">
               <a:ext uri="{FF2B5EF4-FFF2-40B4-BE49-F238E27FC236}">
-                <a16:creationId xmlns:a16="http://schemas.microsoft.com/office/drawing/2014/main" id="{DB663E2B-4F54-4E27-B6AE-1312B5BE617D}"/>
+                <a16:creationId xmlns:a16="http://schemas.microsoft.com/office/drawing/2014/main" id="{6F2DE2EE-8785-4F73-9A03-BCAD10B7B3D5}"/>
               </a:ext>
             </a:extLst>
           </p:cNvPr>
@@ -7766,7 +10287,7 @@
           <p:cNvPr id="6" name="">
             <a:extLst xmlns:a="http://schemas.openxmlformats.org/drawingml/2006/main">
               <a:ext uri="{FF2B5EF4-FFF2-40B4-BE49-F238E27FC236}">
-                <a16:creationId xmlns:a16="http://schemas.microsoft.com/office/drawing/2014/main" id="{A1BAE9A4-0320-4C30-BB1A-C1FA65468EF3}"/>
+                <a16:creationId xmlns:a16="http://schemas.microsoft.com/office/drawing/2014/main" id="{8261D291-5364-40C2-B560-3238CF4E27EC}"/>
               </a:ext>
             </a:extLst>
           </p:cNvPr>
@@ -7827,7 +10348,7 @@
           <p:cNvPr id="7" name="">
             <a:extLst xmlns:a="http://schemas.openxmlformats.org/drawingml/2006/main">
               <a:ext uri="{FF2B5EF4-FFF2-40B4-BE49-F238E27FC236}">
-                <a16:creationId xmlns:a16="http://schemas.microsoft.com/office/drawing/2014/main" id="{AED3838C-0901-43E0-965B-F53FBFF61F3E}"/>
+                <a16:creationId xmlns:a16="http://schemas.microsoft.com/office/drawing/2014/main" id="{62CFE674-7886-4C2D-8A5D-B51660FA3B43}"/>
               </a:ext>
             </a:extLst>
           </p:cNvPr>
@@ -7886,7 +10407,7 @@
     </p:spTree>
     <p:extLst>
       <p:ext uri="{BB962C8B-B14F-4D97-AF65-F5344CB8AC3E}">
-        <p14:creationId xmlns:p14="http://schemas.microsoft.com/office/powerpoint/2010/main" val="976751183"/>
+        <p14:creationId xmlns:p14="http://schemas.microsoft.com/office/powerpoint/2010/main" val="1101579237"/>
       </p:ext>
     </p:extLst>
   </p:cSld>
@@ -7917,7 +10438,7 @@
           <p:cNvPr id="7" name="">
             <a:extLst xmlns:a="http://schemas.openxmlformats.org/drawingml/2006/main">
               <a:ext uri="{FF2B5EF4-FFF2-40B4-BE49-F238E27FC236}">
-                <a16:creationId xmlns:a16="http://schemas.microsoft.com/office/drawing/2014/main" id="{D9611D70-030D-4995-AE96-73815025C357}"/>
+                <a16:creationId xmlns:a16="http://schemas.microsoft.com/office/drawing/2014/main" id="{230F45D1-6A22-4189-88A8-137A629DAF7E}"/>
               </a:ext>
             </a:extLst>
           </p:cNvPr>
@@ -7978,7 +10499,7 @@
           <p:cNvPr id="2" name="">
             <a:extLst xmlns:a="http://schemas.openxmlformats.org/drawingml/2006/main">
               <a:ext uri="{FF2B5EF4-FFF2-40B4-BE49-F238E27FC236}">
-                <a16:creationId xmlns:a16="http://schemas.microsoft.com/office/drawing/2014/main" id="{4E1C7A2F-206C-46B1-90FA-1D8197F0E41C}"/>
+                <a16:creationId xmlns:a16="http://schemas.microsoft.com/office/drawing/2014/main" id="{CDBBD5EF-C747-45E2-A974-A618B8003A20}"/>
               </a:ext>
             </a:extLst>
           </p:cNvPr>
@@ -8039,7 +10560,7 @@
           <p:cNvPr id="3" name="">
             <a:extLst xmlns:a="http://schemas.openxmlformats.org/drawingml/2006/main">
               <a:ext uri="{FF2B5EF4-FFF2-40B4-BE49-F238E27FC236}">
-                <a16:creationId xmlns:a16="http://schemas.microsoft.com/office/drawing/2014/main" id="{3D572CD0-9CF5-41DF-8023-16DD739C730F}"/>
+                <a16:creationId xmlns:a16="http://schemas.microsoft.com/office/drawing/2014/main" id="{E15B49A3-F91B-433D-99A3-B055EA6206F1}"/>
               </a:ext>
             </a:extLst>
           </p:cNvPr>
@@ -8100,7 +10621,7 @@
           <p:cNvPr id="4" name="">
             <a:extLst xmlns:a="http://schemas.openxmlformats.org/drawingml/2006/main">
               <a:ext uri="{FF2B5EF4-FFF2-40B4-BE49-F238E27FC236}">
-                <a16:creationId xmlns:a16="http://schemas.microsoft.com/office/drawing/2014/main" id="{AB0C4625-2182-482D-99AA-1964E12B5497}"/>
+                <a16:creationId xmlns:a16="http://schemas.microsoft.com/office/drawing/2014/main" id="{47282B42-D659-4ABD-8A55-E57845B6EBBE}"/>
               </a:ext>
             </a:extLst>
           </p:cNvPr>
@@ -8165,7 +10686,7 @@
           <p:nvPr/>
         </p:nvPicPr>
         <p:blipFill>
-          <a:blip xmlns:r="http://schemas.openxmlformats.org/officeDocument/2006/relationships" xmlns:a="http://schemas.openxmlformats.org/drawingml/2006/main" r:embed="R042c4ebeb7f24bf0"/>
+          <a:blip xmlns:r="http://schemas.openxmlformats.org/officeDocument/2006/relationships" xmlns:a="http://schemas.openxmlformats.org/drawingml/2006/main" r:embed="R53fac2c85f5c461d"/>
           <a:stretch xmlns:a="http://schemas.openxmlformats.org/drawingml/2006/main"/>
         </p:blipFill>
         <p:spPr>
@@ -8183,7 +10704,7 @@
           <p:cNvPr id="6" name="">
             <a:extLst xmlns:a="http://schemas.openxmlformats.org/drawingml/2006/main">
               <a:ext uri="{FF2B5EF4-FFF2-40B4-BE49-F238E27FC236}">
-                <a16:creationId xmlns:a16="http://schemas.microsoft.com/office/drawing/2014/main" id="{EFC78CC4-0E83-4D4F-8B95-1DDCE7011BC4}"/>
+                <a16:creationId xmlns:a16="http://schemas.microsoft.com/office/drawing/2014/main" id="{3970CAE4-C079-4871-BAF4-04985044C3D8}"/>
               </a:ext>
             </a:extLst>
           </p:cNvPr>
@@ -8242,7 +10763,7 @@
     </p:spTree>
     <p:extLst>
       <p:ext uri="{BB962C8B-B14F-4D97-AF65-F5344CB8AC3E}">
-        <p14:creationId xmlns:p14="http://schemas.microsoft.com/office/powerpoint/2010/main" val="677232483"/>
+        <p14:creationId xmlns:p14="http://schemas.microsoft.com/office/powerpoint/2010/main" val="1254508175"/>
       </p:ext>
     </p:extLst>
   </p:cSld>
@@ -8273,7 +10794,7 @@
           <p:cNvPr id="11" name="">
             <a:extLst xmlns:a="http://schemas.openxmlformats.org/drawingml/2006/main">
               <a:ext uri="{FF2B5EF4-FFF2-40B4-BE49-F238E27FC236}">
-                <a16:creationId xmlns:a16="http://schemas.microsoft.com/office/drawing/2014/main" id="{6D821554-4CBA-4072-9CFC-521ED2029A46}"/>
+                <a16:creationId xmlns:a16="http://schemas.microsoft.com/office/drawing/2014/main" id="{A3028D6A-D079-4346-BF37-2546CA652E2E}"/>
               </a:ext>
             </a:extLst>
           </p:cNvPr>
@@ -8334,7 +10855,7 @@
           <p:cNvPr id="2" name="">
             <a:extLst xmlns:a="http://schemas.openxmlformats.org/drawingml/2006/main">
               <a:ext uri="{FF2B5EF4-FFF2-40B4-BE49-F238E27FC236}">
-                <a16:creationId xmlns:a16="http://schemas.microsoft.com/office/drawing/2014/main" id="{9EF05C5B-053C-48DB-B6A9-E4CE6861DCA0}"/>
+                <a16:creationId xmlns:a16="http://schemas.microsoft.com/office/drawing/2014/main" id="{5860E559-E756-4BA9-AEA0-A16D2A1DC321}"/>
               </a:ext>
             </a:extLst>
           </p:cNvPr>
@@ -8395,7 +10916,7 @@
           <p:cNvPr id="3" name="">
             <a:extLst xmlns:a="http://schemas.openxmlformats.org/drawingml/2006/main">
               <a:ext uri="{FF2B5EF4-FFF2-40B4-BE49-F238E27FC236}">
-                <a16:creationId xmlns:a16="http://schemas.microsoft.com/office/drawing/2014/main" id="{374A5669-4972-4341-9ACB-126CB2085617}"/>
+                <a16:creationId xmlns:a16="http://schemas.microsoft.com/office/drawing/2014/main" id="{9724B6FE-551E-4F5A-903E-C2A81145C152}"/>
               </a:ext>
             </a:extLst>
           </p:cNvPr>
@@ -8456,7 +10977,7 @@
           <p:cNvPr id="4" name="">
             <a:extLst xmlns:a="http://schemas.openxmlformats.org/drawingml/2006/main">
               <a:ext uri="{FF2B5EF4-FFF2-40B4-BE49-F238E27FC236}">
-                <a16:creationId xmlns:a16="http://schemas.microsoft.com/office/drawing/2014/main" id="{50BA85C3-82E3-4C64-A64B-136C8A427E8A}"/>
+                <a16:creationId xmlns:a16="http://schemas.microsoft.com/office/drawing/2014/main" id="{9D9A1C4D-9B04-4180-8AFB-95D31B6C20F4}"/>
               </a:ext>
             </a:extLst>
           </p:cNvPr>
@@ -8517,7 +11038,7 @@
           <p:cNvPr id="5" name="">
             <a:extLst xmlns:a="http://schemas.openxmlformats.org/drawingml/2006/main">
               <a:ext uri="{FF2B5EF4-FFF2-40B4-BE49-F238E27FC236}">
-                <a16:creationId xmlns:a16="http://schemas.microsoft.com/office/drawing/2014/main" id="{19542E8F-A2F6-4E5C-9BA2-B08D58398FE5}"/>
+                <a16:creationId xmlns:a16="http://schemas.microsoft.com/office/drawing/2014/main" id="{5F1A93D1-EF27-47CC-B089-3CB2251F507A}"/>
               </a:ext>
             </a:extLst>
           </p:cNvPr>
@@ -8578,7 +11099,7 @@
           <p:cNvPr id="6" name="">
             <a:extLst xmlns:a="http://schemas.openxmlformats.org/drawingml/2006/main">
               <a:ext uri="{FF2B5EF4-FFF2-40B4-BE49-F238E27FC236}">
-                <a16:creationId xmlns:a16="http://schemas.microsoft.com/office/drawing/2014/main" id="{5C27D9CB-6097-4582-9827-E6E8D431E6DF}"/>
+                <a16:creationId xmlns:a16="http://schemas.microsoft.com/office/drawing/2014/main" id="{AD834AEA-86FA-4A5B-96F6-CFB08E963E69}"/>
               </a:ext>
             </a:extLst>
           </p:cNvPr>
@@ -8639,7 +11160,7 @@
           <p:cNvPr id="7" name="">
             <a:extLst xmlns:a="http://schemas.openxmlformats.org/drawingml/2006/main">
               <a:ext uri="{FF2B5EF4-FFF2-40B4-BE49-F238E27FC236}">
-                <a16:creationId xmlns:a16="http://schemas.microsoft.com/office/drawing/2014/main" id="{AFFC4F4B-A62C-4B90-83F5-246389EB8436}"/>
+                <a16:creationId xmlns:a16="http://schemas.microsoft.com/office/drawing/2014/main" id="{EC9D7850-6F8E-4A41-B776-F69C2969E9C4}"/>
               </a:ext>
             </a:extLst>
           </p:cNvPr>
@@ -8700,7 +11221,7 @@
           <p:cNvPr id="8" name="">
             <a:extLst xmlns:a="http://schemas.openxmlformats.org/drawingml/2006/main">
               <a:ext uri="{FF2B5EF4-FFF2-40B4-BE49-F238E27FC236}">
-                <a16:creationId xmlns:a16="http://schemas.microsoft.com/office/drawing/2014/main" id="{20FD73D1-67B5-445A-99BE-085F9EEBF486}"/>
+                <a16:creationId xmlns:a16="http://schemas.microsoft.com/office/drawing/2014/main" id="{0A4C1958-4471-4756-BDA1-0E7010FC8523}"/>
               </a:ext>
             </a:extLst>
           </p:cNvPr>
@@ -8761,7 +11282,7 @@
           <p:cNvPr id="9" name="">
             <a:extLst xmlns:a="http://schemas.openxmlformats.org/drawingml/2006/main">
               <a:ext uri="{FF2B5EF4-FFF2-40B4-BE49-F238E27FC236}">
-                <a16:creationId xmlns:a16="http://schemas.microsoft.com/office/drawing/2014/main" id="{A936411A-FF74-40D3-A143-B80870CF7AE0}"/>
+                <a16:creationId xmlns:a16="http://schemas.microsoft.com/office/drawing/2014/main" id="{3DD107CC-37C6-4E52-BC3D-31D5DE8E4604}"/>
               </a:ext>
             </a:extLst>
           </p:cNvPr>
@@ -8822,7 +11343,7 @@
           <p:cNvPr id="10" name="">
             <a:extLst xmlns:a="http://schemas.openxmlformats.org/drawingml/2006/main">
               <a:ext uri="{FF2B5EF4-FFF2-40B4-BE49-F238E27FC236}">
-                <a16:creationId xmlns:a16="http://schemas.microsoft.com/office/drawing/2014/main" id="{F7A66050-B5C2-417C-969F-659ADB3B7E0E}"/>
+                <a16:creationId xmlns:a16="http://schemas.microsoft.com/office/drawing/2014/main" id="{9481FA4F-2ECA-45EF-9D21-C249A6641605}"/>
               </a:ext>
             </a:extLst>
           </p:cNvPr>
@@ -8881,7 +11402,7 @@
     </p:spTree>
     <p:extLst>
       <p:ext uri="{BB962C8B-B14F-4D97-AF65-F5344CB8AC3E}">
-        <p14:creationId xmlns:p14="http://schemas.microsoft.com/office/powerpoint/2010/main" val="1232194741"/>
+        <p14:creationId xmlns:p14="http://schemas.microsoft.com/office/powerpoint/2010/main" val="2124503018"/>
       </p:ext>
     </p:extLst>
   </p:cSld>
@@ -8912,7 +11433,7 @@
           <p:cNvPr id="8" name="">
             <a:extLst xmlns:a="http://schemas.openxmlformats.org/drawingml/2006/main">
               <a:ext uri="{FF2B5EF4-FFF2-40B4-BE49-F238E27FC236}">
-                <a16:creationId xmlns:a16="http://schemas.microsoft.com/office/drawing/2014/main" id="{FAE5628F-01EC-42A8-9625-5EEEC96078D9}"/>
+                <a16:creationId xmlns:a16="http://schemas.microsoft.com/office/drawing/2014/main" id="{21241308-23AD-44D5-BCC5-D8C6AD6F16DC}"/>
               </a:ext>
             </a:extLst>
           </p:cNvPr>
@@ -8973,7 +11494,7 @@
           <p:cNvPr id="2" name="">
             <a:extLst xmlns:a="http://schemas.openxmlformats.org/drawingml/2006/main">
               <a:ext uri="{FF2B5EF4-FFF2-40B4-BE49-F238E27FC236}">
-                <a16:creationId xmlns:a16="http://schemas.microsoft.com/office/drawing/2014/main" id="{C731E7B0-0816-47E0-8485-FDBA4B5F65DB}"/>
+                <a16:creationId xmlns:a16="http://schemas.microsoft.com/office/drawing/2014/main" id="{0D69001E-8C4B-4830-B934-AF2EA3A77EB3}"/>
               </a:ext>
             </a:extLst>
           </p:cNvPr>
@@ -9034,7 +11555,7 @@
           <p:cNvPr id="3" name="">
             <a:extLst xmlns:a="http://schemas.openxmlformats.org/drawingml/2006/main">
               <a:ext uri="{FF2B5EF4-FFF2-40B4-BE49-F238E27FC236}">
-                <a16:creationId xmlns:a16="http://schemas.microsoft.com/office/drawing/2014/main" id="{F4D76DDF-2A2C-49EC-9276-FD89F883991A}"/>
+                <a16:creationId xmlns:a16="http://schemas.microsoft.com/office/drawing/2014/main" id="{87F1760F-8791-49D6-B548-EEB43EF93D88}"/>
               </a:ext>
             </a:extLst>
           </p:cNvPr>
@@ -9095,7 +11616,7 @@
           <p:cNvPr id="4" name="">
             <a:extLst xmlns:a="http://schemas.openxmlformats.org/drawingml/2006/main">
               <a:ext uri="{FF2B5EF4-FFF2-40B4-BE49-F238E27FC236}">
-                <a16:creationId xmlns:a16="http://schemas.microsoft.com/office/drawing/2014/main" id="{6E046EAF-89CF-4A96-AC8B-BBC8CF2EEE61}"/>
+                <a16:creationId xmlns:a16="http://schemas.microsoft.com/office/drawing/2014/main" id="{62C3F336-0F35-4947-BFBF-B6BDACBEBD23}"/>
               </a:ext>
             </a:extLst>
           </p:cNvPr>
@@ -9156,7 +11677,7 @@
           <p:cNvPr id="5" name="">
             <a:extLst xmlns:a="http://schemas.openxmlformats.org/drawingml/2006/main">
               <a:ext uri="{FF2B5EF4-FFF2-40B4-BE49-F238E27FC236}">
-                <a16:creationId xmlns:a16="http://schemas.microsoft.com/office/drawing/2014/main" id="{34F66F11-B38D-46D2-96D3-0EA678E96092}"/>
+                <a16:creationId xmlns:a16="http://schemas.microsoft.com/office/drawing/2014/main" id="{F2A1008A-DEE9-41E2-8D47-1D8DD283ECC6}"/>
               </a:ext>
             </a:extLst>
           </p:cNvPr>
@@ -9415,7 +11936,7 @@
           <p:cNvPr id="7" name="">
             <a:extLst xmlns:a="http://schemas.openxmlformats.org/drawingml/2006/main">
               <a:ext uri="{FF2B5EF4-FFF2-40B4-BE49-F238E27FC236}">
-                <a16:creationId xmlns:a16="http://schemas.microsoft.com/office/drawing/2014/main" id="{76D93644-761A-49B2-96F2-38BC946417A9}"/>
+                <a16:creationId xmlns:a16="http://schemas.microsoft.com/office/drawing/2014/main" id="{E951A141-F664-41A4-B0DA-9F9E35DF4A20}"/>
               </a:ext>
             </a:extLst>
           </p:cNvPr>
@@ -9474,7 +11995,7 @@
     </p:spTree>
     <p:extLst>
       <p:ext uri="{BB962C8B-B14F-4D97-AF65-F5344CB8AC3E}">
-        <p14:creationId xmlns:p14="http://schemas.microsoft.com/office/powerpoint/2010/main" val="608422282"/>
+        <p14:creationId xmlns:p14="http://schemas.microsoft.com/office/powerpoint/2010/main" val="586915372"/>
       </p:ext>
     </p:extLst>
   </p:cSld>
@@ -9505,7 +12026,7 @@
           <p:cNvPr id="7" name="">
             <a:extLst xmlns:a="http://schemas.openxmlformats.org/drawingml/2006/main">
               <a:ext uri="{FF2B5EF4-FFF2-40B4-BE49-F238E27FC236}">
-                <a16:creationId xmlns:a16="http://schemas.microsoft.com/office/drawing/2014/main" id="{6B4974DC-BD99-4B67-B5E4-42BFD36EEA21}"/>
+                <a16:creationId xmlns:a16="http://schemas.microsoft.com/office/drawing/2014/main" id="{C4961E67-C7DB-40C6-8D17-AAA2A7648579}"/>
               </a:ext>
             </a:extLst>
           </p:cNvPr>
@@ -9566,7 +12087,7 @@
           <p:cNvPr id="2" name="">
             <a:extLst xmlns:a="http://schemas.openxmlformats.org/drawingml/2006/main">
               <a:ext uri="{FF2B5EF4-FFF2-40B4-BE49-F238E27FC236}">
-                <a16:creationId xmlns:a16="http://schemas.microsoft.com/office/drawing/2014/main" id="{175AE5EA-76BA-49AE-9F7E-A04AEA7DD883}"/>
+                <a16:creationId xmlns:a16="http://schemas.microsoft.com/office/drawing/2014/main" id="{E228F13A-AE52-4C02-8823-6196DF40CDE1}"/>
               </a:ext>
             </a:extLst>
           </p:cNvPr>
@@ -9627,7 +12148,7 @@
           <p:cNvPr id="3" name="">
             <a:extLst xmlns:a="http://schemas.openxmlformats.org/drawingml/2006/main">
               <a:ext uri="{FF2B5EF4-FFF2-40B4-BE49-F238E27FC236}">
-                <a16:creationId xmlns:a16="http://schemas.microsoft.com/office/drawing/2014/main" id="{733BEEEA-4621-4058-AC78-8C7E8B557E59}"/>
+                <a16:creationId xmlns:a16="http://schemas.microsoft.com/office/drawing/2014/main" id="{24EB219C-33F5-40DC-A874-65DEF8C3CC9D}"/>
               </a:ext>
             </a:extLst>
           </p:cNvPr>
@@ -9688,7 +12209,7 @@
           <p:cNvPr id="4" name="">
             <a:extLst xmlns:a="http://schemas.openxmlformats.org/drawingml/2006/main">
               <a:ext uri="{FF2B5EF4-FFF2-40B4-BE49-F238E27FC236}">
-                <a16:creationId xmlns:a16="http://schemas.microsoft.com/office/drawing/2014/main" id="{7FD0F2CE-82BD-4EB5-9D35-527F7D323AF3}"/>
+                <a16:creationId xmlns:a16="http://schemas.microsoft.com/office/drawing/2014/main" id="{971212AE-D60F-4F2A-B8D2-91AA24E7911F}"/>
               </a:ext>
             </a:extLst>
           </p:cNvPr>
@@ -10032,7 +12553,7 @@
           <p:cNvPr id="6" name="">
             <a:extLst xmlns:a="http://schemas.openxmlformats.org/drawingml/2006/main">
               <a:ext uri="{FF2B5EF4-FFF2-40B4-BE49-F238E27FC236}">
-                <a16:creationId xmlns:a16="http://schemas.microsoft.com/office/drawing/2014/main" id="{99798F67-8B70-497B-AE0D-693585E3996B}"/>
+                <a16:creationId xmlns:a16="http://schemas.microsoft.com/office/drawing/2014/main" id="{1EBA7936-CAA8-42EC-808C-1AC9CB46D25A}"/>
               </a:ext>
             </a:extLst>
           </p:cNvPr>
@@ -10091,7 +12612,7 @@
     </p:spTree>
     <p:extLst>
       <p:ext uri="{BB962C8B-B14F-4D97-AF65-F5344CB8AC3E}">
-        <p14:creationId xmlns:p14="http://schemas.microsoft.com/office/powerpoint/2010/main" val="14629851"/>
+        <p14:creationId xmlns:p14="http://schemas.microsoft.com/office/powerpoint/2010/main" val="49524413"/>
       </p:ext>
     </p:extLst>
   </p:cSld>
@@ -10122,7 +12643,7 @@
           <p:cNvPr id="7" name="">
             <a:extLst xmlns:a="http://schemas.openxmlformats.org/drawingml/2006/main">
               <a:ext uri="{FF2B5EF4-FFF2-40B4-BE49-F238E27FC236}">
-                <a16:creationId xmlns:a16="http://schemas.microsoft.com/office/drawing/2014/main" id="{F61E4469-8EF0-44E9-937F-1EB74E7C07D8}"/>
+                <a16:creationId xmlns:a16="http://schemas.microsoft.com/office/drawing/2014/main" id="{E9FCE2D7-29A4-4DF5-A53F-13479D1FCE1C}"/>
               </a:ext>
             </a:extLst>
           </p:cNvPr>
@@ -10183,7 +12704,7 @@
           <p:cNvPr id="2" name="">
             <a:extLst xmlns:a="http://schemas.openxmlformats.org/drawingml/2006/main">
               <a:ext uri="{FF2B5EF4-FFF2-40B4-BE49-F238E27FC236}">
-                <a16:creationId xmlns:a16="http://schemas.microsoft.com/office/drawing/2014/main" id="{72351F19-5E87-445D-8286-2A7BF61E943C}"/>
+                <a16:creationId xmlns:a16="http://schemas.microsoft.com/office/drawing/2014/main" id="{2921E09C-BD91-4878-B4BD-A3A4B2137691}"/>
               </a:ext>
             </a:extLst>
           </p:cNvPr>
@@ -10244,7 +12765,7 @@
           <p:cNvPr id="3" name="">
             <a:extLst xmlns:a="http://schemas.openxmlformats.org/drawingml/2006/main">
               <a:ext uri="{FF2B5EF4-FFF2-40B4-BE49-F238E27FC236}">
-                <a16:creationId xmlns:a16="http://schemas.microsoft.com/office/drawing/2014/main" id="{A98D7951-0E9B-4E04-90A0-54F4D5F16C21}"/>
+                <a16:creationId xmlns:a16="http://schemas.microsoft.com/office/drawing/2014/main" id="{7C6DAD0E-62F1-41D1-96D5-7848A91A3B21}"/>
               </a:ext>
             </a:extLst>
           </p:cNvPr>
@@ -10305,7 +12826,7 @@
           <p:cNvPr id="4" name="">
             <a:extLst xmlns:a="http://schemas.openxmlformats.org/drawingml/2006/main">
               <a:ext uri="{FF2B5EF4-FFF2-40B4-BE49-F238E27FC236}">
-                <a16:creationId xmlns:a16="http://schemas.microsoft.com/office/drawing/2014/main" id="{E9F6EA56-0E73-4F7B-A307-BAFFA1323B97}"/>
+                <a16:creationId xmlns:a16="http://schemas.microsoft.com/office/drawing/2014/main" id="{D9019912-2753-4173-9CD9-5DCF60E62D2B}"/>
               </a:ext>
             </a:extLst>
           </p:cNvPr>
@@ -10649,7 +13170,7 @@
           <p:cNvPr id="6" name="">
             <a:extLst xmlns:a="http://schemas.openxmlformats.org/drawingml/2006/main">
               <a:ext uri="{FF2B5EF4-FFF2-40B4-BE49-F238E27FC236}">
-                <a16:creationId xmlns:a16="http://schemas.microsoft.com/office/drawing/2014/main" id="{C1A430E5-DEE5-4273-96DC-394C87177D90}"/>
+                <a16:creationId xmlns:a16="http://schemas.microsoft.com/office/drawing/2014/main" id="{BE9C087C-45DB-495F-9A2D-CA0C3ECE1E67}"/>
               </a:ext>
             </a:extLst>
           </p:cNvPr>
@@ -10708,7 +13229,7 @@
     </p:spTree>
     <p:extLst>
       <p:ext uri="{BB962C8B-B14F-4D97-AF65-F5344CB8AC3E}">
-        <p14:creationId xmlns:p14="http://schemas.microsoft.com/office/powerpoint/2010/main" val="686932504"/>
+        <p14:creationId xmlns:p14="http://schemas.microsoft.com/office/powerpoint/2010/main" val="82840649"/>
       </p:ext>
     </p:extLst>
   </p:cSld>
@@ -10739,7 +13260,7 @@
           <p:cNvPr id="13" name="">
             <a:extLst xmlns:a="http://schemas.openxmlformats.org/drawingml/2006/main">
               <a:ext uri="{FF2B5EF4-FFF2-40B4-BE49-F238E27FC236}">
-                <a16:creationId xmlns:a16="http://schemas.microsoft.com/office/drawing/2014/main" id="{21AFC943-C7EB-4C35-BD59-BF1E09AE217E}"/>
+                <a16:creationId xmlns:a16="http://schemas.microsoft.com/office/drawing/2014/main" id="{6B963BBE-2042-4EE3-85E2-909941347AD4}"/>
               </a:ext>
             </a:extLst>
           </p:cNvPr>
@@ -10800,7 +13321,7 @@
           <p:cNvPr id="2" name="">
             <a:extLst xmlns:a="http://schemas.openxmlformats.org/drawingml/2006/main">
               <a:ext uri="{FF2B5EF4-FFF2-40B4-BE49-F238E27FC236}">
-                <a16:creationId xmlns:a16="http://schemas.microsoft.com/office/drawing/2014/main" id="{480EE7D2-7020-42B8-B2E4-D862970B4CDB}"/>
+                <a16:creationId xmlns:a16="http://schemas.microsoft.com/office/drawing/2014/main" id="{6F13F3B1-A368-441E-8058-8080A57EC7C7}"/>
               </a:ext>
             </a:extLst>
           </p:cNvPr>
@@ -10861,7 +13382,7 @@
           <p:cNvPr id="3" name="">
             <a:extLst xmlns:a="http://schemas.openxmlformats.org/drawingml/2006/main">
               <a:ext uri="{FF2B5EF4-FFF2-40B4-BE49-F238E27FC236}">
-                <a16:creationId xmlns:a16="http://schemas.microsoft.com/office/drawing/2014/main" id="{8BC898CD-CAED-43D1-9DF3-1A67EE8242E3}"/>
+                <a16:creationId xmlns:a16="http://schemas.microsoft.com/office/drawing/2014/main" id="{AAC3A780-70DC-4CE0-B534-3C9E362CF711}"/>
               </a:ext>
             </a:extLst>
           </p:cNvPr>
@@ -10922,7 +13443,7 @@
           <p:cNvPr id="4" name="">
             <a:extLst xmlns:a="http://schemas.openxmlformats.org/drawingml/2006/main">
               <a:ext uri="{FF2B5EF4-FFF2-40B4-BE49-F238E27FC236}">
-                <a16:creationId xmlns:a16="http://schemas.microsoft.com/office/drawing/2014/main" id="{6008105B-5168-46C6-B37F-8C0DE6270C3D}"/>
+                <a16:creationId xmlns:a16="http://schemas.microsoft.com/office/drawing/2014/main" id="{729988E6-402D-4051-8D9A-BBEC26D11169}"/>
               </a:ext>
             </a:extLst>
           </p:cNvPr>
@@ -10987,7 +13508,7 @@
           <p:nvPr/>
         </p:nvPicPr>
         <p:blipFill>
-          <a:blip xmlns:r="http://schemas.openxmlformats.org/officeDocument/2006/relationships" xmlns:a="http://schemas.openxmlformats.org/drawingml/2006/main" r:embed="Reda9afbcf3de4152"/>
+          <a:blip xmlns:r="http://schemas.openxmlformats.org/officeDocument/2006/relationships" xmlns:a="http://schemas.openxmlformats.org/drawingml/2006/main" r:embed="Rad5e71cdda8e4e59"/>
           <a:stretch xmlns:a="http://schemas.openxmlformats.org/drawingml/2006/main"/>
         </p:blipFill>
         <p:spPr>
@@ -11005,7 +13526,7 @@
           <p:cNvPr id="6" name="">
             <a:extLst xmlns:a="http://schemas.openxmlformats.org/drawingml/2006/main">
               <a:ext uri="{FF2B5EF4-FFF2-40B4-BE49-F238E27FC236}">
-                <a16:creationId xmlns:a16="http://schemas.microsoft.com/office/drawing/2014/main" id="{4E433CE7-5655-43C6-B7DA-D72ED83A3206}"/>
+                <a16:creationId xmlns:a16="http://schemas.microsoft.com/office/drawing/2014/main" id="{0FAE0A82-A779-41A6-8FF0-9BA00CC86B1B}"/>
               </a:ext>
             </a:extLst>
           </p:cNvPr>
@@ -11066,7 +13587,7 @@
           <p:cNvPr id="7" name="">
             <a:extLst xmlns:a="http://schemas.openxmlformats.org/drawingml/2006/main">
               <a:ext uri="{FF2B5EF4-FFF2-40B4-BE49-F238E27FC236}">
-                <a16:creationId xmlns:a16="http://schemas.microsoft.com/office/drawing/2014/main" id="{BB06C5C1-5ABB-474C-A597-009C6B0753BD}"/>
+                <a16:creationId xmlns:a16="http://schemas.microsoft.com/office/drawing/2014/main" id="{2A2D7CB0-F39C-459F-B037-BF77E9A5CDBE}"/>
               </a:ext>
             </a:extLst>
           </p:cNvPr>
@@ -11127,7 +13648,7 @@
           <p:cNvPr id="8" name="">
             <a:extLst xmlns:a="http://schemas.openxmlformats.org/drawingml/2006/main">
               <a:ext uri="{FF2B5EF4-FFF2-40B4-BE49-F238E27FC236}">
-                <a16:creationId xmlns:a16="http://schemas.microsoft.com/office/drawing/2014/main" id="{AFCDE639-AC35-458B-8906-29A7E7B91AC8}"/>
+                <a16:creationId xmlns:a16="http://schemas.microsoft.com/office/drawing/2014/main" id="{67832740-CE4C-430F-A071-2C58795DF31F}"/>
               </a:ext>
             </a:extLst>
           </p:cNvPr>
@@ -11188,7 +13709,7 @@
           <p:cNvPr id="9" name="">
             <a:extLst xmlns:a="http://schemas.openxmlformats.org/drawingml/2006/main">
               <a:ext uri="{FF2B5EF4-FFF2-40B4-BE49-F238E27FC236}">
-                <a16:creationId xmlns:a16="http://schemas.microsoft.com/office/drawing/2014/main" id="{2E0BE064-4464-4F15-AC53-AA57782DD044}"/>
+                <a16:creationId xmlns:a16="http://schemas.microsoft.com/office/drawing/2014/main" id="{FA8E304F-7452-4D35-9AE2-68809C0E2EA8}"/>
               </a:ext>
             </a:extLst>
           </p:cNvPr>
@@ -11249,7 +13770,7 @@
           <p:cNvPr id="10" name="">
             <a:extLst xmlns:a="http://schemas.openxmlformats.org/drawingml/2006/main">
               <a:ext uri="{FF2B5EF4-FFF2-40B4-BE49-F238E27FC236}">
-                <a16:creationId xmlns:a16="http://schemas.microsoft.com/office/drawing/2014/main" id="{FB5ED898-8BDF-4967-A9B8-7AC9783BEAC7}"/>
+                <a16:creationId xmlns:a16="http://schemas.microsoft.com/office/drawing/2014/main" id="{8B98C818-703F-423A-9707-F5C70E2D844B}"/>
               </a:ext>
             </a:extLst>
           </p:cNvPr>
@@ -11310,7 +13831,7 @@
           <p:cNvPr id="11" name="">
             <a:extLst xmlns:a="http://schemas.openxmlformats.org/drawingml/2006/main">
               <a:ext uri="{FF2B5EF4-FFF2-40B4-BE49-F238E27FC236}">
-                <a16:creationId xmlns:a16="http://schemas.microsoft.com/office/drawing/2014/main" id="{48F8AA08-0789-4990-B456-80B050A61852}"/>
+                <a16:creationId xmlns:a16="http://schemas.microsoft.com/office/drawing/2014/main" id="{87191DBA-5968-4E28-AEB1-174F5B135096}"/>
               </a:ext>
             </a:extLst>
           </p:cNvPr>
@@ -11371,7 +13892,7 @@
           <p:cNvPr id="12" name="">
             <a:extLst xmlns:a="http://schemas.openxmlformats.org/drawingml/2006/main">
               <a:ext uri="{FF2B5EF4-FFF2-40B4-BE49-F238E27FC236}">
-                <a16:creationId xmlns:a16="http://schemas.microsoft.com/office/drawing/2014/main" id="{7A42E2B8-7D0D-4D83-AFDE-D89564CBB0B7}"/>
+                <a16:creationId xmlns:a16="http://schemas.microsoft.com/office/drawing/2014/main" id="{E49C109F-2709-468D-BE62-5AD8CBAE84E3}"/>
               </a:ext>
             </a:extLst>
           </p:cNvPr>
@@ -11430,7 +13951,7 @@
     </p:spTree>
     <p:extLst>
       <p:ext uri="{BB962C8B-B14F-4D97-AF65-F5344CB8AC3E}">
-        <p14:creationId xmlns:p14="http://schemas.microsoft.com/office/powerpoint/2010/main" val="394356863"/>
+        <p14:creationId xmlns:p14="http://schemas.microsoft.com/office/powerpoint/2010/main" val="1895487725"/>
       </p:ext>
     </p:extLst>
   </p:cSld>
@@ -11478,16 +13999,16 @@
         <a:srgbClr val="96607D"/>
       </a:folHlink>
     </a:clrScheme>
-    <a:fontScheme name="">
+    <a:fontScheme name="Office">
       <a:majorFont>
-        <a:latin typeface="Aptos"/>
-        <a:ea typeface=""/>
-        <a:cs typeface=""/>
+        <a:latin typeface="Calibri Light"/>
+        <a:ea typeface="Calibri Light"/>
+        <a:cs typeface="Calibri Light"/>
       </a:majorFont>
       <a:minorFont>
-        <a:latin typeface="Aptos"/>
-        <a:ea typeface=""/>
-        <a:cs typeface=""/>
+        <a:latin typeface="Calibri"/>
+        <a:ea typeface="Calibri"/>
+        <a:cs typeface="Calibri"/>
       </a:minorFont>
     </a:fontScheme>
     <a:fmtScheme name="ChatGPT">

</xml_diff>

<commit_message>
docs(report): document data flow and enforce deliverable limits
Document the implemented data boundaries, joins, feature columns, relationships, and Big Data scope. Rebuild the report below 50 pages and keep the current presentation within the 20-slide limit while preserving reproducibility details outside the main PDF.

---

Bổ sung walkthrough về boundary dữ liệu, phép join, feature columns, quan hệ và phạm vi Big Data đã triển khai. Biên dịch lại báo cáo dưới 50 trang và giữ bộ trình bày hiện tại trong giới hạn 20 slide; các chi tiết tái lập vẫn được giữ ở source và handoff ngoài PDF chính.
</commit_message>
<xml_diff>
--- a/slides/cmapss_fd001_presentation.pptx
+++ b/slides/cmapss_fd001_presentation.pptx
@@ -2,30 +2,30 @@
 <file path=ppt/presentation.xml><?xml version="1.0" encoding="utf-8"?>
 <p:presentation xmlns:p="http://schemas.openxmlformats.org/presentationml/2006/main">
   <p:sldMasterIdLst>
-    <p:sldMasterId xmlns:r="http://schemas.openxmlformats.org/officeDocument/2006/relationships" id="2147483648" r:id="Re58b5c0bddde4125"/>
+    <p:sldMasterId xmlns:r="http://schemas.openxmlformats.org/officeDocument/2006/relationships" id="2147483648" r:id="R9b770b8641a24b7f"/>
   </p:sldMasterIdLst>
   <p:notesMasterIdLst>
-    <p:notesMasterId xmlns:r="http://schemas.openxmlformats.org/officeDocument/2006/relationships" r:id="Rcd79f44ee7704b31"/>
+    <p:notesMasterId xmlns:r="http://schemas.openxmlformats.org/officeDocument/2006/relationships" r:id="R22b105e163074564"/>
   </p:notesMasterIdLst>
   <p:sldIdLst>
-    <p:sldId xmlns:r="http://schemas.openxmlformats.org/officeDocument/2006/relationships" id="256" r:id="R943f942bb23f4e94"/>
-    <p:sldId xmlns:r="http://schemas.openxmlformats.org/officeDocument/2006/relationships" id="257" r:id="Rf42a1872f4154377"/>
-    <p:sldId xmlns:r="http://schemas.openxmlformats.org/officeDocument/2006/relationships" id="258" r:id="R35381d84789240f2"/>
-    <p:sldId xmlns:r="http://schemas.openxmlformats.org/officeDocument/2006/relationships" id="259" r:id="R5a6575d339c64d7a"/>
-    <p:sldId xmlns:r="http://schemas.openxmlformats.org/officeDocument/2006/relationships" id="260" r:id="Rd45e7be1017442a3"/>
-    <p:sldId xmlns:r="http://schemas.openxmlformats.org/officeDocument/2006/relationships" id="261" r:id="R2fb9a20b1a5c4455"/>
-    <p:sldId xmlns:r="http://schemas.openxmlformats.org/officeDocument/2006/relationships" id="262" r:id="R9b39a2a8e8924994"/>
-    <p:sldId xmlns:r="http://schemas.openxmlformats.org/officeDocument/2006/relationships" id="263" r:id="R9ae74660e8724962"/>
-    <p:sldId xmlns:r="http://schemas.openxmlformats.org/officeDocument/2006/relationships" id="264" r:id="R78cafa76bc6d4b51"/>
-    <p:sldId xmlns:r="http://schemas.openxmlformats.org/officeDocument/2006/relationships" id="265" r:id="R244f7aa264284356"/>
-    <p:sldId xmlns:r="http://schemas.openxmlformats.org/officeDocument/2006/relationships" id="266" r:id="R4ed2ce06188a4eb1"/>
-    <p:sldId xmlns:r="http://schemas.openxmlformats.org/officeDocument/2006/relationships" id="267" r:id="R717877d64f884085"/>
-    <p:sldId xmlns:r="http://schemas.openxmlformats.org/officeDocument/2006/relationships" id="268" r:id="R41eb0ad303b64bf2"/>
-    <p:sldId xmlns:r="http://schemas.openxmlformats.org/officeDocument/2006/relationships" id="269" r:id="R70524e69980341a7"/>
-    <p:sldId xmlns:r="http://schemas.openxmlformats.org/officeDocument/2006/relationships" id="270" r:id="R756a1a46ee4c498c"/>
-    <p:sldId xmlns:r="http://schemas.openxmlformats.org/officeDocument/2006/relationships" id="271" r:id="R1f5f99211f604516"/>
-    <p:sldId xmlns:r="http://schemas.openxmlformats.org/officeDocument/2006/relationships" id="272" r:id="Rd399195afe8147d0"/>
-    <p:sldId xmlns:r="http://schemas.openxmlformats.org/officeDocument/2006/relationships" id="273" r:id="Rc6704c059d6d4683"/>
+    <p:sldId xmlns:r="http://schemas.openxmlformats.org/officeDocument/2006/relationships" id="256" r:id="Ref5e4058000d41ef"/>
+    <p:sldId xmlns:r="http://schemas.openxmlformats.org/officeDocument/2006/relationships" id="257" r:id="Rfa51e09a5847494d"/>
+    <p:sldId xmlns:r="http://schemas.openxmlformats.org/officeDocument/2006/relationships" id="258" r:id="R98a2c8f1364c42f1"/>
+    <p:sldId xmlns:r="http://schemas.openxmlformats.org/officeDocument/2006/relationships" id="259" r:id="R5f9cba5f17764ba4"/>
+    <p:sldId xmlns:r="http://schemas.openxmlformats.org/officeDocument/2006/relationships" id="260" r:id="R7866a504d8014dfc"/>
+    <p:sldId xmlns:r="http://schemas.openxmlformats.org/officeDocument/2006/relationships" id="261" r:id="Ra99c4673049d4ff1"/>
+    <p:sldId xmlns:r="http://schemas.openxmlformats.org/officeDocument/2006/relationships" id="262" r:id="R253171194a3c4f71"/>
+    <p:sldId xmlns:r="http://schemas.openxmlformats.org/officeDocument/2006/relationships" id="263" r:id="Ra8055d244e4d488f"/>
+    <p:sldId xmlns:r="http://schemas.openxmlformats.org/officeDocument/2006/relationships" id="264" r:id="R04dc8f3bdb574c1e"/>
+    <p:sldId xmlns:r="http://schemas.openxmlformats.org/officeDocument/2006/relationships" id="265" r:id="Ra8337fd2f3db4750"/>
+    <p:sldId xmlns:r="http://schemas.openxmlformats.org/officeDocument/2006/relationships" id="266" r:id="Rcde03451423b4e36"/>
+    <p:sldId xmlns:r="http://schemas.openxmlformats.org/officeDocument/2006/relationships" id="267" r:id="Rff579a557e3841b0"/>
+    <p:sldId xmlns:r="http://schemas.openxmlformats.org/officeDocument/2006/relationships" id="268" r:id="Rf1ea90faec7f4021"/>
+    <p:sldId xmlns:r="http://schemas.openxmlformats.org/officeDocument/2006/relationships" id="269" r:id="R6e37013cdb534b8a"/>
+    <p:sldId xmlns:r="http://schemas.openxmlformats.org/officeDocument/2006/relationships" id="270" r:id="R0fe72f273acf4ac0"/>
+    <p:sldId xmlns:r="http://schemas.openxmlformats.org/officeDocument/2006/relationships" id="271" r:id="R6e0a3a6e4c0f4ac8"/>
+    <p:sldId xmlns:r="http://schemas.openxmlformats.org/officeDocument/2006/relationships" id="272" r:id="R93233fb774f94e54"/>
+    <p:sldId xmlns:r="http://schemas.openxmlformats.org/officeDocument/2006/relationships" id="273" r:id="R9c04e813fef746a3"/>
   </p:sldIdLst>
   <p:sldSz cx="12192000" cy="6858000"/>
   <p:notesSz cx="6858000" cy="9144000"/>
@@ -215,16 +215,16 @@
         <a:srgbClr val="96607D"/>
       </a:folHlink>
     </a:clrScheme>
-    <a:fontScheme name="Office">
+    <a:fontScheme name="">
       <a:majorFont>
-        <a:latin typeface="Calibri Light"/>
-        <a:ea typeface="Calibri Light"/>
-        <a:cs typeface="Calibri Light"/>
+        <a:latin typeface="Aptos"/>
+        <a:ea typeface=""/>
+        <a:cs typeface=""/>
       </a:majorFont>
       <a:minorFont>
-        <a:latin typeface="Calibri"/>
-        <a:ea typeface="Calibri"/>
-        <a:cs typeface="Calibri"/>
+        <a:latin typeface="Aptos"/>
+        <a:ea typeface=""/>
+        <a:cs typeface=""/>
       </a:minorFont>
     </a:fontScheme>
     <a:fmtScheme name="ChatGPT">
@@ -1299,7 +1299,7 @@
           <a:lstStyle xmlns:a="http://schemas.openxmlformats.org/drawingml/2006/main"/>
           <a:p xmlns:a="http://schemas.openxmlformats.org/drawingml/2006/main">
             <a:r>
-              <a:t>Đọc sơ đồ từ trái sang phải. Raw được kiểm tra schema và khóa, ETL ghi Silver/Gold, rolling features dùng lịch sử của từng engine, GroupKFold chọn model, final evaluation ghép nhãn test ở bước cuối. Nhánh Health Index là phân tích phụ. Nguồn hình: assets/diagrams/fd001-pipeline.png.</a:t>
+              <a:t>Đọc sơ đồ từ trái sang phải. Trong một subset, reader đọc train/test cùng schema, thêm split rồi union theo dòng. Silver giữ observations typed trong Parquet; SQLite chỉ có engine_summary và train_targets. Rolling features dùng lịch sử của từng engine, GroupKFold chọn model, final evaluation ghép nhãn test ở bước cuối. PySpark hiện tái hiện ETL local để parity; chưa có query engine trên Parquet, Airflow hoặc Power BI.</a:t>
             </a:r>
           </a:p>
         </p:txBody>
@@ -1439,7 +1439,7 @@
           <a:lstStyle xmlns:a="http://schemas.openxmlformats.org/drawingml/2006/main"/>
           <a:p xmlns:a="http://schemas.openxmlformats.org/drawingml/2006/main">
             <a:r>
-              <a:t>Window dài 30. Ví dụ tại cycle 170 dùng 141–170, không dùng 171. Với mỗi trong 21 sensor, tính last, mean, standard deviation, min, max, slope. Tổng 126 đặc trưng. Artifact hiện có 27.927 window. Không nối window qua hai engine.</a:t>
+              <a:t>Window dài 30. Ví dụ tại cycle 170 dùng 141–170, không dùng 171. Với mỗi trong 21 sensor, tính last, mean, standard deviation, min, max, slope. Tổng 126 đặc trưng. Artifact hiện có 27.927 window. Observation và feature dùng cùng khóa; modeling join feature với train target one-to-one. Ba setting không đưa vào X của model RUL. Không nối window qua hai engine.</a:t>
             </a:r>
           </a:p>
         </p:txBody>
@@ -1717,7 +1717,7 @@
   </p:cSld>
   <p:clrMap bg1="lt1" tx1="dk1" bg2="lt2" tx2="dk2" accent1="accent1" accent2="accent2" accent3="accent3" accent4="accent4" accent5="accent5" accent6="accent6" hlink="hlink" folHlink="folHlink"/>
   <p:sldLayoutIdLst>
-    <p:sldLayoutId xmlns:r="http://schemas.openxmlformats.org/officeDocument/2006/relationships" id="2147483649" r:id="Re41c164fe7e74f1a"/>
+    <p:sldLayoutId xmlns:r="http://schemas.openxmlformats.org/officeDocument/2006/relationships" id="2147483649" r:id="R23a877c3ffd14d1a"/>
   </p:sldLayoutIdLst>
   <p:txStyles>
     <p:titleStyle>
@@ -2040,16 +2040,16 @@
         <a:srgbClr val="96607D"/>
       </a:folHlink>
     </a:clrScheme>
-    <a:fontScheme name="Office">
+    <a:fontScheme name="">
       <a:majorFont>
-        <a:latin typeface="Calibri Light"/>
-        <a:ea typeface="Calibri Light"/>
-        <a:cs typeface="Calibri Light"/>
+        <a:latin typeface="Aptos"/>
+        <a:ea typeface=""/>
+        <a:cs typeface=""/>
       </a:majorFont>
       <a:minorFont>
-        <a:latin typeface="Calibri"/>
-        <a:ea typeface="Calibri"/>
-        <a:cs typeface="Calibri"/>
+        <a:latin typeface="Aptos"/>
+        <a:ea typeface=""/>
+        <a:cs typeface=""/>
       </a:minorFont>
     </a:fontScheme>
     <a:fmtScheme name="ChatGPT">
@@ -2268,7 +2268,7 @@
           <p:cNvPr id="5" name="">
             <a:extLst xmlns:a="http://schemas.openxmlformats.org/drawingml/2006/main">
               <a:ext uri="{FF2B5EF4-FFF2-40B4-BE49-F238E27FC236}">
-                <a16:creationId xmlns:a16="http://schemas.microsoft.com/office/drawing/2014/main" id="{591BE462-9FA0-45FD-979B-4D3032FB84FF}"/>
+                <a16:creationId xmlns:a16="http://schemas.microsoft.com/office/drawing/2014/main" id="{820BAF43-6BF8-444F-B768-F9877AFC1B85}"/>
               </a:ext>
             </a:extLst>
           </p:cNvPr>
@@ -2329,7 +2329,7 @@
           <p:cNvPr id="2" name="">
             <a:extLst xmlns:a="http://schemas.openxmlformats.org/drawingml/2006/main">
               <a:ext uri="{FF2B5EF4-FFF2-40B4-BE49-F238E27FC236}">
-                <a16:creationId xmlns:a16="http://schemas.microsoft.com/office/drawing/2014/main" id="{788FEA61-D633-4599-B032-C746A875AEAC}"/>
+                <a16:creationId xmlns:a16="http://schemas.microsoft.com/office/drawing/2014/main" id="{D7DC8F3F-453D-492A-AEE1-59EF636127CE}"/>
               </a:ext>
             </a:extLst>
           </p:cNvPr>
@@ -2390,7 +2390,7 @@
           <p:cNvPr id="3" name="">
             <a:extLst xmlns:a="http://schemas.openxmlformats.org/drawingml/2006/main">
               <a:ext uri="{FF2B5EF4-FFF2-40B4-BE49-F238E27FC236}">
-                <a16:creationId xmlns:a16="http://schemas.microsoft.com/office/drawing/2014/main" id="{8154D036-4F90-4FAC-81C6-058551F233EE}"/>
+                <a16:creationId xmlns:a16="http://schemas.microsoft.com/office/drawing/2014/main" id="{38663B2D-7857-4970-A631-663AB3739ABF}"/>
               </a:ext>
             </a:extLst>
           </p:cNvPr>
@@ -2451,7 +2451,7 @@
           <p:cNvPr id="4" name="">
             <a:extLst xmlns:a="http://schemas.openxmlformats.org/drawingml/2006/main">
               <a:ext uri="{FF2B5EF4-FFF2-40B4-BE49-F238E27FC236}">
-                <a16:creationId xmlns:a16="http://schemas.microsoft.com/office/drawing/2014/main" id="{105A829B-F7DE-47C0-AE60-B15984C20EDC}"/>
+                <a16:creationId xmlns:a16="http://schemas.microsoft.com/office/drawing/2014/main" id="{6C096419-1B36-47AA-BC99-C896FE40E8BE}"/>
               </a:ext>
             </a:extLst>
           </p:cNvPr>
@@ -2510,7 +2510,7 @@
     </p:spTree>
     <p:extLst>
       <p:ext uri="{BB962C8B-B14F-4D97-AF65-F5344CB8AC3E}">
-        <p14:creationId xmlns:p14="http://schemas.microsoft.com/office/powerpoint/2010/main" val="2147292593"/>
+        <p14:creationId xmlns:p14="http://schemas.microsoft.com/office/powerpoint/2010/main" val="1526597498"/>
       </p:ext>
     </p:extLst>
   </p:cSld>
@@ -2541,7 +2541,7 @@
           <p:cNvPr id="11" name="">
             <a:extLst xmlns:a="http://schemas.openxmlformats.org/drawingml/2006/main">
               <a:ext uri="{FF2B5EF4-FFF2-40B4-BE49-F238E27FC236}">
-                <a16:creationId xmlns:a16="http://schemas.microsoft.com/office/drawing/2014/main" id="{0B7B2763-2B1C-49A2-8210-19EB93D6623E}"/>
+                <a16:creationId xmlns:a16="http://schemas.microsoft.com/office/drawing/2014/main" id="{A5ECBB1B-BE9F-42EE-8943-1E1A9D55B8A7}"/>
               </a:ext>
             </a:extLst>
           </p:cNvPr>
@@ -2602,7 +2602,7 @@
           <p:cNvPr id="2" name="">
             <a:extLst xmlns:a="http://schemas.openxmlformats.org/drawingml/2006/main">
               <a:ext uri="{FF2B5EF4-FFF2-40B4-BE49-F238E27FC236}">
-                <a16:creationId xmlns:a16="http://schemas.microsoft.com/office/drawing/2014/main" id="{F382C42A-C11B-456B-92D5-4B0E2FDB1312}"/>
+                <a16:creationId xmlns:a16="http://schemas.microsoft.com/office/drawing/2014/main" id="{3F8BBEDD-B69B-4E00-BB5E-36D3A1B8A584}"/>
               </a:ext>
             </a:extLst>
           </p:cNvPr>
@@ -2663,7 +2663,7 @@
           <p:cNvPr id="3" name="">
             <a:extLst xmlns:a="http://schemas.openxmlformats.org/drawingml/2006/main">
               <a:ext uri="{FF2B5EF4-FFF2-40B4-BE49-F238E27FC236}">
-                <a16:creationId xmlns:a16="http://schemas.microsoft.com/office/drawing/2014/main" id="{BE352025-3334-416E-8AFE-7DDA1E1B2C1E}"/>
+                <a16:creationId xmlns:a16="http://schemas.microsoft.com/office/drawing/2014/main" id="{898EAAAC-6276-467E-9511-3AADCE0A4431}"/>
               </a:ext>
             </a:extLst>
           </p:cNvPr>
@@ -2724,7 +2724,7 @@
           <p:cNvPr id="4" name="">
             <a:extLst xmlns:a="http://schemas.openxmlformats.org/drawingml/2006/main">
               <a:ext uri="{FF2B5EF4-FFF2-40B4-BE49-F238E27FC236}">
-                <a16:creationId xmlns:a16="http://schemas.microsoft.com/office/drawing/2014/main" id="{B958C523-A7B3-45E7-A69A-0AC5FDDD9A1D}"/>
+                <a16:creationId xmlns:a16="http://schemas.microsoft.com/office/drawing/2014/main" id="{6E2772D2-B940-488C-9F6F-2E9CF91E299F}"/>
               </a:ext>
             </a:extLst>
           </p:cNvPr>
@@ -2789,7 +2789,7 @@
           <p:nvPr/>
         </p:nvPicPr>
         <p:blipFill>
-          <a:blip xmlns:r="http://schemas.openxmlformats.org/officeDocument/2006/relationships" xmlns:a="http://schemas.openxmlformats.org/drawingml/2006/main" r:embed="R07eda72a577d4fd1"/>
+          <a:blip xmlns:r="http://schemas.openxmlformats.org/officeDocument/2006/relationships" xmlns:a="http://schemas.openxmlformats.org/drawingml/2006/main" r:embed="Re2fde293eeeb4298"/>
           <a:stretch xmlns:a="http://schemas.openxmlformats.org/drawingml/2006/main"/>
         </p:blipFill>
         <p:spPr>
@@ -2807,7 +2807,7 @@
           <p:cNvPr id="6" name="">
             <a:extLst xmlns:a="http://schemas.openxmlformats.org/drawingml/2006/main">
               <a:ext uri="{FF2B5EF4-FFF2-40B4-BE49-F238E27FC236}">
-                <a16:creationId xmlns:a16="http://schemas.microsoft.com/office/drawing/2014/main" id="{E3154D58-B44A-488F-B7D7-A714C5E875A6}"/>
+                <a16:creationId xmlns:a16="http://schemas.microsoft.com/office/drawing/2014/main" id="{188F287B-027F-4716-856D-7540C15A47D3}"/>
               </a:ext>
             </a:extLst>
           </p:cNvPr>
@@ -2868,7 +2868,7 @@
           <p:cNvPr id="7" name="">
             <a:extLst xmlns:a="http://schemas.openxmlformats.org/drawingml/2006/main">
               <a:ext uri="{FF2B5EF4-FFF2-40B4-BE49-F238E27FC236}">
-                <a16:creationId xmlns:a16="http://schemas.microsoft.com/office/drawing/2014/main" id="{09420CCD-2AAF-414D-BD93-D577DD610489}"/>
+                <a16:creationId xmlns:a16="http://schemas.microsoft.com/office/drawing/2014/main" id="{CC4003F5-27B7-4D54-A5A3-6C583CDF6AF2}"/>
               </a:ext>
             </a:extLst>
           </p:cNvPr>
@@ -2929,7 +2929,7 @@
           <p:cNvPr id="8" name="">
             <a:extLst xmlns:a="http://schemas.openxmlformats.org/drawingml/2006/main">
               <a:ext uri="{FF2B5EF4-FFF2-40B4-BE49-F238E27FC236}">
-                <a16:creationId xmlns:a16="http://schemas.microsoft.com/office/drawing/2014/main" id="{F1E077B3-F368-4BA3-B22E-9193E0C7E8BF}"/>
+                <a16:creationId xmlns:a16="http://schemas.microsoft.com/office/drawing/2014/main" id="{D919B022-222E-4696-BBBB-5D23FE09D9BE}"/>
               </a:ext>
             </a:extLst>
           </p:cNvPr>
@@ -2990,7 +2990,7 @@
           <p:cNvPr id="9" name="">
             <a:extLst xmlns:a="http://schemas.openxmlformats.org/drawingml/2006/main">
               <a:ext uri="{FF2B5EF4-FFF2-40B4-BE49-F238E27FC236}">
-                <a16:creationId xmlns:a16="http://schemas.microsoft.com/office/drawing/2014/main" id="{509D60E5-95A0-4A44-A79C-6C00DB6584F0}"/>
+                <a16:creationId xmlns:a16="http://schemas.microsoft.com/office/drawing/2014/main" id="{C774844A-BA3B-495C-8BF2-CB6C5A04ADFB}"/>
               </a:ext>
             </a:extLst>
           </p:cNvPr>
@@ -3051,7 +3051,7 @@
           <p:cNvPr id="10" name="">
             <a:extLst xmlns:a="http://schemas.openxmlformats.org/drawingml/2006/main">
               <a:ext uri="{FF2B5EF4-FFF2-40B4-BE49-F238E27FC236}">
-                <a16:creationId xmlns:a16="http://schemas.microsoft.com/office/drawing/2014/main" id="{006635FA-73B8-42AD-98DF-1458F3B29814}"/>
+                <a16:creationId xmlns:a16="http://schemas.microsoft.com/office/drawing/2014/main" id="{C6E72D6E-BF37-4CA1-9674-6460CEE54FF9}"/>
               </a:ext>
             </a:extLst>
           </p:cNvPr>
@@ -3110,7 +3110,7 @@
     </p:spTree>
     <p:extLst>
       <p:ext uri="{BB962C8B-B14F-4D97-AF65-F5344CB8AC3E}">
-        <p14:creationId xmlns:p14="http://schemas.microsoft.com/office/powerpoint/2010/main" val="1868418869"/>
+        <p14:creationId xmlns:p14="http://schemas.microsoft.com/office/powerpoint/2010/main" val="555843310"/>
       </p:ext>
     </p:extLst>
   </p:cSld>
@@ -3141,7 +3141,7 @@
           <p:cNvPr id="9" name="">
             <a:extLst xmlns:a="http://schemas.openxmlformats.org/drawingml/2006/main">
               <a:ext uri="{FF2B5EF4-FFF2-40B4-BE49-F238E27FC236}">
-                <a16:creationId xmlns:a16="http://schemas.microsoft.com/office/drawing/2014/main" id="{3EC9F2C1-F152-4CE9-937E-F971EA43AD7A}"/>
+                <a16:creationId xmlns:a16="http://schemas.microsoft.com/office/drawing/2014/main" id="{CB4CAD8E-8955-4D72-BE01-55D17BED90A2}"/>
               </a:ext>
             </a:extLst>
           </p:cNvPr>
@@ -3202,7 +3202,7 @@
           <p:cNvPr id="2" name="">
             <a:extLst xmlns:a="http://schemas.openxmlformats.org/drawingml/2006/main">
               <a:ext uri="{FF2B5EF4-FFF2-40B4-BE49-F238E27FC236}">
-                <a16:creationId xmlns:a16="http://schemas.microsoft.com/office/drawing/2014/main" id="{10D721F9-239E-46EB-9E9C-3D0C4AEB0BE6}"/>
+                <a16:creationId xmlns:a16="http://schemas.microsoft.com/office/drawing/2014/main" id="{F6C7FDC0-522B-434B-B5C6-8021EB2CBDEF}"/>
               </a:ext>
             </a:extLst>
           </p:cNvPr>
@@ -3263,7 +3263,7 @@
           <p:cNvPr id="3" name="">
             <a:extLst xmlns:a="http://schemas.openxmlformats.org/drawingml/2006/main">
               <a:ext uri="{FF2B5EF4-FFF2-40B4-BE49-F238E27FC236}">
-                <a16:creationId xmlns:a16="http://schemas.microsoft.com/office/drawing/2014/main" id="{742FF340-4519-4800-BCD7-33A9518CD9C8}"/>
+                <a16:creationId xmlns:a16="http://schemas.microsoft.com/office/drawing/2014/main" id="{490FFF31-399E-4633-90F0-5A950EDA1538}"/>
               </a:ext>
             </a:extLst>
           </p:cNvPr>
@@ -3324,7 +3324,7 @@
           <p:cNvPr id="4" name="">
             <a:extLst xmlns:a="http://schemas.openxmlformats.org/drawingml/2006/main">
               <a:ext uri="{FF2B5EF4-FFF2-40B4-BE49-F238E27FC236}">
-                <a16:creationId xmlns:a16="http://schemas.microsoft.com/office/drawing/2014/main" id="{1AE2B875-A107-4DF6-BB1F-92E48E319857}"/>
+                <a16:creationId xmlns:a16="http://schemas.microsoft.com/office/drawing/2014/main" id="{10955D9A-1EE6-42D9-86D8-1C8FB3B8E736}"/>
               </a:ext>
             </a:extLst>
           </p:cNvPr>
@@ -3389,7 +3389,7 @@
           <p:nvPr/>
         </p:nvPicPr>
         <p:blipFill>
-          <a:blip xmlns:r="http://schemas.openxmlformats.org/officeDocument/2006/relationships" xmlns:a="http://schemas.openxmlformats.org/drawingml/2006/main" r:embed="Ra8012491e5fa4881"/>
+          <a:blip xmlns:r="http://schemas.openxmlformats.org/officeDocument/2006/relationships" xmlns:a="http://schemas.openxmlformats.org/drawingml/2006/main" r:embed="Rd04fc30a9bea4d89"/>
           <a:stretch xmlns:a="http://schemas.openxmlformats.org/drawingml/2006/main"/>
         </p:blipFill>
         <p:spPr>
@@ -3690,7 +3690,7 @@
           <p:cNvPr id="7" name="">
             <a:extLst xmlns:a="http://schemas.openxmlformats.org/drawingml/2006/main">
               <a:ext uri="{FF2B5EF4-FFF2-40B4-BE49-F238E27FC236}">
-                <a16:creationId xmlns:a16="http://schemas.microsoft.com/office/drawing/2014/main" id="{AC3A8413-A1CD-4408-B8C9-A2DB11AB76A2}"/>
+                <a16:creationId xmlns:a16="http://schemas.microsoft.com/office/drawing/2014/main" id="{68EE72FA-3DBA-44AA-BA68-FCB0753B4491}"/>
               </a:ext>
             </a:extLst>
           </p:cNvPr>
@@ -3751,7 +3751,7 @@
           <p:cNvPr id="8" name="">
             <a:extLst xmlns:a="http://schemas.openxmlformats.org/drawingml/2006/main">
               <a:ext uri="{FF2B5EF4-FFF2-40B4-BE49-F238E27FC236}">
-                <a16:creationId xmlns:a16="http://schemas.microsoft.com/office/drawing/2014/main" id="{33C0F27D-1983-4B9D-84F8-B46BE16E874F}"/>
+                <a16:creationId xmlns:a16="http://schemas.microsoft.com/office/drawing/2014/main" id="{40313237-0527-4202-B01E-1C79186CA7CF}"/>
               </a:ext>
             </a:extLst>
           </p:cNvPr>
@@ -3810,7 +3810,7 @@
     </p:spTree>
     <p:extLst>
       <p:ext uri="{BB962C8B-B14F-4D97-AF65-F5344CB8AC3E}">
-        <p14:creationId xmlns:p14="http://schemas.microsoft.com/office/powerpoint/2010/main" val="1285266853"/>
+        <p14:creationId xmlns:p14="http://schemas.microsoft.com/office/powerpoint/2010/main" val="1893167351"/>
       </p:ext>
     </p:extLst>
   </p:cSld>
@@ -3841,7 +3841,7 @@
           <p:cNvPr id="11" name="">
             <a:extLst xmlns:a="http://schemas.openxmlformats.org/drawingml/2006/main">
               <a:ext uri="{FF2B5EF4-FFF2-40B4-BE49-F238E27FC236}">
-                <a16:creationId xmlns:a16="http://schemas.microsoft.com/office/drawing/2014/main" id="{D66A9032-5BC0-4149-A4D4-DC146B0CDF97}"/>
+                <a16:creationId xmlns:a16="http://schemas.microsoft.com/office/drawing/2014/main" id="{B14F63C6-641E-4D8C-898B-6DEB3C09196C}"/>
               </a:ext>
             </a:extLst>
           </p:cNvPr>
@@ -3902,7 +3902,7 @@
           <p:cNvPr id="2" name="">
             <a:extLst xmlns:a="http://schemas.openxmlformats.org/drawingml/2006/main">
               <a:ext uri="{FF2B5EF4-FFF2-40B4-BE49-F238E27FC236}">
-                <a16:creationId xmlns:a16="http://schemas.microsoft.com/office/drawing/2014/main" id="{E78E9B39-E68B-4F8F-BFCA-D4ACEEF6029C}"/>
+                <a16:creationId xmlns:a16="http://schemas.microsoft.com/office/drawing/2014/main" id="{BF0B437C-7FF2-4188-BDFF-B64CF695A957}"/>
               </a:ext>
             </a:extLst>
           </p:cNvPr>
@@ -3963,7 +3963,7 @@
           <p:cNvPr id="3" name="">
             <a:extLst xmlns:a="http://schemas.openxmlformats.org/drawingml/2006/main">
               <a:ext uri="{FF2B5EF4-FFF2-40B4-BE49-F238E27FC236}">
-                <a16:creationId xmlns:a16="http://schemas.microsoft.com/office/drawing/2014/main" id="{A62E885C-4229-4B73-8D9B-BBD72B5883FD}"/>
+                <a16:creationId xmlns:a16="http://schemas.microsoft.com/office/drawing/2014/main" id="{75EFE17E-9C43-49DA-9A1B-83DD7D61E880}"/>
               </a:ext>
             </a:extLst>
           </p:cNvPr>
@@ -4024,7 +4024,7 @@
           <p:cNvPr id="4" name="">
             <a:extLst xmlns:a="http://schemas.openxmlformats.org/drawingml/2006/main">
               <a:ext uri="{FF2B5EF4-FFF2-40B4-BE49-F238E27FC236}">
-                <a16:creationId xmlns:a16="http://schemas.microsoft.com/office/drawing/2014/main" id="{733545AF-1603-41C4-9686-37559E5C0246}"/>
+                <a16:creationId xmlns:a16="http://schemas.microsoft.com/office/drawing/2014/main" id="{68ED6D62-E459-4D0A-950D-D439E540B559}"/>
               </a:ext>
             </a:extLst>
           </p:cNvPr>
@@ -4089,7 +4089,7 @@
           <p:nvPr/>
         </p:nvPicPr>
         <p:blipFill>
-          <a:blip xmlns:r="http://schemas.openxmlformats.org/officeDocument/2006/relationships" xmlns:a="http://schemas.openxmlformats.org/drawingml/2006/main" r:embed="Rbb433cb00d7b4833"/>
+          <a:blip xmlns:r="http://schemas.openxmlformats.org/officeDocument/2006/relationships" xmlns:a="http://schemas.openxmlformats.org/drawingml/2006/main" r:embed="R2031ddfb6ecf4761"/>
           <a:stretch xmlns:a="http://schemas.openxmlformats.org/drawingml/2006/main"/>
         </p:blipFill>
         <p:spPr>
@@ -4107,7 +4107,7 @@
           <p:cNvPr id="6" name="">
             <a:extLst xmlns:a="http://schemas.openxmlformats.org/drawingml/2006/main">
               <a:ext uri="{FF2B5EF4-FFF2-40B4-BE49-F238E27FC236}">
-                <a16:creationId xmlns:a16="http://schemas.microsoft.com/office/drawing/2014/main" id="{F05CDF73-F686-4CDD-8238-1AF2CA3D7DCC}"/>
+                <a16:creationId xmlns:a16="http://schemas.microsoft.com/office/drawing/2014/main" id="{ED7F2D31-6BED-44C7-B603-2B592140FE61}"/>
               </a:ext>
             </a:extLst>
           </p:cNvPr>
@@ -4168,7 +4168,7 @@
           <p:cNvPr id="7" name="">
             <a:extLst xmlns:a="http://schemas.openxmlformats.org/drawingml/2006/main">
               <a:ext uri="{FF2B5EF4-FFF2-40B4-BE49-F238E27FC236}">
-                <a16:creationId xmlns:a16="http://schemas.microsoft.com/office/drawing/2014/main" id="{7E2E8D65-C249-4F4B-BF39-F39203AB9E61}"/>
+                <a16:creationId xmlns:a16="http://schemas.microsoft.com/office/drawing/2014/main" id="{506FC8CF-C332-4CB2-9633-FBA3561B831C}"/>
               </a:ext>
             </a:extLst>
           </p:cNvPr>
@@ -4229,7 +4229,7 @@
           <p:cNvPr id="8" name="">
             <a:extLst xmlns:a="http://schemas.openxmlformats.org/drawingml/2006/main">
               <a:ext uri="{FF2B5EF4-FFF2-40B4-BE49-F238E27FC236}">
-                <a16:creationId xmlns:a16="http://schemas.microsoft.com/office/drawing/2014/main" id="{A0887943-1E8C-47A2-9441-CF4D8AA0513C}"/>
+                <a16:creationId xmlns:a16="http://schemas.microsoft.com/office/drawing/2014/main" id="{4787B779-A202-4353-9698-57256D3F47D1}"/>
               </a:ext>
             </a:extLst>
           </p:cNvPr>
@@ -4290,7 +4290,7 @@
           <p:cNvPr id="9" name="">
             <a:extLst xmlns:a="http://schemas.openxmlformats.org/drawingml/2006/main">
               <a:ext uri="{FF2B5EF4-FFF2-40B4-BE49-F238E27FC236}">
-                <a16:creationId xmlns:a16="http://schemas.microsoft.com/office/drawing/2014/main" id="{92DA953E-1CC1-4BAB-9D18-EA51B3F586F0}"/>
+                <a16:creationId xmlns:a16="http://schemas.microsoft.com/office/drawing/2014/main" id="{A54505EA-C27A-408A-A4B3-A771372A55A0}"/>
               </a:ext>
             </a:extLst>
           </p:cNvPr>
@@ -4351,7 +4351,7 @@
           <p:cNvPr id="10" name="">
             <a:extLst xmlns:a="http://schemas.openxmlformats.org/drawingml/2006/main">
               <a:ext uri="{FF2B5EF4-FFF2-40B4-BE49-F238E27FC236}">
-                <a16:creationId xmlns:a16="http://schemas.microsoft.com/office/drawing/2014/main" id="{354254A1-FEE5-44C9-8644-CA0F9A9FC9EA}"/>
+                <a16:creationId xmlns:a16="http://schemas.microsoft.com/office/drawing/2014/main" id="{8C547502-9A64-4432-A9E2-94D6755B371F}"/>
               </a:ext>
             </a:extLst>
           </p:cNvPr>
@@ -4410,7 +4410,7 @@
     </p:spTree>
     <p:extLst>
       <p:ext uri="{BB962C8B-B14F-4D97-AF65-F5344CB8AC3E}">
-        <p14:creationId xmlns:p14="http://schemas.microsoft.com/office/powerpoint/2010/main" val="1283968221"/>
+        <p14:creationId xmlns:p14="http://schemas.microsoft.com/office/powerpoint/2010/main" val="1394798085"/>
       </p:ext>
     </p:extLst>
   </p:cSld>
@@ -4441,7 +4441,7 @@
           <p:cNvPr id="11" name="">
             <a:extLst xmlns:a="http://schemas.openxmlformats.org/drawingml/2006/main">
               <a:ext uri="{FF2B5EF4-FFF2-40B4-BE49-F238E27FC236}">
-                <a16:creationId xmlns:a16="http://schemas.microsoft.com/office/drawing/2014/main" id="{9AF86465-26BF-4B6D-80A9-F865018FA73A}"/>
+                <a16:creationId xmlns:a16="http://schemas.microsoft.com/office/drawing/2014/main" id="{FCCC9E0C-4062-4DC5-8B6E-9098524583D3}"/>
               </a:ext>
             </a:extLst>
           </p:cNvPr>
@@ -4502,7 +4502,7 @@
           <p:cNvPr id="2" name="">
             <a:extLst xmlns:a="http://schemas.openxmlformats.org/drawingml/2006/main">
               <a:ext uri="{FF2B5EF4-FFF2-40B4-BE49-F238E27FC236}">
-                <a16:creationId xmlns:a16="http://schemas.microsoft.com/office/drawing/2014/main" id="{21616687-F611-4A1F-A22D-E921354BCD1A}"/>
+                <a16:creationId xmlns:a16="http://schemas.microsoft.com/office/drawing/2014/main" id="{D71731A3-A47F-4885-9A7B-2BE79876BB71}"/>
               </a:ext>
             </a:extLst>
           </p:cNvPr>
@@ -4563,7 +4563,7 @@
           <p:cNvPr id="3" name="">
             <a:extLst xmlns:a="http://schemas.openxmlformats.org/drawingml/2006/main">
               <a:ext uri="{FF2B5EF4-FFF2-40B4-BE49-F238E27FC236}">
-                <a16:creationId xmlns:a16="http://schemas.microsoft.com/office/drawing/2014/main" id="{E19651D2-8038-480A-A5CF-7A4E7A25FEBB}"/>
+                <a16:creationId xmlns:a16="http://schemas.microsoft.com/office/drawing/2014/main" id="{57188FCC-A1A4-479B-BF11-64D73F4B9D4A}"/>
               </a:ext>
             </a:extLst>
           </p:cNvPr>
@@ -4624,7 +4624,7 @@
           <p:cNvPr id="4" name="">
             <a:extLst xmlns:a="http://schemas.openxmlformats.org/drawingml/2006/main">
               <a:ext uri="{FF2B5EF4-FFF2-40B4-BE49-F238E27FC236}">
-                <a16:creationId xmlns:a16="http://schemas.microsoft.com/office/drawing/2014/main" id="{A6EA5691-CA52-4B16-8E64-92D81147FCBB}"/>
+                <a16:creationId xmlns:a16="http://schemas.microsoft.com/office/drawing/2014/main" id="{2C37D731-A196-4E56-BF24-F082CB1D27E2}"/>
               </a:ext>
             </a:extLst>
           </p:cNvPr>
@@ -4685,7 +4685,7 @@
           <p:cNvPr id="5" name="">
             <a:extLst xmlns:a="http://schemas.openxmlformats.org/drawingml/2006/main">
               <a:ext uri="{FF2B5EF4-FFF2-40B4-BE49-F238E27FC236}">
-                <a16:creationId xmlns:a16="http://schemas.microsoft.com/office/drawing/2014/main" id="{3FF8AF82-F680-4BE8-9BEB-98D01363A119}"/>
+                <a16:creationId xmlns:a16="http://schemas.microsoft.com/office/drawing/2014/main" id="{A46A6B24-3711-44C9-8ACA-24AA65B3C38B}"/>
               </a:ext>
             </a:extLst>
           </p:cNvPr>
@@ -4746,7 +4746,7 @@
           <p:cNvPr id="6" name="">
             <a:extLst xmlns:a="http://schemas.openxmlformats.org/drawingml/2006/main">
               <a:ext uri="{FF2B5EF4-FFF2-40B4-BE49-F238E27FC236}">
-                <a16:creationId xmlns:a16="http://schemas.microsoft.com/office/drawing/2014/main" id="{03200E5A-9980-4632-8EEE-314941AEF9AF}"/>
+                <a16:creationId xmlns:a16="http://schemas.microsoft.com/office/drawing/2014/main" id="{695EA9E0-77FC-4231-8360-CDD73ACAC766}"/>
               </a:ext>
             </a:extLst>
           </p:cNvPr>
@@ -4807,7 +4807,7 @@
           <p:cNvPr id="7" name="">
             <a:extLst xmlns:a="http://schemas.openxmlformats.org/drawingml/2006/main">
               <a:ext uri="{FF2B5EF4-FFF2-40B4-BE49-F238E27FC236}">
-                <a16:creationId xmlns:a16="http://schemas.microsoft.com/office/drawing/2014/main" id="{5F72297F-4D0D-40FA-A36C-EDE0585F8129}"/>
+                <a16:creationId xmlns:a16="http://schemas.microsoft.com/office/drawing/2014/main" id="{974A7809-7EBF-4935-B069-BC4FF1D9060F}"/>
               </a:ext>
             </a:extLst>
           </p:cNvPr>
@@ -4868,7 +4868,7 @@
           <p:cNvPr id="8" name="">
             <a:extLst xmlns:a="http://schemas.openxmlformats.org/drawingml/2006/main">
               <a:ext uri="{FF2B5EF4-FFF2-40B4-BE49-F238E27FC236}">
-                <a16:creationId xmlns:a16="http://schemas.microsoft.com/office/drawing/2014/main" id="{D4FB69E5-9C9B-4F0A-B26E-1F83BA5AAE7F}"/>
+                <a16:creationId xmlns:a16="http://schemas.microsoft.com/office/drawing/2014/main" id="{5FCB5A3C-8C74-41F6-BFB8-38239505C743}"/>
               </a:ext>
             </a:extLst>
           </p:cNvPr>
@@ -4929,7 +4929,7 @@
           <p:cNvPr id="9" name="">
             <a:extLst xmlns:a="http://schemas.openxmlformats.org/drawingml/2006/main">
               <a:ext uri="{FF2B5EF4-FFF2-40B4-BE49-F238E27FC236}">
-                <a16:creationId xmlns:a16="http://schemas.microsoft.com/office/drawing/2014/main" id="{626200E8-6309-4504-B7FB-D7EEA85E2F62}"/>
+                <a16:creationId xmlns:a16="http://schemas.microsoft.com/office/drawing/2014/main" id="{0754F3D1-C9DB-4EBD-8FBD-16B4666B53BA}"/>
               </a:ext>
             </a:extLst>
           </p:cNvPr>
@@ -4990,7 +4990,7 @@
           <p:cNvPr id="10" name="">
             <a:extLst xmlns:a="http://schemas.openxmlformats.org/drawingml/2006/main">
               <a:ext uri="{FF2B5EF4-FFF2-40B4-BE49-F238E27FC236}">
-                <a16:creationId xmlns:a16="http://schemas.microsoft.com/office/drawing/2014/main" id="{8663E835-E9AE-42AB-9C2B-AAEA35FF51E8}"/>
+                <a16:creationId xmlns:a16="http://schemas.microsoft.com/office/drawing/2014/main" id="{99B392D0-4927-4F1E-AEB9-74B2274B7314}"/>
               </a:ext>
             </a:extLst>
           </p:cNvPr>
@@ -5049,7 +5049,7 @@
     </p:spTree>
     <p:extLst>
       <p:ext uri="{BB962C8B-B14F-4D97-AF65-F5344CB8AC3E}">
-        <p14:creationId xmlns:p14="http://schemas.microsoft.com/office/powerpoint/2010/main" val="1156684681"/>
+        <p14:creationId xmlns:p14="http://schemas.microsoft.com/office/powerpoint/2010/main" val="1573737211"/>
       </p:ext>
     </p:extLst>
   </p:cSld>
@@ -5080,7 +5080,7 @@
           <p:cNvPr id="11" name="">
             <a:extLst xmlns:a="http://schemas.openxmlformats.org/drawingml/2006/main">
               <a:ext uri="{FF2B5EF4-FFF2-40B4-BE49-F238E27FC236}">
-                <a16:creationId xmlns:a16="http://schemas.microsoft.com/office/drawing/2014/main" id="{741B6DE7-7A63-4AF3-9983-83FFC99F88CD}"/>
+                <a16:creationId xmlns:a16="http://schemas.microsoft.com/office/drawing/2014/main" id="{657AC37D-C4E7-4307-81E6-397D8E06F970}"/>
               </a:ext>
             </a:extLst>
           </p:cNvPr>
@@ -5141,7 +5141,7 @@
           <p:cNvPr id="2" name="">
             <a:extLst xmlns:a="http://schemas.openxmlformats.org/drawingml/2006/main">
               <a:ext uri="{FF2B5EF4-FFF2-40B4-BE49-F238E27FC236}">
-                <a16:creationId xmlns:a16="http://schemas.microsoft.com/office/drawing/2014/main" id="{B62F893C-F757-46A0-9F98-93A277EAD64D}"/>
+                <a16:creationId xmlns:a16="http://schemas.microsoft.com/office/drawing/2014/main" id="{77541248-89B2-40C0-ABE3-E1AD16C24993}"/>
               </a:ext>
             </a:extLst>
           </p:cNvPr>
@@ -5202,7 +5202,7 @@
           <p:cNvPr id="3" name="">
             <a:extLst xmlns:a="http://schemas.openxmlformats.org/drawingml/2006/main">
               <a:ext uri="{FF2B5EF4-FFF2-40B4-BE49-F238E27FC236}">
-                <a16:creationId xmlns:a16="http://schemas.microsoft.com/office/drawing/2014/main" id="{75E74F10-65F1-4BC6-B141-3F32FAD3961B}"/>
+                <a16:creationId xmlns:a16="http://schemas.microsoft.com/office/drawing/2014/main" id="{DFB159C5-4400-484E-94B4-41988CE58BBF}"/>
               </a:ext>
             </a:extLst>
           </p:cNvPr>
@@ -5263,7 +5263,7 @@
           <p:cNvPr id="4" name="">
             <a:extLst xmlns:a="http://schemas.openxmlformats.org/drawingml/2006/main">
               <a:ext uri="{FF2B5EF4-FFF2-40B4-BE49-F238E27FC236}">
-                <a16:creationId xmlns:a16="http://schemas.microsoft.com/office/drawing/2014/main" id="{D825E92B-7EBF-4F7A-826F-B4623816CD14}"/>
+                <a16:creationId xmlns:a16="http://schemas.microsoft.com/office/drawing/2014/main" id="{3AC781BD-E1F4-4168-9E78-609A0EC1AC89}"/>
               </a:ext>
             </a:extLst>
           </p:cNvPr>
@@ -5324,7 +5324,7 @@
           <p:cNvPr id="5" name="">
             <a:extLst xmlns:a="http://schemas.openxmlformats.org/drawingml/2006/main">
               <a:ext uri="{FF2B5EF4-FFF2-40B4-BE49-F238E27FC236}">
-                <a16:creationId xmlns:a16="http://schemas.microsoft.com/office/drawing/2014/main" id="{D67CFE22-F841-4976-B8F8-BA76DF82A9C9}"/>
+                <a16:creationId xmlns:a16="http://schemas.microsoft.com/office/drawing/2014/main" id="{EF335AD3-FB0D-44B5-B2BB-D803744BA54D}"/>
               </a:ext>
             </a:extLst>
           </p:cNvPr>
@@ -5385,7 +5385,7 @@
           <p:cNvPr id="6" name="">
             <a:extLst xmlns:a="http://schemas.openxmlformats.org/drawingml/2006/main">
               <a:ext uri="{FF2B5EF4-FFF2-40B4-BE49-F238E27FC236}">
-                <a16:creationId xmlns:a16="http://schemas.microsoft.com/office/drawing/2014/main" id="{C1568799-9501-4390-9EFA-7B6B3E645D0D}"/>
+                <a16:creationId xmlns:a16="http://schemas.microsoft.com/office/drawing/2014/main" id="{8D7A2E11-F2D3-4B16-90C8-E8B50F9C1FAD}"/>
               </a:ext>
             </a:extLst>
           </p:cNvPr>
@@ -5446,7 +5446,7 @@
           <p:cNvPr id="7" name="">
             <a:extLst xmlns:a="http://schemas.openxmlformats.org/drawingml/2006/main">
               <a:ext uri="{FF2B5EF4-FFF2-40B4-BE49-F238E27FC236}">
-                <a16:creationId xmlns:a16="http://schemas.microsoft.com/office/drawing/2014/main" id="{8C0EA479-D9AC-4D05-8D1F-DD4F25B4E415}"/>
+                <a16:creationId xmlns:a16="http://schemas.microsoft.com/office/drawing/2014/main" id="{2AC32205-62A5-4CEE-B8CB-34C6B99C6A62}"/>
               </a:ext>
             </a:extLst>
           </p:cNvPr>
@@ -5507,7 +5507,7 @@
           <p:cNvPr id="8" name="">
             <a:extLst xmlns:a="http://schemas.openxmlformats.org/drawingml/2006/main">
               <a:ext uri="{FF2B5EF4-FFF2-40B4-BE49-F238E27FC236}">
-                <a16:creationId xmlns:a16="http://schemas.microsoft.com/office/drawing/2014/main" id="{2E2DC638-765D-4F57-8328-6339EDABDBDD}"/>
+                <a16:creationId xmlns:a16="http://schemas.microsoft.com/office/drawing/2014/main" id="{1E7548B0-5422-4853-95AC-15C5FE86D065}"/>
               </a:ext>
             </a:extLst>
           </p:cNvPr>
@@ -5568,7 +5568,7 @@
           <p:cNvPr id="9" name="">
             <a:extLst xmlns:a="http://schemas.openxmlformats.org/drawingml/2006/main">
               <a:ext uri="{FF2B5EF4-FFF2-40B4-BE49-F238E27FC236}">
-                <a16:creationId xmlns:a16="http://schemas.microsoft.com/office/drawing/2014/main" id="{96D07D62-715D-4A15-9DBB-5D3BB3204F9D}"/>
+                <a16:creationId xmlns:a16="http://schemas.microsoft.com/office/drawing/2014/main" id="{13BDDD48-A488-4161-80A5-E01453CD4336}"/>
               </a:ext>
             </a:extLst>
           </p:cNvPr>
@@ -5629,7 +5629,7 @@
           <p:cNvPr id="10" name="">
             <a:extLst xmlns:a="http://schemas.openxmlformats.org/drawingml/2006/main">
               <a:ext uri="{FF2B5EF4-FFF2-40B4-BE49-F238E27FC236}">
-                <a16:creationId xmlns:a16="http://schemas.microsoft.com/office/drawing/2014/main" id="{8ABEF3A2-D842-434F-9A25-9346899A7F08}"/>
+                <a16:creationId xmlns:a16="http://schemas.microsoft.com/office/drawing/2014/main" id="{23DCDB5A-E318-4CC4-9FE5-597B018CDB9B}"/>
               </a:ext>
             </a:extLst>
           </p:cNvPr>
@@ -5688,7 +5688,7 @@
     </p:spTree>
     <p:extLst>
       <p:ext uri="{BB962C8B-B14F-4D97-AF65-F5344CB8AC3E}">
-        <p14:creationId xmlns:p14="http://schemas.microsoft.com/office/powerpoint/2010/main" val="249231885"/>
+        <p14:creationId xmlns:p14="http://schemas.microsoft.com/office/powerpoint/2010/main" val="1317249664"/>
       </p:ext>
     </p:extLst>
   </p:cSld>
@@ -5719,7 +5719,7 @@
           <p:cNvPr id="8" name="">
             <a:extLst xmlns:a="http://schemas.openxmlformats.org/drawingml/2006/main">
               <a:ext uri="{FF2B5EF4-FFF2-40B4-BE49-F238E27FC236}">
-                <a16:creationId xmlns:a16="http://schemas.microsoft.com/office/drawing/2014/main" id="{3B6F23E5-6510-4160-88AE-1A2EB8C41C60}"/>
+                <a16:creationId xmlns:a16="http://schemas.microsoft.com/office/drawing/2014/main" id="{A5D49D59-A09F-44EA-B3AC-7656F48D5D58}"/>
               </a:ext>
             </a:extLst>
           </p:cNvPr>
@@ -5780,7 +5780,7 @@
           <p:cNvPr id="2" name="">
             <a:extLst xmlns:a="http://schemas.openxmlformats.org/drawingml/2006/main">
               <a:ext uri="{FF2B5EF4-FFF2-40B4-BE49-F238E27FC236}">
-                <a16:creationId xmlns:a16="http://schemas.microsoft.com/office/drawing/2014/main" id="{3F99A810-D2F7-44C9-B03B-E2B4F1A87005}"/>
+                <a16:creationId xmlns:a16="http://schemas.microsoft.com/office/drawing/2014/main" id="{7DEB5BF1-85F0-4728-9B64-410D390D16A2}"/>
               </a:ext>
             </a:extLst>
           </p:cNvPr>
@@ -5841,7 +5841,7 @@
           <p:cNvPr id="3" name="">
             <a:extLst xmlns:a="http://schemas.openxmlformats.org/drawingml/2006/main">
               <a:ext uri="{FF2B5EF4-FFF2-40B4-BE49-F238E27FC236}">
-                <a16:creationId xmlns:a16="http://schemas.microsoft.com/office/drawing/2014/main" id="{64B9C10B-569A-482A-A6B1-20C32F8E8C46}"/>
+                <a16:creationId xmlns:a16="http://schemas.microsoft.com/office/drawing/2014/main" id="{2391FE0E-21D4-458C-BA59-C26130CAD910}"/>
               </a:ext>
             </a:extLst>
           </p:cNvPr>
@@ -5902,7 +5902,7 @@
           <p:cNvPr id="4" name="">
             <a:extLst xmlns:a="http://schemas.openxmlformats.org/drawingml/2006/main">
               <a:ext uri="{FF2B5EF4-FFF2-40B4-BE49-F238E27FC236}">
-                <a16:creationId xmlns:a16="http://schemas.microsoft.com/office/drawing/2014/main" id="{274FDC0F-639A-4DC6-BBDE-E409E6458741}"/>
+                <a16:creationId xmlns:a16="http://schemas.microsoft.com/office/drawing/2014/main" id="{53C0D7A2-87C5-402A-B59D-57B6272DEE5B}"/>
               </a:ext>
             </a:extLst>
           </p:cNvPr>
@@ -6413,7 +6413,7 @@
           <p:cNvPr id="6" name="">
             <a:extLst xmlns:a="http://schemas.openxmlformats.org/drawingml/2006/main">
               <a:ext uri="{FF2B5EF4-FFF2-40B4-BE49-F238E27FC236}">
-                <a16:creationId xmlns:a16="http://schemas.microsoft.com/office/drawing/2014/main" id="{8B2031A4-0830-47A4-99C1-F54918297302}"/>
+                <a16:creationId xmlns:a16="http://schemas.microsoft.com/office/drawing/2014/main" id="{7E6FFA5E-944C-4F61-9F28-EB2B76CBA34C}"/>
               </a:ext>
             </a:extLst>
           </p:cNvPr>
@@ -6474,7 +6474,7 @@
           <p:cNvPr id="7" name="">
             <a:extLst xmlns:a="http://schemas.openxmlformats.org/drawingml/2006/main">
               <a:ext uri="{FF2B5EF4-FFF2-40B4-BE49-F238E27FC236}">
-                <a16:creationId xmlns:a16="http://schemas.microsoft.com/office/drawing/2014/main" id="{20EC9E5F-B840-4E12-9781-52E7F074A5DE}"/>
+                <a16:creationId xmlns:a16="http://schemas.microsoft.com/office/drawing/2014/main" id="{51D15DD0-4614-4EE2-B3BC-C2E7951BF249}"/>
               </a:ext>
             </a:extLst>
           </p:cNvPr>
@@ -6533,7 +6533,7 @@
     </p:spTree>
     <p:extLst>
       <p:ext uri="{BB962C8B-B14F-4D97-AF65-F5344CB8AC3E}">
-        <p14:creationId xmlns:p14="http://schemas.microsoft.com/office/powerpoint/2010/main" val="1064156394"/>
+        <p14:creationId xmlns:p14="http://schemas.microsoft.com/office/powerpoint/2010/main" val="721402739"/>
       </p:ext>
     </p:extLst>
   </p:cSld>
@@ -6564,7 +6564,7 @@
           <p:cNvPr id="9" name="">
             <a:extLst xmlns:a="http://schemas.openxmlformats.org/drawingml/2006/main">
               <a:ext uri="{FF2B5EF4-FFF2-40B4-BE49-F238E27FC236}">
-                <a16:creationId xmlns:a16="http://schemas.microsoft.com/office/drawing/2014/main" id="{3891DEB7-210D-4453-B81C-FC32A6BDF26C}"/>
+                <a16:creationId xmlns:a16="http://schemas.microsoft.com/office/drawing/2014/main" id="{241E1ABA-4C0F-46DC-A697-52E71BD11722}"/>
               </a:ext>
             </a:extLst>
           </p:cNvPr>
@@ -6625,7 +6625,7 @@
           <p:cNvPr id="2" name="">
             <a:extLst xmlns:a="http://schemas.openxmlformats.org/drawingml/2006/main">
               <a:ext uri="{FF2B5EF4-FFF2-40B4-BE49-F238E27FC236}">
-                <a16:creationId xmlns:a16="http://schemas.microsoft.com/office/drawing/2014/main" id="{1DC390D2-F4E5-4535-BF34-2D3BA53E2407}"/>
+                <a16:creationId xmlns:a16="http://schemas.microsoft.com/office/drawing/2014/main" id="{DD01640E-DDC5-44EB-9DB7-DC648D4C421A}"/>
               </a:ext>
             </a:extLst>
           </p:cNvPr>
@@ -6686,7 +6686,7 @@
           <p:cNvPr id="3" name="">
             <a:extLst xmlns:a="http://schemas.openxmlformats.org/drawingml/2006/main">
               <a:ext uri="{FF2B5EF4-FFF2-40B4-BE49-F238E27FC236}">
-                <a16:creationId xmlns:a16="http://schemas.microsoft.com/office/drawing/2014/main" id="{687B6976-B8EB-4637-A0ED-CA870B44884D}"/>
+                <a16:creationId xmlns:a16="http://schemas.microsoft.com/office/drawing/2014/main" id="{75ADE341-996F-43EB-A158-4E9DD1926B13}"/>
               </a:ext>
             </a:extLst>
           </p:cNvPr>
@@ -6747,7 +6747,7 @@
           <p:cNvPr id="4" name="">
             <a:extLst xmlns:a="http://schemas.openxmlformats.org/drawingml/2006/main">
               <a:ext uri="{FF2B5EF4-FFF2-40B4-BE49-F238E27FC236}">
-                <a16:creationId xmlns:a16="http://schemas.microsoft.com/office/drawing/2014/main" id="{4B6B763B-0D56-4C5D-81A8-84F21C240DE1}"/>
+                <a16:creationId xmlns:a16="http://schemas.microsoft.com/office/drawing/2014/main" id="{648D8693-F1D5-4FA2-81D6-49A7F4C763E0}"/>
               </a:ext>
             </a:extLst>
           </p:cNvPr>
@@ -7176,7 +7176,7 @@
           <p:cNvPr id="6" name="">
             <a:extLst xmlns:a="http://schemas.openxmlformats.org/drawingml/2006/main">
               <a:ext uri="{FF2B5EF4-FFF2-40B4-BE49-F238E27FC236}">
-                <a16:creationId xmlns:a16="http://schemas.microsoft.com/office/drawing/2014/main" id="{140675A1-B358-47D9-8211-685E961051A7}"/>
+                <a16:creationId xmlns:a16="http://schemas.microsoft.com/office/drawing/2014/main" id="{BB4B2AFC-15B4-4941-B4CB-5607567701CB}"/>
               </a:ext>
             </a:extLst>
           </p:cNvPr>
@@ -7237,7 +7237,7 @@
           <p:cNvPr id="7" name="">
             <a:extLst xmlns:a="http://schemas.openxmlformats.org/drawingml/2006/main">
               <a:ext uri="{FF2B5EF4-FFF2-40B4-BE49-F238E27FC236}">
-                <a16:creationId xmlns:a16="http://schemas.microsoft.com/office/drawing/2014/main" id="{B9ED52AE-F227-42DA-8037-D8EC0D01FA36}"/>
+                <a16:creationId xmlns:a16="http://schemas.microsoft.com/office/drawing/2014/main" id="{C0B71590-E32E-476F-B61B-3620A6754229}"/>
               </a:ext>
             </a:extLst>
           </p:cNvPr>
@@ -7298,7 +7298,7 @@
           <p:cNvPr id="8" name="">
             <a:extLst xmlns:a="http://schemas.openxmlformats.org/drawingml/2006/main">
               <a:ext uri="{FF2B5EF4-FFF2-40B4-BE49-F238E27FC236}">
-                <a16:creationId xmlns:a16="http://schemas.microsoft.com/office/drawing/2014/main" id="{1C821484-2E9A-489A-901A-677C734ED3E6}"/>
+                <a16:creationId xmlns:a16="http://schemas.microsoft.com/office/drawing/2014/main" id="{7133CD07-F2FB-4DEC-89AC-9D44A21A8E48}"/>
               </a:ext>
             </a:extLst>
           </p:cNvPr>
@@ -7357,7 +7357,7 @@
     </p:spTree>
     <p:extLst>
       <p:ext uri="{BB962C8B-B14F-4D97-AF65-F5344CB8AC3E}">
-        <p14:creationId xmlns:p14="http://schemas.microsoft.com/office/powerpoint/2010/main" val="1172673718"/>
+        <p14:creationId xmlns:p14="http://schemas.microsoft.com/office/powerpoint/2010/main" val="1642542118"/>
       </p:ext>
     </p:extLst>
   </p:cSld>
@@ -7388,7 +7388,7 @@
           <p:cNvPr id="11" name="">
             <a:extLst xmlns:a="http://schemas.openxmlformats.org/drawingml/2006/main">
               <a:ext uri="{FF2B5EF4-FFF2-40B4-BE49-F238E27FC236}">
-                <a16:creationId xmlns:a16="http://schemas.microsoft.com/office/drawing/2014/main" id="{4FE6F597-DE63-406E-86A8-782AB3392698}"/>
+                <a16:creationId xmlns:a16="http://schemas.microsoft.com/office/drawing/2014/main" id="{3E2B7B18-E5B8-48AD-9B3B-2BD0B44FC3FF}"/>
               </a:ext>
             </a:extLst>
           </p:cNvPr>
@@ -7449,7 +7449,7 @@
           <p:cNvPr id="2" name="">
             <a:extLst xmlns:a="http://schemas.openxmlformats.org/drawingml/2006/main">
               <a:ext uri="{FF2B5EF4-FFF2-40B4-BE49-F238E27FC236}">
-                <a16:creationId xmlns:a16="http://schemas.microsoft.com/office/drawing/2014/main" id="{DD68E398-3833-4AD0-B74C-D8C90ADCB691}"/>
+                <a16:creationId xmlns:a16="http://schemas.microsoft.com/office/drawing/2014/main" id="{076D1FBF-7EDB-43BE-B5B6-0074AE8D9394}"/>
               </a:ext>
             </a:extLst>
           </p:cNvPr>
@@ -7510,7 +7510,7 @@
           <p:cNvPr id="3" name="">
             <a:extLst xmlns:a="http://schemas.openxmlformats.org/drawingml/2006/main">
               <a:ext uri="{FF2B5EF4-FFF2-40B4-BE49-F238E27FC236}">
-                <a16:creationId xmlns:a16="http://schemas.microsoft.com/office/drawing/2014/main" id="{F07D4E4B-81DC-4841-B9B5-485D13C6908A}"/>
+                <a16:creationId xmlns:a16="http://schemas.microsoft.com/office/drawing/2014/main" id="{31294048-4FB1-4D71-8C69-FCA46A244759}"/>
               </a:ext>
             </a:extLst>
           </p:cNvPr>
@@ -7571,7 +7571,7 @@
           <p:cNvPr id="4" name="">
             <a:extLst xmlns:a="http://schemas.openxmlformats.org/drawingml/2006/main">
               <a:ext uri="{FF2B5EF4-FFF2-40B4-BE49-F238E27FC236}">
-                <a16:creationId xmlns:a16="http://schemas.microsoft.com/office/drawing/2014/main" id="{B84F7688-69DA-4792-9184-8D407A66DB35}"/>
+                <a16:creationId xmlns:a16="http://schemas.microsoft.com/office/drawing/2014/main" id="{3629532F-2F8E-4583-BDCA-45E5E66CF1D8}"/>
               </a:ext>
             </a:extLst>
           </p:cNvPr>
@@ -7632,7 +7632,7 @@
           <p:cNvPr id="5" name="">
             <a:extLst xmlns:a="http://schemas.openxmlformats.org/drawingml/2006/main">
               <a:ext uri="{FF2B5EF4-FFF2-40B4-BE49-F238E27FC236}">
-                <a16:creationId xmlns:a16="http://schemas.microsoft.com/office/drawing/2014/main" id="{EB40D202-ACA0-49F1-B359-1A9A78D147B4}"/>
+                <a16:creationId xmlns:a16="http://schemas.microsoft.com/office/drawing/2014/main" id="{803093FF-A46A-47BC-8615-84C4AD1EB5B5}"/>
               </a:ext>
             </a:extLst>
           </p:cNvPr>
@@ -7693,7 +7693,7 @@
           <p:cNvPr id="6" name="">
             <a:extLst xmlns:a="http://schemas.openxmlformats.org/drawingml/2006/main">
               <a:ext uri="{FF2B5EF4-FFF2-40B4-BE49-F238E27FC236}">
-                <a16:creationId xmlns:a16="http://schemas.microsoft.com/office/drawing/2014/main" id="{EC55127C-CFC4-4B0D-AA75-EDBE546144B5}"/>
+                <a16:creationId xmlns:a16="http://schemas.microsoft.com/office/drawing/2014/main" id="{9621B4B7-2D96-44C1-85BF-FFFFDFEC9BA4}"/>
               </a:ext>
             </a:extLst>
           </p:cNvPr>
@@ -7754,7 +7754,7 @@
           <p:cNvPr id="7" name="">
             <a:extLst xmlns:a="http://schemas.openxmlformats.org/drawingml/2006/main">
               <a:ext uri="{FF2B5EF4-FFF2-40B4-BE49-F238E27FC236}">
-                <a16:creationId xmlns:a16="http://schemas.microsoft.com/office/drawing/2014/main" id="{653970EE-1659-4F02-BFBC-75A477C76F45}"/>
+                <a16:creationId xmlns:a16="http://schemas.microsoft.com/office/drawing/2014/main" id="{96585ECA-3C36-4B96-B130-E8D2D9D27F4F}"/>
               </a:ext>
             </a:extLst>
           </p:cNvPr>
@@ -7815,7 +7815,7 @@
           <p:cNvPr id="8" name="">
             <a:extLst xmlns:a="http://schemas.openxmlformats.org/drawingml/2006/main">
               <a:ext uri="{FF2B5EF4-FFF2-40B4-BE49-F238E27FC236}">
-                <a16:creationId xmlns:a16="http://schemas.microsoft.com/office/drawing/2014/main" id="{76F83EF9-4987-4C1C-8CAA-7330395B3F47}"/>
+                <a16:creationId xmlns:a16="http://schemas.microsoft.com/office/drawing/2014/main" id="{0416E94B-855D-4FB9-AD72-F0FAFA303EE1}"/>
               </a:ext>
             </a:extLst>
           </p:cNvPr>
@@ -7876,7 +7876,7 @@
           <p:cNvPr id="9" name="">
             <a:extLst xmlns:a="http://schemas.openxmlformats.org/drawingml/2006/main">
               <a:ext uri="{FF2B5EF4-FFF2-40B4-BE49-F238E27FC236}">
-                <a16:creationId xmlns:a16="http://schemas.microsoft.com/office/drawing/2014/main" id="{7C24A1F4-E6E3-413F-94FB-2E76A93B71D0}"/>
+                <a16:creationId xmlns:a16="http://schemas.microsoft.com/office/drawing/2014/main" id="{0DDFB535-C387-4DC4-9AA8-2C08C001A9C0}"/>
               </a:ext>
             </a:extLst>
           </p:cNvPr>
@@ -7937,7 +7937,7 @@
           <p:cNvPr id="10" name="">
             <a:extLst xmlns:a="http://schemas.openxmlformats.org/drawingml/2006/main">
               <a:ext uri="{FF2B5EF4-FFF2-40B4-BE49-F238E27FC236}">
-                <a16:creationId xmlns:a16="http://schemas.microsoft.com/office/drawing/2014/main" id="{173E1E94-CA9A-41C9-8BAD-CB1D75F4D4F1}"/>
+                <a16:creationId xmlns:a16="http://schemas.microsoft.com/office/drawing/2014/main" id="{C98034C2-DD14-4F87-913B-1D16AAF5D2F0}"/>
               </a:ext>
             </a:extLst>
           </p:cNvPr>
@@ -7996,7 +7996,7 @@
     </p:spTree>
     <p:extLst>
       <p:ext uri="{BB962C8B-B14F-4D97-AF65-F5344CB8AC3E}">
-        <p14:creationId xmlns:p14="http://schemas.microsoft.com/office/powerpoint/2010/main" val="1067971343"/>
+        <p14:creationId xmlns:p14="http://schemas.microsoft.com/office/powerpoint/2010/main" val="531871666"/>
       </p:ext>
     </p:extLst>
   </p:cSld>
@@ -8027,7 +8027,7 @@
           <p:cNvPr id="8" name="">
             <a:extLst xmlns:a="http://schemas.openxmlformats.org/drawingml/2006/main">
               <a:ext uri="{FF2B5EF4-FFF2-40B4-BE49-F238E27FC236}">
-                <a16:creationId xmlns:a16="http://schemas.microsoft.com/office/drawing/2014/main" id="{B4FFD5B0-FC5A-4C16-B698-FC3FC6CCC76A}"/>
+                <a16:creationId xmlns:a16="http://schemas.microsoft.com/office/drawing/2014/main" id="{3FE8CF3A-D36A-45A3-9EC5-0F8BD5768F23}"/>
               </a:ext>
             </a:extLst>
           </p:cNvPr>
@@ -8088,7 +8088,7 @@
           <p:cNvPr id="2" name="">
             <a:extLst xmlns:a="http://schemas.openxmlformats.org/drawingml/2006/main">
               <a:ext uri="{FF2B5EF4-FFF2-40B4-BE49-F238E27FC236}">
-                <a16:creationId xmlns:a16="http://schemas.microsoft.com/office/drawing/2014/main" id="{05C2E80A-6720-4E45-B089-FCCBA1AAE482}"/>
+                <a16:creationId xmlns:a16="http://schemas.microsoft.com/office/drawing/2014/main" id="{224B9468-3512-438E-8D32-7B0E8D029E1D}"/>
               </a:ext>
             </a:extLst>
           </p:cNvPr>
@@ -8149,7 +8149,7 @@
           <p:cNvPr id="3" name="">
             <a:extLst xmlns:a="http://schemas.openxmlformats.org/drawingml/2006/main">
               <a:ext uri="{FF2B5EF4-FFF2-40B4-BE49-F238E27FC236}">
-                <a16:creationId xmlns:a16="http://schemas.microsoft.com/office/drawing/2014/main" id="{40BC05FE-59E6-44E6-9E89-FBD66F4D7A7B}"/>
+                <a16:creationId xmlns:a16="http://schemas.microsoft.com/office/drawing/2014/main" id="{6AB9E334-A24E-468B-B19E-CB76FECA926A}"/>
               </a:ext>
             </a:extLst>
           </p:cNvPr>
@@ -8210,7 +8210,7 @@
           <p:cNvPr id="4" name="">
             <a:extLst xmlns:a="http://schemas.openxmlformats.org/drawingml/2006/main">
               <a:ext uri="{FF2B5EF4-FFF2-40B4-BE49-F238E27FC236}">
-                <a16:creationId xmlns:a16="http://schemas.microsoft.com/office/drawing/2014/main" id="{796323EF-344A-43AF-9649-CF11804C2B71}"/>
+                <a16:creationId xmlns:a16="http://schemas.microsoft.com/office/drawing/2014/main" id="{E5E022C0-A391-48C3-B7BC-46553AD3D918}"/>
               </a:ext>
             </a:extLst>
           </p:cNvPr>
@@ -8967,7 +8967,7 @@
           <p:cNvPr id="6" name="">
             <a:extLst xmlns:a="http://schemas.openxmlformats.org/drawingml/2006/main">
               <a:ext uri="{FF2B5EF4-FFF2-40B4-BE49-F238E27FC236}">
-                <a16:creationId xmlns:a16="http://schemas.microsoft.com/office/drawing/2014/main" id="{4864DE71-7875-4CF9-863B-BA5B52F6F6B3}"/>
+                <a16:creationId xmlns:a16="http://schemas.microsoft.com/office/drawing/2014/main" id="{E861EA8F-1334-460C-96CD-B166D47AF4AF}"/>
               </a:ext>
             </a:extLst>
           </p:cNvPr>
@@ -9028,7 +9028,7 @@
           <p:cNvPr id="7" name="">
             <a:extLst xmlns:a="http://schemas.openxmlformats.org/drawingml/2006/main">
               <a:ext uri="{FF2B5EF4-FFF2-40B4-BE49-F238E27FC236}">
-                <a16:creationId xmlns:a16="http://schemas.microsoft.com/office/drawing/2014/main" id="{520178CD-CACA-4C48-90CF-07ACD6C5182C}"/>
+                <a16:creationId xmlns:a16="http://schemas.microsoft.com/office/drawing/2014/main" id="{909851EE-8C28-4461-B312-7C29520ADFEB}"/>
               </a:ext>
             </a:extLst>
           </p:cNvPr>
@@ -9087,7 +9087,7 @@
     </p:spTree>
     <p:extLst>
       <p:ext uri="{BB962C8B-B14F-4D97-AF65-F5344CB8AC3E}">
-        <p14:creationId xmlns:p14="http://schemas.microsoft.com/office/powerpoint/2010/main" val="429167047"/>
+        <p14:creationId xmlns:p14="http://schemas.microsoft.com/office/powerpoint/2010/main" val="1653395256"/>
       </p:ext>
     </p:extLst>
   </p:cSld>
@@ -9118,7 +9118,7 @@
           <p:cNvPr id="11" name="">
             <a:extLst xmlns:a="http://schemas.openxmlformats.org/drawingml/2006/main">
               <a:ext uri="{FF2B5EF4-FFF2-40B4-BE49-F238E27FC236}">
-                <a16:creationId xmlns:a16="http://schemas.microsoft.com/office/drawing/2014/main" id="{0C13A50A-D47C-41A7-845F-29B08513C4A0}"/>
+                <a16:creationId xmlns:a16="http://schemas.microsoft.com/office/drawing/2014/main" id="{DB3AC7BD-580B-4B15-A45C-3DC67D624819}"/>
               </a:ext>
             </a:extLst>
           </p:cNvPr>
@@ -9179,7 +9179,7 @@
           <p:cNvPr id="2" name="">
             <a:extLst xmlns:a="http://schemas.openxmlformats.org/drawingml/2006/main">
               <a:ext uri="{FF2B5EF4-FFF2-40B4-BE49-F238E27FC236}">
-                <a16:creationId xmlns:a16="http://schemas.microsoft.com/office/drawing/2014/main" id="{E37B7722-6877-49FB-B4B4-E30F6C2BAE24}"/>
+                <a16:creationId xmlns:a16="http://schemas.microsoft.com/office/drawing/2014/main" id="{EE59015C-02CE-4C07-9DE9-56F5B60617DC}"/>
               </a:ext>
             </a:extLst>
           </p:cNvPr>
@@ -9240,7 +9240,7 @@
           <p:cNvPr id="3" name="">
             <a:extLst xmlns:a="http://schemas.openxmlformats.org/drawingml/2006/main">
               <a:ext uri="{FF2B5EF4-FFF2-40B4-BE49-F238E27FC236}">
-                <a16:creationId xmlns:a16="http://schemas.microsoft.com/office/drawing/2014/main" id="{9C0FE028-CBEB-4676-B49B-004AC9F140C2}"/>
+                <a16:creationId xmlns:a16="http://schemas.microsoft.com/office/drawing/2014/main" id="{9CDE1714-E0BF-4C7D-9DCA-E3010EB764ED}"/>
               </a:ext>
             </a:extLst>
           </p:cNvPr>
@@ -9301,7 +9301,7 @@
           <p:cNvPr id="4" name="">
             <a:extLst xmlns:a="http://schemas.openxmlformats.org/drawingml/2006/main">
               <a:ext uri="{FF2B5EF4-FFF2-40B4-BE49-F238E27FC236}">
-                <a16:creationId xmlns:a16="http://schemas.microsoft.com/office/drawing/2014/main" id="{8411D093-FE7E-4CE2-B146-E28306519CB7}"/>
+                <a16:creationId xmlns:a16="http://schemas.microsoft.com/office/drawing/2014/main" id="{F4C0821A-77EE-4E2A-840D-67DE1FDAA8A6}"/>
               </a:ext>
             </a:extLst>
           </p:cNvPr>
@@ -9362,7 +9362,7 @@
           <p:cNvPr id="5" name="">
             <a:extLst xmlns:a="http://schemas.openxmlformats.org/drawingml/2006/main">
               <a:ext uri="{FF2B5EF4-FFF2-40B4-BE49-F238E27FC236}">
-                <a16:creationId xmlns:a16="http://schemas.microsoft.com/office/drawing/2014/main" id="{0A4D98CB-B6F1-4F22-BEFE-E2C8826055F9}"/>
+                <a16:creationId xmlns:a16="http://schemas.microsoft.com/office/drawing/2014/main" id="{99C30926-E072-4825-9BC2-E6FFB3E8FE2D}"/>
               </a:ext>
             </a:extLst>
           </p:cNvPr>
@@ -9423,7 +9423,7 @@
           <p:cNvPr id="6" name="">
             <a:extLst xmlns:a="http://schemas.openxmlformats.org/drawingml/2006/main">
               <a:ext uri="{FF2B5EF4-FFF2-40B4-BE49-F238E27FC236}">
-                <a16:creationId xmlns:a16="http://schemas.microsoft.com/office/drawing/2014/main" id="{E46BBF7F-B03C-4070-BEE2-E151454091B1}"/>
+                <a16:creationId xmlns:a16="http://schemas.microsoft.com/office/drawing/2014/main" id="{06733B77-5DAF-4125-9A39-2E7BE6EE5650}"/>
               </a:ext>
             </a:extLst>
           </p:cNvPr>
@@ -9484,7 +9484,7 @@
           <p:cNvPr id="7" name="">
             <a:extLst xmlns:a="http://schemas.openxmlformats.org/drawingml/2006/main">
               <a:ext uri="{FF2B5EF4-FFF2-40B4-BE49-F238E27FC236}">
-                <a16:creationId xmlns:a16="http://schemas.microsoft.com/office/drawing/2014/main" id="{C656E694-DFE8-43AC-8A74-BE241EC39633}"/>
+                <a16:creationId xmlns:a16="http://schemas.microsoft.com/office/drawing/2014/main" id="{571F34EB-9B06-44AC-BFAF-C071E893E140}"/>
               </a:ext>
             </a:extLst>
           </p:cNvPr>
@@ -9545,7 +9545,7 @@
           <p:cNvPr id="8" name="">
             <a:extLst xmlns:a="http://schemas.openxmlformats.org/drawingml/2006/main">
               <a:ext uri="{FF2B5EF4-FFF2-40B4-BE49-F238E27FC236}">
-                <a16:creationId xmlns:a16="http://schemas.microsoft.com/office/drawing/2014/main" id="{FF579DFC-F8D3-4670-8CD0-A6559439BCED}"/>
+                <a16:creationId xmlns:a16="http://schemas.microsoft.com/office/drawing/2014/main" id="{A984A38D-312A-46EC-AB19-ADCC910AC4BF}"/>
               </a:ext>
             </a:extLst>
           </p:cNvPr>
@@ -9606,7 +9606,7 @@
           <p:cNvPr id="9" name="">
             <a:extLst xmlns:a="http://schemas.openxmlformats.org/drawingml/2006/main">
               <a:ext uri="{FF2B5EF4-FFF2-40B4-BE49-F238E27FC236}">
-                <a16:creationId xmlns:a16="http://schemas.microsoft.com/office/drawing/2014/main" id="{9989521F-ACCB-4F1E-B4A4-E8E6A31384B3}"/>
+                <a16:creationId xmlns:a16="http://schemas.microsoft.com/office/drawing/2014/main" id="{03504352-54BD-4116-9384-B1D008703E60}"/>
               </a:ext>
             </a:extLst>
           </p:cNvPr>
@@ -9667,7 +9667,7 @@
           <p:cNvPr id="10" name="">
             <a:extLst xmlns:a="http://schemas.openxmlformats.org/drawingml/2006/main">
               <a:ext uri="{FF2B5EF4-FFF2-40B4-BE49-F238E27FC236}">
-                <a16:creationId xmlns:a16="http://schemas.microsoft.com/office/drawing/2014/main" id="{148196E8-687A-4F0F-BDAF-C084EB6DA55F}"/>
+                <a16:creationId xmlns:a16="http://schemas.microsoft.com/office/drawing/2014/main" id="{D2FC4959-5966-4FC2-A680-2C271EFE06FC}"/>
               </a:ext>
             </a:extLst>
           </p:cNvPr>
@@ -9726,7 +9726,7 @@
     </p:spTree>
     <p:extLst>
       <p:ext uri="{BB962C8B-B14F-4D97-AF65-F5344CB8AC3E}">
-        <p14:creationId xmlns:p14="http://schemas.microsoft.com/office/powerpoint/2010/main" val="1285167433"/>
+        <p14:creationId xmlns:p14="http://schemas.microsoft.com/office/powerpoint/2010/main" val="1020331902"/>
       </p:ext>
     </p:extLst>
   </p:cSld>
@@ -9757,7 +9757,7 @@
           <p:cNvPr id="8" name="">
             <a:extLst xmlns:a="http://schemas.openxmlformats.org/drawingml/2006/main">
               <a:ext uri="{FF2B5EF4-FFF2-40B4-BE49-F238E27FC236}">
-                <a16:creationId xmlns:a16="http://schemas.microsoft.com/office/drawing/2014/main" id="{58BA8F71-A922-423C-85D7-D73E89FB174A}"/>
+                <a16:creationId xmlns:a16="http://schemas.microsoft.com/office/drawing/2014/main" id="{4D58EA92-2F91-4854-B42A-B2254D69FDE0}"/>
               </a:ext>
             </a:extLst>
           </p:cNvPr>
@@ -9818,7 +9818,7 @@
           <p:cNvPr id="2" name="">
             <a:extLst xmlns:a="http://schemas.openxmlformats.org/drawingml/2006/main">
               <a:ext uri="{FF2B5EF4-FFF2-40B4-BE49-F238E27FC236}">
-                <a16:creationId xmlns:a16="http://schemas.microsoft.com/office/drawing/2014/main" id="{82D4D4BE-689C-4696-A358-3DCC26D56316}"/>
+                <a16:creationId xmlns:a16="http://schemas.microsoft.com/office/drawing/2014/main" id="{DA5A6222-3419-4DEB-B679-8E7C493E0FB7}"/>
               </a:ext>
             </a:extLst>
           </p:cNvPr>
@@ -9879,7 +9879,7 @@
           <p:cNvPr id="3" name="">
             <a:extLst xmlns:a="http://schemas.openxmlformats.org/drawingml/2006/main">
               <a:ext uri="{FF2B5EF4-FFF2-40B4-BE49-F238E27FC236}">
-                <a16:creationId xmlns:a16="http://schemas.microsoft.com/office/drawing/2014/main" id="{3DB052B9-0DDC-4E63-B06F-E1D173BF96D4}"/>
+                <a16:creationId xmlns:a16="http://schemas.microsoft.com/office/drawing/2014/main" id="{D06784B6-4F07-4927-B142-9F493AED7339}"/>
               </a:ext>
             </a:extLst>
           </p:cNvPr>
@@ -9940,7 +9940,7 @@
           <p:cNvPr id="4" name="">
             <a:extLst xmlns:a="http://schemas.openxmlformats.org/drawingml/2006/main">
               <a:ext uri="{FF2B5EF4-FFF2-40B4-BE49-F238E27FC236}">
-                <a16:creationId xmlns:a16="http://schemas.microsoft.com/office/drawing/2014/main" id="{6F2DE2EE-8785-4F73-9A03-BCAD10B7B3D5}"/>
+                <a16:creationId xmlns:a16="http://schemas.microsoft.com/office/drawing/2014/main" id="{9A8DD694-2344-4BBA-9A49-F082320A3BBB}"/>
               </a:ext>
             </a:extLst>
           </p:cNvPr>
@@ -10287,7 +10287,7 @@
           <p:cNvPr id="6" name="">
             <a:extLst xmlns:a="http://schemas.openxmlformats.org/drawingml/2006/main">
               <a:ext uri="{FF2B5EF4-FFF2-40B4-BE49-F238E27FC236}">
-                <a16:creationId xmlns:a16="http://schemas.microsoft.com/office/drawing/2014/main" id="{8261D291-5364-40C2-B560-3238CF4E27EC}"/>
+                <a16:creationId xmlns:a16="http://schemas.microsoft.com/office/drawing/2014/main" id="{5C08ABCB-F36D-44C0-8241-90BF922D32C5}"/>
               </a:ext>
             </a:extLst>
           </p:cNvPr>
@@ -10348,7 +10348,7 @@
           <p:cNvPr id="7" name="">
             <a:extLst xmlns:a="http://schemas.openxmlformats.org/drawingml/2006/main">
               <a:ext uri="{FF2B5EF4-FFF2-40B4-BE49-F238E27FC236}">
-                <a16:creationId xmlns:a16="http://schemas.microsoft.com/office/drawing/2014/main" id="{62CFE674-7886-4C2D-8A5D-B51660FA3B43}"/>
+                <a16:creationId xmlns:a16="http://schemas.microsoft.com/office/drawing/2014/main" id="{D457B6B1-92AB-41A9-B38E-52EE92DC9954}"/>
               </a:ext>
             </a:extLst>
           </p:cNvPr>
@@ -10407,7 +10407,7 @@
     </p:spTree>
     <p:extLst>
       <p:ext uri="{BB962C8B-B14F-4D97-AF65-F5344CB8AC3E}">
-        <p14:creationId xmlns:p14="http://schemas.microsoft.com/office/powerpoint/2010/main" val="1101579237"/>
+        <p14:creationId xmlns:p14="http://schemas.microsoft.com/office/powerpoint/2010/main" val="1198646338"/>
       </p:ext>
     </p:extLst>
   </p:cSld>
@@ -10438,7 +10438,7 @@
           <p:cNvPr id="7" name="">
             <a:extLst xmlns:a="http://schemas.openxmlformats.org/drawingml/2006/main">
               <a:ext uri="{FF2B5EF4-FFF2-40B4-BE49-F238E27FC236}">
-                <a16:creationId xmlns:a16="http://schemas.microsoft.com/office/drawing/2014/main" id="{230F45D1-6A22-4189-88A8-137A629DAF7E}"/>
+                <a16:creationId xmlns:a16="http://schemas.microsoft.com/office/drawing/2014/main" id="{CB1ABE21-6859-427C-ADEA-38ECAE6506E3}"/>
               </a:ext>
             </a:extLst>
           </p:cNvPr>
@@ -10499,7 +10499,7 @@
           <p:cNvPr id="2" name="">
             <a:extLst xmlns:a="http://schemas.openxmlformats.org/drawingml/2006/main">
               <a:ext uri="{FF2B5EF4-FFF2-40B4-BE49-F238E27FC236}">
-                <a16:creationId xmlns:a16="http://schemas.microsoft.com/office/drawing/2014/main" id="{CDBBD5EF-C747-45E2-A974-A618B8003A20}"/>
+                <a16:creationId xmlns:a16="http://schemas.microsoft.com/office/drawing/2014/main" id="{050736A2-A4AE-4C9A-B224-35778099DDCE}"/>
               </a:ext>
             </a:extLst>
           </p:cNvPr>
@@ -10560,7 +10560,7 @@
           <p:cNvPr id="3" name="">
             <a:extLst xmlns:a="http://schemas.openxmlformats.org/drawingml/2006/main">
               <a:ext uri="{FF2B5EF4-FFF2-40B4-BE49-F238E27FC236}">
-                <a16:creationId xmlns:a16="http://schemas.microsoft.com/office/drawing/2014/main" id="{E15B49A3-F91B-433D-99A3-B055EA6206F1}"/>
+                <a16:creationId xmlns:a16="http://schemas.microsoft.com/office/drawing/2014/main" id="{72F13C5A-58F7-4A3D-8B2B-23F2F91E6FCB}"/>
               </a:ext>
             </a:extLst>
           </p:cNvPr>
@@ -10611,7 +10611,7 @@
                 <a:ea typeface="Arial"/>
                 <a:cs typeface="Arial"/>
               </a:rPr>
-              <a:t>Nguồn: assets/diagrams/fd001-pipeline.png; outputs/modeling/tables/evaluation_protocol.csv</a:t>
+              <a:t>Nguồn: assets/diagrams/fd001-pipeline.png; handoff/DATA_WALKTHROUGH.md</a:t>
             </a:r>
           </a:p>
         </p:txBody>
@@ -10621,7 +10621,7 @@
           <p:cNvPr id="4" name="">
             <a:extLst xmlns:a="http://schemas.openxmlformats.org/drawingml/2006/main">
               <a:ext uri="{FF2B5EF4-FFF2-40B4-BE49-F238E27FC236}">
-                <a16:creationId xmlns:a16="http://schemas.microsoft.com/office/drawing/2014/main" id="{47282B42-D659-4ABD-8A55-E57845B6EBBE}"/>
+                <a16:creationId xmlns:a16="http://schemas.microsoft.com/office/drawing/2014/main" id="{1EEB21CF-3FDC-4FE6-8866-9E64E1A2EB55}"/>
               </a:ext>
             </a:extLst>
           </p:cNvPr>
@@ -10686,7 +10686,7 @@
           <p:nvPr/>
         </p:nvPicPr>
         <p:blipFill>
-          <a:blip xmlns:r="http://schemas.openxmlformats.org/officeDocument/2006/relationships" xmlns:a="http://schemas.openxmlformats.org/drawingml/2006/main" r:embed="R53fac2c85f5c461d"/>
+          <a:blip xmlns:r="http://schemas.openxmlformats.org/officeDocument/2006/relationships" xmlns:a="http://schemas.openxmlformats.org/drawingml/2006/main" r:embed="R011955c33caa41c7"/>
           <a:stretch xmlns:a="http://schemas.openxmlformats.org/drawingml/2006/main"/>
         </p:blipFill>
         <p:spPr>
@@ -10704,7 +10704,7 @@
           <p:cNvPr id="6" name="">
             <a:extLst xmlns:a="http://schemas.openxmlformats.org/drawingml/2006/main">
               <a:ext uri="{FF2B5EF4-FFF2-40B4-BE49-F238E27FC236}">
-                <a16:creationId xmlns:a16="http://schemas.microsoft.com/office/drawing/2014/main" id="{3970CAE4-C079-4871-BAF4-04985044C3D8}"/>
+                <a16:creationId xmlns:a16="http://schemas.microsoft.com/office/drawing/2014/main" id="{683BE203-FFD9-4930-86B6-0749FAC3F3B0}"/>
               </a:ext>
             </a:extLst>
           </p:cNvPr>
@@ -10755,7 +10755,7 @@
                 <a:ea typeface="Arial"/>
                 <a:cs typeface="Arial"/>
               </a:rPr>
-              <a:t>Điểm kiểm soát quan trọng: nhãn test chỉ xuất hiện sau khi model đã tạo dự đoán cuối.</a:t>
+              <a:t>FD001: 33.727 observations → Silver Parquet → Gold summary/features. Nhãn test chỉ xuất hiện sau khi model đã tạo dự đoán cuối.</a:t>
             </a:r>
           </a:p>
         </p:txBody>
@@ -10763,7 +10763,7 @@
     </p:spTree>
     <p:extLst>
       <p:ext uri="{BB962C8B-B14F-4D97-AF65-F5344CB8AC3E}">
-        <p14:creationId xmlns:p14="http://schemas.microsoft.com/office/powerpoint/2010/main" val="1254508175"/>
+        <p14:creationId xmlns:p14="http://schemas.microsoft.com/office/powerpoint/2010/main" val="1843444779"/>
       </p:ext>
     </p:extLst>
   </p:cSld>
@@ -10794,7 +10794,7 @@
           <p:cNvPr id="11" name="">
             <a:extLst xmlns:a="http://schemas.openxmlformats.org/drawingml/2006/main">
               <a:ext uri="{FF2B5EF4-FFF2-40B4-BE49-F238E27FC236}">
-                <a16:creationId xmlns:a16="http://schemas.microsoft.com/office/drawing/2014/main" id="{A3028D6A-D079-4346-BF37-2546CA652E2E}"/>
+                <a16:creationId xmlns:a16="http://schemas.microsoft.com/office/drawing/2014/main" id="{F2D82B0C-E8EA-4B64-B130-1A7A134BF1A8}"/>
               </a:ext>
             </a:extLst>
           </p:cNvPr>
@@ -10855,7 +10855,7 @@
           <p:cNvPr id="2" name="">
             <a:extLst xmlns:a="http://schemas.openxmlformats.org/drawingml/2006/main">
               <a:ext uri="{FF2B5EF4-FFF2-40B4-BE49-F238E27FC236}">
-                <a16:creationId xmlns:a16="http://schemas.microsoft.com/office/drawing/2014/main" id="{5860E559-E756-4BA9-AEA0-A16D2A1DC321}"/>
+                <a16:creationId xmlns:a16="http://schemas.microsoft.com/office/drawing/2014/main" id="{9E44BFAC-1379-447B-A460-B31F8F4F1C65}"/>
               </a:ext>
             </a:extLst>
           </p:cNvPr>
@@ -10916,7 +10916,7 @@
           <p:cNvPr id="3" name="">
             <a:extLst xmlns:a="http://schemas.openxmlformats.org/drawingml/2006/main">
               <a:ext uri="{FF2B5EF4-FFF2-40B4-BE49-F238E27FC236}">
-                <a16:creationId xmlns:a16="http://schemas.microsoft.com/office/drawing/2014/main" id="{9724B6FE-551E-4F5A-903E-C2A81145C152}"/>
+                <a16:creationId xmlns:a16="http://schemas.microsoft.com/office/drawing/2014/main" id="{B2C1A42E-7D4B-4B26-833C-7F66EAF892DA}"/>
               </a:ext>
             </a:extLst>
           </p:cNvPr>
@@ -10977,7 +10977,7 @@
           <p:cNvPr id="4" name="">
             <a:extLst xmlns:a="http://schemas.openxmlformats.org/drawingml/2006/main">
               <a:ext uri="{FF2B5EF4-FFF2-40B4-BE49-F238E27FC236}">
-                <a16:creationId xmlns:a16="http://schemas.microsoft.com/office/drawing/2014/main" id="{9D9A1C4D-9B04-4180-8AFB-95D31B6C20F4}"/>
+                <a16:creationId xmlns:a16="http://schemas.microsoft.com/office/drawing/2014/main" id="{05992EC9-D0FE-4DBE-A3B9-E3BB00FBB4DB}"/>
               </a:ext>
             </a:extLst>
           </p:cNvPr>
@@ -11038,7 +11038,7 @@
           <p:cNvPr id="5" name="">
             <a:extLst xmlns:a="http://schemas.openxmlformats.org/drawingml/2006/main">
               <a:ext uri="{FF2B5EF4-FFF2-40B4-BE49-F238E27FC236}">
-                <a16:creationId xmlns:a16="http://schemas.microsoft.com/office/drawing/2014/main" id="{5F1A93D1-EF27-47CC-B089-3CB2251F507A}"/>
+                <a16:creationId xmlns:a16="http://schemas.microsoft.com/office/drawing/2014/main" id="{92B67511-7173-49C4-9C90-D86356526A71}"/>
               </a:ext>
             </a:extLst>
           </p:cNvPr>
@@ -11099,7 +11099,7 @@
           <p:cNvPr id="6" name="">
             <a:extLst xmlns:a="http://schemas.openxmlformats.org/drawingml/2006/main">
               <a:ext uri="{FF2B5EF4-FFF2-40B4-BE49-F238E27FC236}">
-                <a16:creationId xmlns:a16="http://schemas.microsoft.com/office/drawing/2014/main" id="{AD834AEA-86FA-4A5B-96F6-CFB08E963E69}"/>
+                <a16:creationId xmlns:a16="http://schemas.microsoft.com/office/drawing/2014/main" id="{211BB11C-627A-4AE7-939E-783210CB05A4}"/>
               </a:ext>
             </a:extLst>
           </p:cNvPr>
@@ -11160,7 +11160,7 @@
           <p:cNvPr id="7" name="">
             <a:extLst xmlns:a="http://schemas.openxmlformats.org/drawingml/2006/main">
               <a:ext uri="{FF2B5EF4-FFF2-40B4-BE49-F238E27FC236}">
-                <a16:creationId xmlns:a16="http://schemas.microsoft.com/office/drawing/2014/main" id="{EC9D7850-6F8E-4A41-B776-F69C2969E9C4}"/>
+                <a16:creationId xmlns:a16="http://schemas.microsoft.com/office/drawing/2014/main" id="{EA74BE10-3523-4AB8-821C-9A4546432877}"/>
               </a:ext>
             </a:extLst>
           </p:cNvPr>
@@ -11221,7 +11221,7 @@
           <p:cNvPr id="8" name="">
             <a:extLst xmlns:a="http://schemas.openxmlformats.org/drawingml/2006/main">
               <a:ext uri="{FF2B5EF4-FFF2-40B4-BE49-F238E27FC236}">
-                <a16:creationId xmlns:a16="http://schemas.microsoft.com/office/drawing/2014/main" id="{0A4C1958-4471-4756-BDA1-0E7010FC8523}"/>
+                <a16:creationId xmlns:a16="http://schemas.microsoft.com/office/drawing/2014/main" id="{AFC4258D-0877-4CC8-8F36-1443DC12B2EF}"/>
               </a:ext>
             </a:extLst>
           </p:cNvPr>
@@ -11282,7 +11282,7 @@
           <p:cNvPr id="9" name="">
             <a:extLst xmlns:a="http://schemas.openxmlformats.org/drawingml/2006/main">
               <a:ext uri="{FF2B5EF4-FFF2-40B4-BE49-F238E27FC236}">
-                <a16:creationId xmlns:a16="http://schemas.microsoft.com/office/drawing/2014/main" id="{3DD107CC-37C6-4E52-BC3D-31D5DE8E4604}"/>
+                <a16:creationId xmlns:a16="http://schemas.microsoft.com/office/drawing/2014/main" id="{B3ABB80F-878D-465E-B43F-4BEFFA5153E5}"/>
               </a:ext>
             </a:extLst>
           </p:cNvPr>
@@ -11343,7 +11343,7 @@
           <p:cNvPr id="10" name="">
             <a:extLst xmlns:a="http://schemas.openxmlformats.org/drawingml/2006/main">
               <a:ext uri="{FF2B5EF4-FFF2-40B4-BE49-F238E27FC236}">
-                <a16:creationId xmlns:a16="http://schemas.microsoft.com/office/drawing/2014/main" id="{9481FA4F-2ECA-45EF-9D21-C249A6641605}"/>
+                <a16:creationId xmlns:a16="http://schemas.microsoft.com/office/drawing/2014/main" id="{C2646AE1-68A7-4785-B5B2-57616C89B083}"/>
               </a:ext>
             </a:extLst>
           </p:cNvPr>
@@ -11402,7 +11402,7 @@
     </p:spTree>
     <p:extLst>
       <p:ext uri="{BB962C8B-B14F-4D97-AF65-F5344CB8AC3E}">
-        <p14:creationId xmlns:p14="http://schemas.microsoft.com/office/powerpoint/2010/main" val="2124503018"/>
+        <p14:creationId xmlns:p14="http://schemas.microsoft.com/office/powerpoint/2010/main" val="231407694"/>
       </p:ext>
     </p:extLst>
   </p:cSld>
@@ -11433,7 +11433,7 @@
           <p:cNvPr id="8" name="">
             <a:extLst xmlns:a="http://schemas.openxmlformats.org/drawingml/2006/main">
               <a:ext uri="{FF2B5EF4-FFF2-40B4-BE49-F238E27FC236}">
-                <a16:creationId xmlns:a16="http://schemas.microsoft.com/office/drawing/2014/main" id="{21241308-23AD-44D5-BCC5-D8C6AD6F16DC}"/>
+                <a16:creationId xmlns:a16="http://schemas.microsoft.com/office/drawing/2014/main" id="{67FA51C5-6CD9-4E90-9B7A-1CCA697D2140}"/>
               </a:ext>
             </a:extLst>
           </p:cNvPr>
@@ -11494,7 +11494,7 @@
           <p:cNvPr id="2" name="">
             <a:extLst xmlns:a="http://schemas.openxmlformats.org/drawingml/2006/main">
               <a:ext uri="{FF2B5EF4-FFF2-40B4-BE49-F238E27FC236}">
-                <a16:creationId xmlns:a16="http://schemas.microsoft.com/office/drawing/2014/main" id="{0D69001E-8C4B-4830-B934-AF2EA3A77EB3}"/>
+                <a16:creationId xmlns:a16="http://schemas.microsoft.com/office/drawing/2014/main" id="{A24A4766-58F2-453A-A001-4210C0C72444}"/>
               </a:ext>
             </a:extLst>
           </p:cNvPr>
@@ -11555,7 +11555,7 @@
           <p:cNvPr id="3" name="">
             <a:extLst xmlns:a="http://schemas.openxmlformats.org/drawingml/2006/main">
               <a:ext uri="{FF2B5EF4-FFF2-40B4-BE49-F238E27FC236}">
-                <a16:creationId xmlns:a16="http://schemas.microsoft.com/office/drawing/2014/main" id="{87F1760F-8791-49D6-B548-EEB43EF93D88}"/>
+                <a16:creationId xmlns:a16="http://schemas.microsoft.com/office/drawing/2014/main" id="{F7547564-3DEA-439F-B4F6-2F8E65DF8424}"/>
               </a:ext>
             </a:extLst>
           </p:cNvPr>
@@ -11606,7 +11606,7 @@
                 <a:ea typeface="Arial"/>
                 <a:cs typeface="Arial"/>
               </a:rPr>
-              <a:t>Nguồn: outputs/features/run_info.json; report/sections/theory.tex</a:t>
+              <a:t>Nguồn: outputs/features/run_info.json; handoff/DATA_WALKTHROUGH.md</a:t>
             </a:r>
           </a:p>
         </p:txBody>
@@ -11616,7 +11616,7 @@
           <p:cNvPr id="4" name="">
             <a:extLst xmlns:a="http://schemas.openxmlformats.org/drawingml/2006/main">
               <a:ext uri="{FF2B5EF4-FFF2-40B4-BE49-F238E27FC236}">
-                <a16:creationId xmlns:a16="http://schemas.microsoft.com/office/drawing/2014/main" id="{62C3F336-0F35-4947-BFBF-B6BDACBEBD23}"/>
+                <a16:creationId xmlns:a16="http://schemas.microsoft.com/office/drawing/2014/main" id="{1DF4A9AF-DB0B-48B8-BFAF-3C29C6C1EFC5}"/>
               </a:ext>
             </a:extLst>
           </p:cNvPr>
@@ -11677,7 +11677,7 @@
           <p:cNvPr id="5" name="">
             <a:extLst xmlns:a="http://schemas.openxmlformats.org/drawingml/2006/main">
               <a:ext uri="{FF2B5EF4-FFF2-40B4-BE49-F238E27FC236}">
-                <a16:creationId xmlns:a16="http://schemas.microsoft.com/office/drawing/2014/main" id="{F2A1008A-DEE9-41E2-8D47-1D8DD283ECC6}"/>
+                <a16:creationId xmlns:a16="http://schemas.microsoft.com/office/drawing/2014/main" id="{E367C320-1557-4A80-A1D1-F6ADD34B0377}"/>
               </a:ext>
             </a:extLst>
           </p:cNvPr>
@@ -11936,7 +11936,7 @@
           <p:cNvPr id="7" name="">
             <a:extLst xmlns:a="http://schemas.openxmlformats.org/drawingml/2006/main">
               <a:ext uri="{FF2B5EF4-FFF2-40B4-BE49-F238E27FC236}">
-                <a16:creationId xmlns:a16="http://schemas.microsoft.com/office/drawing/2014/main" id="{E951A141-F664-41A4-B0DA-9F9E35DF4A20}"/>
+                <a16:creationId xmlns:a16="http://schemas.microsoft.com/office/drawing/2014/main" id="{4B80E6CD-65B8-429C-B49A-35A5F44E5597}"/>
               </a:ext>
             </a:extLst>
           </p:cNvPr>
@@ -11995,7 +11995,7 @@
     </p:spTree>
     <p:extLst>
       <p:ext uri="{BB962C8B-B14F-4D97-AF65-F5344CB8AC3E}">
-        <p14:creationId xmlns:p14="http://schemas.microsoft.com/office/powerpoint/2010/main" val="586915372"/>
+        <p14:creationId xmlns:p14="http://schemas.microsoft.com/office/powerpoint/2010/main" val="525123326"/>
       </p:ext>
     </p:extLst>
   </p:cSld>
@@ -12026,7 +12026,7 @@
           <p:cNvPr id="7" name="">
             <a:extLst xmlns:a="http://schemas.openxmlformats.org/drawingml/2006/main">
               <a:ext uri="{FF2B5EF4-FFF2-40B4-BE49-F238E27FC236}">
-                <a16:creationId xmlns:a16="http://schemas.microsoft.com/office/drawing/2014/main" id="{C4961E67-C7DB-40C6-8D17-AAA2A7648579}"/>
+                <a16:creationId xmlns:a16="http://schemas.microsoft.com/office/drawing/2014/main" id="{85D59879-B636-440C-AE71-9A5B17B7C75A}"/>
               </a:ext>
             </a:extLst>
           </p:cNvPr>
@@ -12087,7 +12087,7 @@
           <p:cNvPr id="2" name="">
             <a:extLst xmlns:a="http://schemas.openxmlformats.org/drawingml/2006/main">
               <a:ext uri="{FF2B5EF4-FFF2-40B4-BE49-F238E27FC236}">
-                <a16:creationId xmlns:a16="http://schemas.microsoft.com/office/drawing/2014/main" id="{E228F13A-AE52-4C02-8823-6196DF40CDE1}"/>
+                <a16:creationId xmlns:a16="http://schemas.microsoft.com/office/drawing/2014/main" id="{131E20A8-1F19-4C39-81F6-B903A7B6B237}"/>
               </a:ext>
             </a:extLst>
           </p:cNvPr>
@@ -12148,7 +12148,7 @@
           <p:cNvPr id="3" name="">
             <a:extLst xmlns:a="http://schemas.openxmlformats.org/drawingml/2006/main">
               <a:ext uri="{FF2B5EF4-FFF2-40B4-BE49-F238E27FC236}">
-                <a16:creationId xmlns:a16="http://schemas.microsoft.com/office/drawing/2014/main" id="{24EB219C-33F5-40DC-A874-65DEF8C3CC9D}"/>
+                <a16:creationId xmlns:a16="http://schemas.microsoft.com/office/drawing/2014/main" id="{523E121A-1106-4337-BAC7-A32E27C93049}"/>
               </a:ext>
             </a:extLst>
           </p:cNvPr>
@@ -12209,7 +12209,7 @@
           <p:cNvPr id="4" name="">
             <a:extLst xmlns:a="http://schemas.openxmlformats.org/drawingml/2006/main">
               <a:ext uri="{FF2B5EF4-FFF2-40B4-BE49-F238E27FC236}">
-                <a16:creationId xmlns:a16="http://schemas.microsoft.com/office/drawing/2014/main" id="{971212AE-D60F-4F2A-B8D2-91AA24E7911F}"/>
+                <a16:creationId xmlns:a16="http://schemas.microsoft.com/office/drawing/2014/main" id="{C07A5168-0611-4F5C-B341-D1AA4BE83874}"/>
               </a:ext>
             </a:extLst>
           </p:cNvPr>
@@ -12553,7 +12553,7 @@
           <p:cNvPr id="6" name="">
             <a:extLst xmlns:a="http://schemas.openxmlformats.org/drawingml/2006/main">
               <a:ext uri="{FF2B5EF4-FFF2-40B4-BE49-F238E27FC236}">
-                <a16:creationId xmlns:a16="http://schemas.microsoft.com/office/drawing/2014/main" id="{1EBA7936-CAA8-42EC-808C-1AC9CB46D25A}"/>
+                <a16:creationId xmlns:a16="http://schemas.microsoft.com/office/drawing/2014/main" id="{C140AFB3-03CA-496C-8B1B-37BD1A49566B}"/>
               </a:ext>
             </a:extLst>
           </p:cNvPr>
@@ -12612,7 +12612,7 @@
     </p:spTree>
     <p:extLst>
       <p:ext uri="{BB962C8B-B14F-4D97-AF65-F5344CB8AC3E}">
-        <p14:creationId xmlns:p14="http://schemas.microsoft.com/office/powerpoint/2010/main" val="49524413"/>
+        <p14:creationId xmlns:p14="http://schemas.microsoft.com/office/powerpoint/2010/main" val="1973142221"/>
       </p:ext>
     </p:extLst>
   </p:cSld>
@@ -12643,7 +12643,7 @@
           <p:cNvPr id="7" name="">
             <a:extLst xmlns:a="http://schemas.openxmlformats.org/drawingml/2006/main">
               <a:ext uri="{FF2B5EF4-FFF2-40B4-BE49-F238E27FC236}">
-                <a16:creationId xmlns:a16="http://schemas.microsoft.com/office/drawing/2014/main" id="{E9FCE2D7-29A4-4DF5-A53F-13479D1FCE1C}"/>
+                <a16:creationId xmlns:a16="http://schemas.microsoft.com/office/drawing/2014/main" id="{5DA00B46-6D4C-4E1D-8115-E91E27FCD183}"/>
               </a:ext>
             </a:extLst>
           </p:cNvPr>
@@ -12704,7 +12704,7 @@
           <p:cNvPr id="2" name="">
             <a:extLst xmlns:a="http://schemas.openxmlformats.org/drawingml/2006/main">
               <a:ext uri="{FF2B5EF4-FFF2-40B4-BE49-F238E27FC236}">
-                <a16:creationId xmlns:a16="http://schemas.microsoft.com/office/drawing/2014/main" id="{2921E09C-BD91-4878-B4BD-A3A4B2137691}"/>
+                <a16:creationId xmlns:a16="http://schemas.microsoft.com/office/drawing/2014/main" id="{6EF8CB0C-7E3A-4A61-B62D-A12C1199D0C6}"/>
               </a:ext>
             </a:extLst>
           </p:cNvPr>
@@ -12765,7 +12765,7 @@
           <p:cNvPr id="3" name="">
             <a:extLst xmlns:a="http://schemas.openxmlformats.org/drawingml/2006/main">
               <a:ext uri="{FF2B5EF4-FFF2-40B4-BE49-F238E27FC236}">
-                <a16:creationId xmlns:a16="http://schemas.microsoft.com/office/drawing/2014/main" id="{7C6DAD0E-62F1-41D1-96D5-7848A91A3B21}"/>
+                <a16:creationId xmlns:a16="http://schemas.microsoft.com/office/drawing/2014/main" id="{63D2C525-2F91-4A4F-97E3-08E3585562BB}"/>
               </a:ext>
             </a:extLst>
           </p:cNvPr>
@@ -12826,7 +12826,7 @@
           <p:cNvPr id="4" name="">
             <a:extLst xmlns:a="http://schemas.openxmlformats.org/drawingml/2006/main">
               <a:ext uri="{FF2B5EF4-FFF2-40B4-BE49-F238E27FC236}">
-                <a16:creationId xmlns:a16="http://schemas.microsoft.com/office/drawing/2014/main" id="{D9019912-2753-4173-9CD9-5DCF60E62D2B}"/>
+                <a16:creationId xmlns:a16="http://schemas.microsoft.com/office/drawing/2014/main" id="{BF785D1A-3134-4167-82BE-4DDE902AF584}"/>
               </a:ext>
             </a:extLst>
           </p:cNvPr>
@@ -13170,7 +13170,7 @@
           <p:cNvPr id="6" name="">
             <a:extLst xmlns:a="http://schemas.openxmlformats.org/drawingml/2006/main">
               <a:ext uri="{FF2B5EF4-FFF2-40B4-BE49-F238E27FC236}">
-                <a16:creationId xmlns:a16="http://schemas.microsoft.com/office/drawing/2014/main" id="{BE9C087C-45DB-495F-9A2D-CA0C3ECE1E67}"/>
+                <a16:creationId xmlns:a16="http://schemas.microsoft.com/office/drawing/2014/main" id="{94EB1A8F-E9D9-41A6-955D-DC917D63BE48}"/>
               </a:ext>
             </a:extLst>
           </p:cNvPr>
@@ -13229,7 +13229,7 @@
     </p:spTree>
     <p:extLst>
       <p:ext uri="{BB962C8B-B14F-4D97-AF65-F5344CB8AC3E}">
-        <p14:creationId xmlns:p14="http://schemas.microsoft.com/office/powerpoint/2010/main" val="82840649"/>
+        <p14:creationId xmlns:p14="http://schemas.microsoft.com/office/powerpoint/2010/main" val="2075600673"/>
       </p:ext>
     </p:extLst>
   </p:cSld>
@@ -13260,7 +13260,7 @@
           <p:cNvPr id="13" name="">
             <a:extLst xmlns:a="http://schemas.openxmlformats.org/drawingml/2006/main">
               <a:ext uri="{FF2B5EF4-FFF2-40B4-BE49-F238E27FC236}">
-                <a16:creationId xmlns:a16="http://schemas.microsoft.com/office/drawing/2014/main" id="{6B963BBE-2042-4EE3-85E2-909941347AD4}"/>
+                <a16:creationId xmlns:a16="http://schemas.microsoft.com/office/drawing/2014/main" id="{85A0731B-45C0-438A-8E4C-5C4F6CC17BAE}"/>
               </a:ext>
             </a:extLst>
           </p:cNvPr>
@@ -13321,7 +13321,7 @@
           <p:cNvPr id="2" name="">
             <a:extLst xmlns:a="http://schemas.openxmlformats.org/drawingml/2006/main">
               <a:ext uri="{FF2B5EF4-FFF2-40B4-BE49-F238E27FC236}">
-                <a16:creationId xmlns:a16="http://schemas.microsoft.com/office/drawing/2014/main" id="{6F13F3B1-A368-441E-8058-8080A57EC7C7}"/>
+                <a16:creationId xmlns:a16="http://schemas.microsoft.com/office/drawing/2014/main" id="{754159DF-AE79-4E73-ADA8-432BF6013E8E}"/>
               </a:ext>
             </a:extLst>
           </p:cNvPr>
@@ -13382,7 +13382,7 @@
           <p:cNvPr id="3" name="">
             <a:extLst xmlns:a="http://schemas.openxmlformats.org/drawingml/2006/main">
               <a:ext uri="{FF2B5EF4-FFF2-40B4-BE49-F238E27FC236}">
-                <a16:creationId xmlns:a16="http://schemas.microsoft.com/office/drawing/2014/main" id="{AAC3A780-70DC-4CE0-B534-3C9E362CF711}"/>
+                <a16:creationId xmlns:a16="http://schemas.microsoft.com/office/drawing/2014/main" id="{38B8C5BE-37E2-449B-B7FF-2540295CE90F}"/>
               </a:ext>
             </a:extLst>
           </p:cNvPr>
@@ -13443,7 +13443,7 @@
           <p:cNvPr id="4" name="">
             <a:extLst xmlns:a="http://schemas.openxmlformats.org/drawingml/2006/main">
               <a:ext uri="{FF2B5EF4-FFF2-40B4-BE49-F238E27FC236}">
-                <a16:creationId xmlns:a16="http://schemas.microsoft.com/office/drawing/2014/main" id="{729988E6-402D-4051-8D9A-BBEC26D11169}"/>
+                <a16:creationId xmlns:a16="http://schemas.microsoft.com/office/drawing/2014/main" id="{FB42F24A-8363-4AD5-B0AD-A41A8CFE2510}"/>
               </a:ext>
             </a:extLst>
           </p:cNvPr>
@@ -13508,7 +13508,7 @@
           <p:nvPr/>
         </p:nvPicPr>
         <p:blipFill>
-          <a:blip xmlns:r="http://schemas.openxmlformats.org/officeDocument/2006/relationships" xmlns:a="http://schemas.openxmlformats.org/drawingml/2006/main" r:embed="Rad5e71cdda8e4e59"/>
+          <a:blip xmlns:r="http://schemas.openxmlformats.org/officeDocument/2006/relationships" xmlns:a="http://schemas.openxmlformats.org/drawingml/2006/main" r:embed="Rf7a00583c3894074"/>
           <a:stretch xmlns:a="http://schemas.openxmlformats.org/drawingml/2006/main"/>
         </p:blipFill>
         <p:spPr>
@@ -13526,7 +13526,7 @@
           <p:cNvPr id="6" name="">
             <a:extLst xmlns:a="http://schemas.openxmlformats.org/drawingml/2006/main">
               <a:ext uri="{FF2B5EF4-FFF2-40B4-BE49-F238E27FC236}">
-                <a16:creationId xmlns:a16="http://schemas.microsoft.com/office/drawing/2014/main" id="{0FAE0A82-A779-41A6-8FF0-9BA00CC86B1B}"/>
+                <a16:creationId xmlns:a16="http://schemas.microsoft.com/office/drawing/2014/main" id="{4C104729-EA1C-40DE-B5D3-2CE5AAEAFC8D}"/>
               </a:ext>
             </a:extLst>
           </p:cNvPr>
@@ -13587,7 +13587,7 @@
           <p:cNvPr id="7" name="">
             <a:extLst xmlns:a="http://schemas.openxmlformats.org/drawingml/2006/main">
               <a:ext uri="{FF2B5EF4-FFF2-40B4-BE49-F238E27FC236}">
-                <a16:creationId xmlns:a16="http://schemas.microsoft.com/office/drawing/2014/main" id="{2A2D7CB0-F39C-459F-B037-BF77E9A5CDBE}"/>
+                <a16:creationId xmlns:a16="http://schemas.microsoft.com/office/drawing/2014/main" id="{6C7FAE2C-C784-4A31-90CC-2C9EF85EE2F4}"/>
               </a:ext>
             </a:extLst>
           </p:cNvPr>
@@ -13648,7 +13648,7 @@
           <p:cNvPr id="8" name="">
             <a:extLst xmlns:a="http://schemas.openxmlformats.org/drawingml/2006/main">
               <a:ext uri="{FF2B5EF4-FFF2-40B4-BE49-F238E27FC236}">
-                <a16:creationId xmlns:a16="http://schemas.microsoft.com/office/drawing/2014/main" id="{67832740-CE4C-430F-A071-2C58795DF31F}"/>
+                <a16:creationId xmlns:a16="http://schemas.microsoft.com/office/drawing/2014/main" id="{572398FE-D92C-4D72-A9D7-88C5C7E254D1}"/>
               </a:ext>
             </a:extLst>
           </p:cNvPr>
@@ -13709,7 +13709,7 @@
           <p:cNvPr id="9" name="">
             <a:extLst xmlns:a="http://schemas.openxmlformats.org/drawingml/2006/main">
               <a:ext uri="{FF2B5EF4-FFF2-40B4-BE49-F238E27FC236}">
-                <a16:creationId xmlns:a16="http://schemas.microsoft.com/office/drawing/2014/main" id="{FA8E304F-7452-4D35-9AE2-68809C0E2EA8}"/>
+                <a16:creationId xmlns:a16="http://schemas.microsoft.com/office/drawing/2014/main" id="{D34FE478-7926-4EA2-9028-083D9ACEA942}"/>
               </a:ext>
             </a:extLst>
           </p:cNvPr>
@@ -13770,7 +13770,7 @@
           <p:cNvPr id="10" name="">
             <a:extLst xmlns:a="http://schemas.openxmlformats.org/drawingml/2006/main">
               <a:ext uri="{FF2B5EF4-FFF2-40B4-BE49-F238E27FC236}">
-                <a16:creationId xmlns:a16="http://schemas.microsoft.com/office/drawing/2014/main" id="{8B98C818-703F-423A-9707-F5C70E2D844B}"/>
+                <a16:creationId xmlns:a16="http://schemas.microsoft.com/office/drawing/2014/main" id="{AD4E8B03-1423-4454-9FAD-AAEDCFB5974D}"/>
               </a:ext>
             </a:extLst>
           </p:cNvPr>
@@ -13831,7 +13831,7 @@
           <p:cNvPr id="11" name="">
             <a:extLst xmlns:a="http://schemas.openxmlformats.org/drawingml/2006/main">
               <a:ext uri="{FF2B5EF4-FFF2-40B4-BE49-F238E27FC236}">
-                <a16:creationId xmlns:a16="http://schemas.microsoft.com/office/drawing/2014/main" id="{87191DBA-5968-4E28-AEB1-174F5B135096}"/>
+                <a16:creationId xmlns:a16="http://schemas.microsoft.com/office/drawing/2014/main" id="{782246BB-711D-46B4-8C2B-59E0B1FAC925}"/>
               </a:ext>
             </a:extLst>
           </p:cNvPr>
@@ -13892,7 +13892,7 @@
           <p:cNvPr id="12" name="">
             <a:extLst xmlns:a="http://schemas.openxmlformats.org/drawingml/2006/main">
               <a:ext uri="{FF2B5EF4-FFF2-40B4-BE49-F238E27FC236}">
-                <a16:creationId xmlns:a16="http://schemas.microsoft.com/office/drawing/2014/main" id="{E49C109F-2709-468D-BE62-5AD8CBAE84E3}"/>
+                <a16:creationId xmlns:a16="http://schemas.microsoft.com/office/drawing/2014/main" id="{86AFF3E3-A1EF-4AB5-A39E-2A8CAD5568EC}"/>
               </a:ext>
             </a:extLst>
           </p:cNvPr>
@@ -13951,7 +13951,7 @@
     </p:spTree>
     <p:extLst>
       <p:ext uri="{BB962C8B-B14F-4D97-AF65-F5344CB8AC3E}">
-        <p14:creationId xmlns:p14="http://schemas.microsoft.com/office/powerpoint/2010/main" val="1895487725"/>
+        <p14:creationId xmlns:p14="http://schemas.microsoft.com/office/powerpoint/2010/main" val="771515463"/>
       </p:ext>
     </p:extLst>
   </p:cSld>
@@ -13999,16 +13999,16 @@
         <a:srgbClr val="96607D"/>
       </a:folHlink>
     </a:clrScheme>
-    <a:fontScheme name="Office">
+    <a:fontScheme name="">
       <a:majorFont>
-        <a:latin typeface="Calibri Light"/>
-        <a:ea typeface="Calibri Light"/>
-        <a:cs typeface="Calibri Light"/>
+        <a:latin typeface="Aptos"/>
+        <a:ea typeface=""/>
+        <a:cs typeface=""/>
       </a:majorFont>
       <a:minorFont>
-        <a:latin typeface="Calibri"/>
-        <a:ea typeface="Calibri"/>
-        <a:cs typeface="Calibri"/>
+        <a:latin typeface="Aptos"/>
+        <a:ea typeface=""/>
+        <a:cs typeface=""/>
       </a:minorFont>
     </a:fontScheme>
     <a:fmtScheme name="ChatGPT">

</xml_diff>